<commit_message>
Add surgical code-slide updater; deck is now hand-editable
Switch the deck to a "pptx-is-master" workflow so it can be polished by hand
without losing code edits, and code can be re-synced without losing hand edits.

- Tagged each code box as a named shape "code:<tag>" (one final full regen of
  the deck from the frozen assets/make_deck.py).
- scripts/code_snippets.py: the canonical code fragments shown on slides.
- scripts/update_code_slides.py: opens the deck and rewrites ONLY the tagged
  code boxes (same pygments highlighting), preserving each box's position and
  font size; everything else in the hand-edited deck is untouched. Supports
  --check and -o.
- slides/SLIDES.md: documents the workflow (edit snippet -> run updater ->
  re-export PDF) and how the code<->box link works.

Verified: a hand-edited title survives an update run while a clobbered code box
is restored from its snippet.

Co-Authored-By: Claude Opus 4.8 (1M context) <noreply@anthropic.com>
</commit_message>
<xml_diff>
--- a/slides/ACCU-Separation-of-Concerns-at-Zero-Cost.pptx
+++ b/slides/ACCU-Separation-of-Concerns-at-Zero-Cost.pptx
@@ -10562,7 +10562,7 @@
       </p:sp>
       <p:sp>
         <p:nvSpPr>
-          <p:cNvPr id="5" name="TextBox 4"/>
+          <p:cNvPr id="5" name="code:tags"/>
           <p:cNvSpPr txBox="1"/>
           <p:nvPr/>
         </p:nvSpPr>
@@ -11681,7 +11681,7 @@
       </p:sp>
       <p:sp>
         <p:nvSpPr>
-          <p:cNvPr id="5" name="TextBox 4"/>
+          <p:cNvPr id="5" name="code:pointmass"/>
           <p:cNvSpPr txBox="1"/>
           <p:nvPr/>
         </p:nvSpPr>
@@ -14580,7 +14580,7 @@
       </p:sp>
       <p:sp>
         <p:nvSpPr>
-          <p:cNvPr id="5" name="TextBox 4"/>
+          <p:cNvPr id="5" name="code:spring"/>
           <p:cNvSpPr txBox="1"/>
           <p:nvPr/>
         </p:nvSpPr>
@@ -17308,7 +17308,7 @@
       </p:sp>
       <p:sp>
         <p:nvSpPr>
-          <p:cNvPr id="5" name="TextBox 4"/>
+          <p:cNvPr id="5" name="code:energy"/>
           <p:cNvSpPr txBox="1"/>
           <p:nvPr/>
         </p:nvSpPr>
@@ -20056,7 +20056,7 @@
       </p:sp>
       <p:sp>
         <p:nvSpPr>
-          <p:cNvPr id="5" name="TextBox 4"/>
+          <p:cNvPr id="5" name="code:wiring"/>
           <p:cNvSpPr txBox="1"/>
           <p:nvPr/>
         </p:nvSpPr>
@@ -23439,7 +23439,7 @@
       </p:sp>
       <p:sp>
         <p:nvSpPr>
-          <p:cNvPr id="5" name="TextBox 4"/>
+          <p:cNvPr id="5" name="code:registry"/>
           <p:cNvSpPr txBox="1"/>
           <p:nvPr/>
         </p:nvSpPr>
@@ -25441,7 +25441,7 @@
       </p:sp>
       <p:sp>
         <p:nvSpPr>
-          <p:cNvPr id="5" name="TextBox 4"/>
+          <p:cNvPr id="5" name="code:concepts"/>
           <p:cNvSpPr txBox="1"/>
           <p:nvPr/>
         </p:nvSpPr>
@@ -31989,7 +31989,7 @@
       </p:sp>
       <p:sp>
         <p:nvSpPr>
-          <p:cNvPr id="5" name="TextBox 4"/>
+          <p:cNvPr id="5" name="code:autodiff"/>
           <p:cNvSpPr txBox="1"/>
           <p:nvPr/>
         </p:nvSpPr>

</xml_diff>

<commit_message>
Fix inconsistent code-slide colouring (uniform type names)
pygments only colours type names it can structurally infer (after class/
typename) and leaves the rest as plain grey Name tokens — so the same type was
coloured differently in different places (e.g. Registry teal after `typename`,
grey in `const Registry&`; Component/LocalDerivative grey everywhere).

Add a small promotion in the highlighter: any multi-char PascalCase identifier
left grey is recoloured to the type colour, so Component, Registry, TagSet,
LocalDerivative, etc. are uniformly teal across every code slide. Single
capitals (T, D, J, K, Q) are left alone (often loop/temp vars). Re-ran the
updater to recolour all 8 code boxes; hand edits untouched.

Co-Authored-By: Claude Opus 4.8 (1M context) <noreply@anthropic.com>
</commit_message>
<xml_diff>
--- a/slides/ACCU-Separation-of-Concerns-at-Zero-Cost.pptx
+++ b/slides/ACCU-Separation-of-Concerns-at-Zero-Cost.pptx
@@ -10573,7 +10573,7 @@
             <a:r>
               <a:rPr sz="1250">
                 <a:solidFill>
-                  <a:srgbClr val="D4D4D4"/>
+                  <a:srgbClr val="4EC9B0"/>
                 </a:solidFill>
                 <a:latin typeface="Consolas"/>
               </a:rPr>
@@ -10742,7 +10742,7 @@
             <a:r>
               <a:rPr sz="1250">
                 <a:solidFill>
-                  <a:srgbClr val="D4D4D4"/>
+                  <a:srgbClr val="4EC9B0"/>
                 </a:solidFill>
                 <a:latin typeface="Consolas"/>
               </a:rPr>
@@ -11004,7 +11004,7 @@
             <a:r>
               <a:rPr sz="1250">
                 <a:solidFill>
-                  <a:srgbClr val="D4D4D4"/>
+                  <a:srgbClr val="4EC9B0"/>
                 </a:solidFill>
                 <a:latin typeface="Consolas"/>
               </a:rPr>
@@ -11227,7 +11227,7 @@
             <a:r>
               <a:rPr sz="1250">
                 <a:solidFill>
-                  <a:srgbClr val="D4D4D4"/>
+                  <a:srgbClr val="4EC9B0"/>
                 </a:solidFill>
                 <a:latin typeface="Consolas"/>
               </a:rPr>
@@ -12092,7 +12092,7 @@
             <a:r>
               <a:rPr sz="1250">
                 <a:solidFill>
-                  <a:srgbClr val="D4D4D4"/>
+                  <a:srgbClr val="4EC9B0"/>
                 </a:solidFill>
                 <a:latin typeface="Consolas"/>
               </a:rPr>
@@ -12261,7 +12261,7 @@
             <a:r>
               <a:rPr sz="1250">
                 <a:solidFill>
-                  <a:srgbClr val="D4D4D4"/>
+                  <a:srgbClr val="4EC9B0"/>
                 </a:solidFill>
                 <a:latin typeface="Consolas"/>
               </a:rPr>
@@ -12635,7 +12635,7 @@
             <a:r>
               <a:rPr sz="1250">
                 <a:solidFill>
-                  <a:srgbClr val="D4D4D4"/>
+                  <a:srgbClr val="4EC9B0"/>
                 </a:solidFill>
                 <a:latin typeface="Consolas"/>
               </a:rPr>
@@ -12804,7 +12804,7 @@
             <a:r>
               <a:rPr sz="1250">
                 <a:solidFill>
-                  <a:srgbClr val="D4D4D4"/>
+                  <a:srgbClr val="4EC9B0"/>
                 </a:solidFill>
                 <a:latin typeface="Consolas"/>
               </a:rPr>
@@ -13393,7 +13393,7 @@
             <a:r>
               <a:rPr sz="1250">
                 <a:solidFill>
-                  <a:srgbClr val="D4D4D4"/>
+                  <a:srgbClr val="4EC9B0"/>
                 </a:solidFill>
                 <a:latin typeface="Consolas"/>
               </a:rPr>
@@ -13562,7 +13562,7 @@
             <a:r>
               <a:rPr sz="1250">
                 <a:solidFill>
-                  <a:srgbClr val="D4D4D4"/>
+                  <a:srgbClr val="4EC9B0"/>
                 </a:solidFill>
                 <a:latin typeface="Consolas"/>
               </a:rPr>
@@ -13932,7 +13932,7 @@
             <a:r>
               <a:rPr sz="1250">
                 <a:solidFill>
-                  <a:srgbClr val="D4D4D4"/>
+                  <a:srgbClr val="4EC9B0"/>
                 </a:solidFill>
                 <a:latin typeface="Consolas"/>
               </a:rPr>
@@ -14101,7 +14101,7 @@
             <a:r>
               <a:rPr sz="1250">
                 <a:solidFill>
-                  <a:srgbClr val="D4D4D4"/>
+                  <a:srgbClr val="4EC9B0"/>
                 </a:solidFill>
                 <a:latin typeface="Consolas"/>
               </a:rPr>
@@ -15144,7 +15144,7 @@
             <a:r>
               <a:rPr sz="1250">
                 <a:solidFill>
-                  <a:srgbClr val="D4D4D4"/>
+                  <a:srgbClr val="4EC9B0"/>
                 </a:solidFill>
                 <a:latin typeface="Consolas"/>
               </a:rPr>
@@ -15313,7 +15313,7 @@
             <a:r>
               <a:rPr sz="1250">
                 <a:solidFill>
-                  <a:srgbClr val="D4D4D4"/>
+                  <a:srgbClr val="4EC9B0"/>
                 </a:solidFill>
                 <a:latin typeface="Consolas"/>
               </a:rPr>
@@ -15500,7 +15500,7 @@
             <a:r>
               <a:rPr sz="1250">
                 <a:solidFill>
-                  <a:srgbClr val="D4D4D4"/>
+                  <a:srgbClr val="4EC9B0"/>
                 </a:solidFill>
                 <a:latin typeface="Consolas"/>
               </a:rPr>
@@ -15916,7 +15916,7 @@
             <a:r>
               <a:rPr sz="1300">
                 <a:solidFill>
-                  <a:srgbClr val="D4D4D4"/>
+                  <a:srgbClr val="4EC9B0"/>
                 </a:solidFill>
                 <a:latin typeface="Consolas"/>
               </a:rPr>
@@ -16085,7 +16085,7 @@
             <a:r>
               <a:rPr sz="1300">
                 <a:solidFill>
-                  <a:srgbClr val="D4D4D4"/>
+                  <a:srgbClr val="4EC9B0"/>
                 </a:solidFill>
                 <a:latin typeface="Consolas"/>
               </a:rPr>
@@ -16340,7 +16340,7 @@
             <a:r>
               <a:rPr sz="1300">
                 <a:solidFill>
-                  <a:srgbClr val="D4D4D4"/>
+                  <a:srgbClr val="4EC9B0"/>
                 </a:solidFill>
                 <a:latin typeface="Consolas"/>
               </a:rPr>
@@ -16509,7 +16509,7 @@
             <a:r>
               <a:rPr sz="1300">
                 <a:solidFill>
-                  <a:srgbClr val="D4D4D4"/>
+                  <a:srgbClr val="4EC9B0"/>
                 </a:solidFill>
                 <a:latin typeface="Consolas"/>
               </a:rPr>
@@ -16705,7 +16705,7 @@
             <a:r>
               <a:rPr sz="1300">
                 <a:solidFill>
-                  <a:srgbClr val="D4D4D4"/>
+                  <a:srgbClr val="4EC9B0"/>
                 </a:solidFill>
                 <a:latin typeface="Consolas"/>
               </a:rPr>
@@ -16901,7 +16901,7 @@
             <a:r>
               <a:rPr sz="1300">
                 <a:solidFill>
-                  <a:srgbClr val="D4D4D4"/>
+                  <a:srgbClr val="4EC9B0"/>
                 </a:solidFill>
                 <a:latin typeface="Consolas"/>
               </a:rPr>
@@ -17097,7 +17097,7 @@
             <a:r>
               <a:rPr sz="1300">
                 <a:solidFill>
-                  <a:srgbClr val="D4D4D4"/>
+                  <a:srgbClr val="4EC9B0"/>
                 </a:solidFill>
                 <a:latin typeface="Consolas"/>
               </a:rPr>
@@ -17293,7 +17293,7 @@
             <a:r>
               <a:rPr sz="1300">
                 <a:solidFill>
-                  <a:srgbClr val="D4D4D4"/>
+                  <a:srgbClr val="4EC9B0"/>
                 </a:solidFill>
                 <a:latin typeface="Consolas"/>
               </a:rPr>
@@ -17489,7 +17489,7 @@
             <a:r>
               <a:rPr sz="1300">
                 <a:solidFill>
-                  <a:srgbClr val="D4D4D4"/>
+                  <a:srgbClr val="4EC9B0"/>
                 </a:solidFill>
                 <a:latin typeface="Consolas"/>
               </a:rPr>
@@ -18744,7 +18744,7 @@
             <a:r>
               <a:rPr sz="1400">
                 <a:solidFill>
-                  <a:srgbClr val="D4D4D4"/>
+                  <a:srgbClr val="4EC9B0"/>
                 </a:solidFill>
                 <a:latin typeface="Consolas"/>
               </a:rPr>
@@ -18922,7 +18922,7 @@
             <a:r>
               <a:rPr sz="1400">
                 <a:solidFill>
-                  <a:srgbClr val="D4D4D4"/>
+                  <a:srgbClr val="4EC9B0"/>
                 </a:solidFill>
                 <a:latin typeface="Consolas"/>
               </a:rPr>
@@ -19100,7 +19100,7 @@
             <a:r>
               <a:rPr sz="1400">
                 <a:solidFill>
-                  <a:srgbClr val="D4D4D4"/>
+                  <a:srgbClr val="4EC9B0"/>
                 </a:solidFill>
                 <a:latin typeface="Consolas"/>
               </a:rPr>
@@ -19251,7 +19251,7 @@
             <a:r>
               <a:rPr sz="1400">
                 <a:solidFill>
-                  <a:srgbClr val="D4D4D4"/>
+                  <a:srgbClr val="4EC9B0"/>
                 </a:solidFill>
                 <a:latin typeface="Consolas"/>
               </a:rPr>
@@ -19557,7 +19557,7 @@
             <a:r>
               <a:rPr sz="1400">
                 <a:solidFill>
-                  <a:srgbClr val="D4D4D4"/>
+                  <a:srgbClr val="4EC9B0"/>
                 </a:solidFill>
                 <a:latin typeface="Consolas"/>
               </a:rPr>
@@ -20113,7 +20113,7 @@
             <a:r>
               <a:rPr sz="1400">
                 <a:solidFill>
-                  <a:srgbClr val="D4D4D4"/>
+                  <a:srgbClr val="4EC9B0"/>
                 </a:solidFill>
                 <a:latin typeface="Consolas"/>
               </a:rPr>
@@ -21702,7 +21702,7 @@
             <a:r>
               <a:rPr sz="1300">
                 <a:solidFill>
-                  <a:srgbClr val="D4D4D4"/>
+                  <a:srgbClr val="4EC9B0"/>
                 </a:solidFill>
                 <a:latin typeface="Consolas"/>
               </a:rPr>
@@ -21747,7 +21747,7 @@
             <a:r>
               <a:rPr sz="1300">
                 <a:solidFill>
-                  <a:srgbClr val="D4D4D4"/>
+                  <a:srgbClr val="4EC9B0"/>
                 </a:solidFill>
                 <a:latin typeface="Consolas"/>
               </a:rPr>
@@ -21896,7 +21896,7 @@
             <a:r>
               <a:rPr sz="1300">
                 <a:solidFill>
-                  <a:srgbClr val="D4D4D4"/>
+                  <a:srgbClr val="4EC9B0"/>
                 </a:solidFill>
                 <a:latin typeface="Consolas"/>
               </a:rPr>
@@ -22024,7 +22024,7 @@
             <a:r>
               <a:rPr sz="1300">
                 <a:solidFill>
-                  <a:srgbClr val="D4D4D4"/>
+                  <a:srgbClr val="4EC9B0"/>
                 </a:solidFill>
                 <a:latin typeface="Consolas"/>
               </a:rPr>
@@ -22042,7 +22042,7 @@
             <a:r>
               <a:rPr sz="1300">
                 <a:solidFill>
-                  <a:srgbClr val="D4D4D4"/>
+                  <a:srgbClr val="4EC9B0"/>
                 </a:solidFill>
                 <a:latin typeface="Consolas"/>
               </a:rPr>
@@ -22506,7 +22506,7 @@
             <a:r>
               <a:rPr sz="1300">
                 <a:solidFill>
-                  <a:srgbClr val="D4D4D4"/>
+                  <a:srgbClr val="4EC9B0"/>
                 </a:solidFill>
                 <a:latin typeface="Consolas"/>
               </a:rPr>
@@ -22524,7 +22524,7 @@
             <a:r>
               <a:rPr sz="1300">
                 <a:solidFill>
-                  <a:srgbClr val="D4D4D4"/>
+                  <a:srgbClr val="4EC9B0"/>
                 </a:solidFill>
                 <a:latin typeface="Consolas"/>
               </a:rPr>
@@ -23011,7 +23011,7 @@
             <a:r>
               <a:rPr sz="1300">
                 <a:solidFill>
-                  <a:srgbClr val="D4D4D4"/>
+                  <a:srgbClr val="4EC9B0"/>
                 </a:solidFill>
                 <a:latin typeface="Consolas"/>
               </a:rPr>
@@ -23144,7 +23144,7 @@
             <a:r>
               <a:rPr sz="1300">
                 <a:solidFill>
-                  <a:srgbClr val="D4D4D4"/>
+                  <a:srgbClr val="4EC9B0"/>
                 </a:solidFill>
                 <a:latin typeface="Consolas"/>
               </a:rPr>
@@ -24200,7 +24200,7 @@
             <a:r>
               <a:rPr sz="1400">
                 <a:solidFill>
-                  <a:srgbClr val="D4D4D4"/>
+                  <a:srgbClr val="4EC9B0"/>
                 </a:solidFill>
                 <a:latin typeface="Consolas"/>
               </a:rPr>
@@ -24545,7 +24545,7 @@
             <a:r>
               <a:rPr sz="1400">
                 <a:solidFill>
-                  <a:srgbClr val="D4D4D4"/>
+                  <a:srgbClr val="4EC9B0"/>
                 </a:solidFill>
                 <a:latin typeface="Consolas"/>
               </a:rPr>
@@ -24617,7 +24617,7 @@
             <a:r>
               <a:rPr sz="1400">
                 <a:solidFill>
-                  <a:srgbClr val="D4D4D4"/>
+                  <a:srgbClr val="4EC9B0"/>
                 </a:solidFill>
                 <a:latin typeface="Consolas"/>
               </a:rPr>
@@ -24635,7 +24635,7 @@
             <a:r>
               <a:rPr sz="1400">
                 <a:solidFill>
-                  <a:srgbClr val="D4D4D4"/>
+                  <a:srgbClr val="4EC9B0"/>
                 </a:solidFill>
                 <a:latin typeface="Consolas"/>
               </a:rPr>
@@ -24921,7 +24921,7 @@
             <a:r>
               <a:rPr sz="1400">
                 <a:solidFill>
-                  <a:srgbClr val="D4D4D4"/>
+                  <a:srgbClr val="4EC9B0"/>
                 </a:solidFill>
                 <a:latin typeface="Consolas"/>
               </a:rPr>
@@ -25036,7 +25036,7 @@
             <a:r>
               <a:rPr sz="1400">
                 <a:solidFill>
-                  <a:srgbClr val="D4D4D4"/>
+                  <a:srgbClr val="4EC9B0"/>
                 </a:solidFill>
                 <a:latin typeface="Consolas"/>
               </a:rPr>

</xml_diff>

<commit_message>
Bold-only line emphasis so token colours are consistent across slides
Previously a highlighted line recoloured every token to solid bold-yellow, so
the same token (notably `query`) was yellow on slides that highlighted its line
and grey elsewhere. Make emphasis bold-only: highlighted lines keep their normal
syntax colours and are simply bold. Every token is now the same colour on every
slide; `query` is uniform (grey) with bold marking the "look here" lines.
Re-ran the updater across all 8 code boxes; hand edits untouched.

Co-Authored-By: Claude Opus 4.8 (1M context) <noreply@anthropic.com>
</commit_message>
<xml_diff>
--- a/slides/ACCU-Separation-of-Concerns-at-Zero-Cost.pptx
+++ b/slides/ACCU-Separation-of-Concerns-at-Zero-Cost.pptx
@@ -11502,7 +11502,7 @@
             <a:r>
               <a:rPr sz="1250" b="1">
                 <a:solidFill>
-                  <a:srgbClr val="F2C744"/>
+                  <a:srgbClr val="D4D4D4"/>
                 </a:solidFill>
                 <a:latin typeface="Consolas"/>
               </a:rPr>
@@ -11511,7 +11511,7 @@
             <a:r>
               <a:rPr sz="1250" b="1">
                 <a:solidFill>
-                  <a:srgbClr val="F2C744"/>
+                  <a:srgbClr val="D4D4D4"/>
                 </a:solidFill>
                 <a:latin typeface="Consolas"/>
               </a:rPr>
@@ -11520,7 +11520,7 @@
             <a:r>
               <a:rPr sz="1250" b="1">
                 <a:solidFill>
-                  <a:srgbClr val="F2C744"/>
+                  <a:srgbClr val="D4D4D4"/>
                 </a:solidFill>
                 <a:latin typeface="Consolas"/>
               </a:rPr>
@@ -11529,7 +11529,7 @@
             <a:r>
               <a:rPr sz="1250" b="1">
                 <a:solidFill>
-                  <a:srgbClr val="F2C744"/>
+                  <a:srgbClr val="D4D4D4"/>
                 </a:solidFill>
                 <a:latin typeface="Consolas"/>
               </a:rPr>
@@ -11538,7 +11538,7 @@
             <a:r>
               <a:rPr sz="1250" b="1">
                 <a:solidFill>
-                  <a:srgbClr val="F2C744"/>
+                  <a:srgbClr val="D4D4D4"/>
                 </a:solidFill>
                 <a:latin typeface="Consolas"/>
               </a:rPr>
@@ -11547,7 +11547,7 @@
             <a:r>
               <a:rPr sz="1250" b="1">
                 <a:solidFill>
-                  <a:srgbClr val="F2C744"/>
+                  <a:srgbClr val="D4D4D4"/>
                 </a:solidFill>
                 <a:latin typeface="Consolas"/>
               </a:rPr>
@@ -11556,7 +11556,7 @@
             <a:r>
               <a:rPr sz="1250" b="1">
                 <a:solidFill>
-                  <a:srgbClr val="F2C744"/>
+                  <a:srgbClr val="D4D4D4"/>
                 </a:solidFill>
                 <a:latin typeface="Consolas"/>
               </a:rPr>
@@ -11565,7 +11565,7 @@
             <a:r>
               <a:rPr sz="1250" b="1">
                 <a:solidFill>
-                  <a:srgbClr val="F2C744"/>
+                  <a:srgbClr val="D4D4D4"/>
                 </a:solidFill>
                 <a:latin typeface="Consolas"/>
               </a:rPr>
@@ -11574,7 +11574,7 @@
             <a:r>
               <a:rPr sz="1250" b="1">
                 <a:solidFill>
-                  <a:srgbClr val="F2C744"/>
+                  <a:srgbClr val="D4D4D4"/>
                 </a:solidFill>
                 <a:latin typeface="Consolas"/>
               </a:rPr>
@@ -11583,7 +11583,7 @@
             <a:r>
               <a:rPr sz="1250" b="1">
                 <a:solidFill>
-                  <a:srgbClr val="F2C744"/>
+                  <a:srgbClr val="569CD6"/>
                 </a:solidFill>
                 <a:latin typeface="Consolas"/>
               </a:rPr>
@@ -11592,7 +11592,7 @@
             <a:r>
               <a:rPr sz="1250" b="1">
                 <a:solidFill>
-                  <a:srgbClr val="F2C744"/>
+                  <a:srgbClr val="D4D4D4"/>
                 </a:solidFill>
                 <a:latin typeface="Consolas"/>
               </a:rPr>
@@ -11601,7 +11601,7 @@
             <a:r>
               <a:rPr sz="1250" b="1">
                 <a:solidFill>
-                  <a:srgbClr val="F2C744"/>
+                  <a:srgbClr val="4EC9B0"/>
                 </a:solidFill>
                 <a:latin typeface="Consolas"/>
               </a:rPr>
@@ -11610,7 +11610,7 @@
             <a:r>
               <a:rPr sz="1250" b="1">
                 <a:solidFill>
-                  <a:srgbClr val="F2C744"/>
+                  <a:srgbClr val="D4D4D4"/>
                 </a:solidFill>
                 <a:latin typeface="Consolas"/>
               </a:rPr>
@@ -11619,7 +11619,7 @@
             <a:r>
               <a:rPr sz="1250" b="1">
                 <a:solidFill>
-                  <a:srgbClr val="F2C744"/>
+                  <a:srgbClr val="D4D4D4"/>
                 </a:solidFill>
                 <a:latin typeface="Consolas"/>
               </a:rPr>
@@ -11628,7 +11628,7 @@
             <a:r>
               <a:rPr sz="1250" b="1">
                 <a:solidFill>
-                  <a:srgbClr val="F2C744"/>
+                  <a:srgbClr val="4EC9B0"/>
                 </a:solidFill>
                 <a:latin typeface="Consolas"/>
               </a:rPr>
@@ -11637,7 +11637,7 @@
             <a:r>
               <a:rPr sz="1250" b="1">
                 <a:solidFill>
-                  <a:srgbClr val="F2C744"/>
+                  <a:srgbClr val="D4D4D4"/>
                 </a:solidFill>
                 <a:latin typeface="Consolas"/>
               </a:rPr>
@@ -11646,7 +11646,7 @@
             <a:r>
               <a:rPr sz="1250" b="1">
                 <a:solidFill>
-                  <a:srgbClr val="F2C744"/>
+                  <a:srgbClr val="D4D4D4"/>
                 </a:solidFill>
                 <a:latin typeface="Consolas"/>
               </a:rPr>
@@ -11655,7 +11655,7 @@
             <a:r>
               <a:rPr sz="1250" b="1">
                 <a:solidFill>
-                  <a:srgbClr val="F2C744"/>
+                  <a:srgbClr val="D4D4D4"/>
                 </a:solidFill>
                 <a:latin typeface="Consolas"/>
               </a:rPr>
@@ -11664,7 +11664,7 @@
             <a:r>
               <a:rPr sz="1250" b="1">
                 <a:solidFill>
-                  <a:srgbClr val="F2C744"/>
+                  <a:srgbClr val="D4D4D4"/>
                 </a:solidFill>
                 <a:latin typeface="Consolas"/>
               </a:rPr>
@@ -11673,7 +11673,7 @@
             <a:r>
               <a:rPr sz="1250" b="1">
                 <a:solidFill>
-                  <a:srgbClr val="F2C744"/>
+                  <a:srgbClr val="D4D4D4"/>
                 </a:solidFill>
                 <a:latin typeface="Consolas"/>
               </a:rPr>
@@ -11682,7 +11682,7 @@
             <a:r>
               <a:rPr sz="1250" b="1">
                 <a:solidFill>
-                  <a:srgbClr val="F2C744"/>
+                  <a:srgbClr val="D4D4D4"/>
                 </a:solidFill>
                 <a:latin typeface="Consolas"/>
               </a:rPr>
@@ -11691,7 +11691,7 @@
             <a:r>
               <a:rPr sz="1250" b="1">
                 <a:solidFill>
-                  <a:srgbClr val="F2C744"/>
+                  <a:srgbClr val="D4D4D4"/>
                 </a:solidFill>
                 <a:latin typeface="Consolas"/>
               </a:rPr>
@@ -11700,7 +11700,7 @@
             <a:r>
               <a:rPr sz="1250" b="1">
                 <a:solidFill>
-                  <a:srgbClr val="F2C744"/>
+                  <a:srgbClr val="D4D4D4"/>
                 </a:solidFill>
                 <a:latin typeface="Consolas"/>
               </a:rPr>
@@ -14189,7 +14189,7 @@
             <a:r>
               <a:rPr sz="1250" b="1">
                 <a:solidFill>
-                  <a:srgbClr val="F2C744"/>
+                  <a:srgbClr val="D4D4D4"/>
                 </a:solidFill>
                 <a:latin typeface="Consolas"/>
               </a:rPr>
@@ -14198,7 +14198,7 @@
             <a:r>
               <a:rPr sz="1250" b="1">
                 <a:solidFill>
-                  <a:srgbClr val="F2C744"/>
+                  <a:srgbClr val="D4D4D4"/>
                 </a:solidFill>
                 <a:latin typeface="Consolas"/>
               </a:rPr>
@@ -14207,7 +14207,7 @@
             <a:r>
               <a:rPr sz="1250" b="1">
                 <a:solidFill>
-                  <a:srgbClr val="F2C744"/>
+                  <a:srgbClr val="D4D4D4"/>
                 </a:solidFill>
                 <a:latin typeface="Consolas"/>
               </a:rPr>
@@ -14216,7 +14216,7 @@
             <a:r>
               <a:rPr sz="1250" b="1">
                 <a:solidFill>
-                  <a:srgbClr val="F2C744"/>
+                  <a:srgbClr val="D4D4D4"/>
                 </a:solidFill>
                 <a:latin typeface="Consolas"/>
               </a:rPr>
@@ -14225,7 +14225,7 @@
             <a:r>
               <a:rPr sz="1250" b="1">
                 <a:solidFill>
-                  <a:srgbClr val="F2C744"/>
+                  <a:srgbClr val="D4D4D4"/>
                 </a:solidFill>
                 <a:latin typeface="Consolas"/>
               </a:rPr>
@@ -14234,7 +14234,7 @@
             <a:r>
               <a:rPr sz="1250" b="1">
                 <a:solidFill>
-                  <a:srgbClr val="F2C744"/>
+                  <a:srgbClr val="D4D4D4"/>
                 </a:solidFill>
                 <a:latin typeface="Consolas"/>
               </a:rPr>
@@ -14243,7 +14243,7 @@
             <a:r>
               <a:rPr sz="1250" b="1">
                 <a:solidFill>
-                  <a:srgbClr val="F2C744"/>
+                  <a:srgbClr val="D4D4D4"/>
                 </a:solidFill>
                 <a:latin typeface="Consolas"/>
               </a:rPr>
@@ -14252,7 +14252,7 @@
             <a:r>
               <a:rPr sz="1250" b="1">
                 <a:solidFill>
-                  <a:srgbClr val="F2C744"/>
+                  <a:srgbClr val="D4D4D4"/>
                 </a:solidFill>
                 <a:latin typeface="Consolas"/>
               </a:rPr>
@@ -14261,7 +14261,7 @@
             <a:r>
               <a:rPr sz="1250" b="1">
                 <a:solidFill>
-                  <a:srgbClr val="F2C744"/>
+                  <a:srgbClr val="D4D4D4"/>
                 </a:solidFill>
                 <a:latin typeface="Consolas"/>
               </a:rPr>
@@ -14270,7 +14270,7 @@
             <a:r>
               <a:rPr sz="1250" b="1">
                 <a:solidFill>
-                  <a:srgbClr val="F2C744"/>
+                  <a:srgbClr val="569CD6"/>
                 </a:solidFill>
                 <a:latin typeface="Consolas"/>
               </a:rPr>
@@ -14279,7 +14279,7 @@
             <a:r>
               <a:rPr sz="1250" b="1">
                 <a:solidFill>
-                  <a:srgbClr val="F2C744"/>
+                  <a:srgbClr val="D4D4D4"/>
                 </a:solidFill>
                 <a:latin typeface="Consolas"/>
               </a:rPr>
@@ -14288,7 +14288,7 @@
             <a:r>
               <a:rPr sz="1250" b="1">
                 <a:solidFill>
-                  <a:srgbClr val="F2C744"/>
+                  <a:srgbClr val="4EC9B0"/>
                 </a:solidFill>
                 <a:latin typeface="Consolas"/>
               </a:rPr>
@@ -14297,7 +14297,7 @@
             <a:r>
               <a:rPr sz="1250" b="1">
                 <a:solidFill>
-                  <a:srgbClr val="F2C744"/>
+                  <a:srgbClr val="D4D4D4"/>
                 </a:solidFill>
                 <a:latin typeface="Consolas"/>
               </a:rPr>
@@ -14306,7 +14306,7 @@
             <a:r>
               <a:rPr sz="1250" b="1">
                 <a:solidFill>
-                  <a:srgbClr val="F2C744"/>
+                  <a:srgbClr val="D4D4D4"/>
                 </a:solidFill>
                 <a:latin typeface="Consolas"/>
               </a:rPr>
@@ -14315,7 +14315,7 @@
             <a:r>
               <a:rPr sz="1250" b="1">
                 <a:solidFill>
-                  <a:srgbClr val="F2C744"/>
+                  <a:srgbClr val="4EC9B0"/>
                 </a:solidFill>
                 <a:latin typeface="Consolas"/>
               </a:rPr>
@@ -14324,7 +14324,7 @@
             <a:r>
               <a:rPr sz="1250" b="1">
                 <a:solidFill>
-                  <a:srgbClr val="F2C744"/>
+                  <a:srgbClr val="D4D4D4"/>
                 </a:solidFill>
                 <a:latin typeface="Consolas"/>
               </a:rPr>
@@ -14333,7 +14333,7 @@
             <a:r>
               <a:rPr sz="1250" b="1">
                 <a:solidFill>
-                  <a:srgbClr val="F2C744"/>
+                  <a:srgbClr val="D4D4D4"/>
                 </a:solidFill>
                 <a:latin typeface="Consolas"/>
               </a:rPr>
@@ -14342,7 +14342,7 @@
             <a:r>
               <a:rPr sz="1250" b="1">
                 <a:solidFill>
-                  <a:srgbClr val="F2C744"/>
+                  <a:srgbClr val="D4D4D4"/>
                 </a:solidFill>
                 <a:latin typeface="Consolas"/>
               </a:rPr>
@@ -14351,7 +14351,7 @@
             <a:r>
               <a:rPr sz="1250" b="1">
                 <a:solidFill>
-                  <a:srgbClr val="F2C744"/>
+                  <a:srgbClr val="D4D4D4"/>
                 </a:solidFill>
                 <a:latin typeface="Consolas"/>
               </a:rPr>
@@ -14360,7 +14360,7 @@
             <a:r>
               <a:rPr sz="1250" b="1">
                 <a:solidFill>
-                  <a:srgbClr val="F2C744"/>
+                  <a:srgbClr val="D4D4D4"/>
                 </a:solidFill>
                 <a:latin typeface="Consolas"/>
               </a:rPr>
@@ -14369,7 +14369,7 @@
             <a:r>
               <a:rPr sz="1250" b="1">
                 <a:solidFill>
-                  <a:srgbClr val="F2C744"/>
+                  <a:srgbClr val="D4D4D4"/>
                 </a:solidFill>
                 <a:latin typeface="Consolas"/>
               </a:rPr>
@@ -14378,7 +14378,7 @@
             <a:r>
               <a:rPr sz="1250" b="1">
                 <a:solidFill>
-                  <a:srgbClr val="F2C744"/>
+                  <a:srgbClr val="D4D4D4"/>
                 </a:solidFill>
                 <a:latin typeface="Consolas"/>
               </a:rPr>
@@ -14387,7 +14387,7 @@
             <a:r>
               <a:rPr sz="1250" b="1">
                 <a:solidFill>
-                  <a:srgbClr val="F2C744"/>
+                  <a:srgbClr val="D4D4D4"/>
                 </a:solidFill>
                 <a:latin typeface="Consolas"/>
               </a:rPr>
@@ -14403,7 +14403,7 @@
             <a:r>
               <a:rPr sz="1250" b="1">
                 <a:solidFill>
-                  <a:srgbClr val="F2C744"/>
+                  <a:srgbClr val="D4D4D4"/>
                 </a:solidFill>
                 <a:latin typeface="Consolas"/>
               </a:rPr>
@@ -14412,7 +14412,7 @@
             <a:r>
               <a:rPr sz="1250" b="1">
                 <a:solidFill>
-                  <a:srgbClr val="F2C744"/>
+                  <a:srgbClr val="D4D4D4"/>
                 </a:solidFill>
                 <a:latin typeface="Consolas"/>
               </a:rPr>
@@ -14421,7 +14421,7 @@
             <a:r>
               <a:rPr sz="1250" b="1">
                 <a:solidFill>
-                  <a:srgbClr val="F2C744"/>
+                  <a:srgbClr val="D4D4D4"/>
                 </a:solidFill>
                 <a:latin typeface="Consolas"/>
               </a:rPr>
@@ -14430,7 +14430,7 @@
             <a:r>
               <a:rPr sz="1250" b="1">
                 <a:solidFill>
-                  <a:srgbClr val="F2C744"/>
+                  <a:srgbClr val="D4D4D4"/>
                 </a:solidFill>
                 <a:latin typeface="Consolas"/>
               </a:rPr>
@@ -14439,7 +14439,7 @@
             <a:r>
               <a:rPr sz="1250" b="1">
                 <a:solidFill>
-                  <a:srgbClr val="F2C744"/>
+                  <a:srgbClr val="D4D4D4"/>
                 </a:solidFill>
                 <a:latin typeface="Consolas"/>
               </a:rPr>
@@ -14448,7 +14448,7 @@
             <a:r>
               <a:rPr sz="1250" b="1">
                 <a:solidFill>
-                  <a:srgbClr val="F2C744"/>
+                  <a:srgbClr val="D4D4D4"/>
                 </a:solidFill>
                 <a:latin typeface="Consolas"/>
               </a:rPr>
@@ -14457,7 +14457,7 @@
             <a:r>
               <a:rPr sz="1250" b="1">
                 <a:solidFill>
-                  <a:srgbClr val="F2C744"/>
+                  <a:srgbClr val="D4D4D4"/>
                 </a:solidFill>
                 <a:latin typeface="Consolas"/>
               </a:rPr>
@@ -14466,7 +14466,7 @@
             <a:r>
               <a:rPr sz="1250" b="1">
                 <a:solidFill>
-                  <a:srgbClr val="F2C744"/>
+                  <a:srgbClr val="D4D4D4"/>
                 </a:solidFill>
                 <a:latin typeface="Consolas"/>
               </a:rPr>
@@ -14475,7 +14475,7 @@
             <a:r>
               <a:rPr sz="1250" b="1">
                 <a:solidFill>
-                  <a:srgbClr val="F2C744"/>
+                  <a:srgbClr val="D4D4D4"/>
                 </a:solidFill>
                 <a:latin typeface="Consolas"/>
               </a:rPr>
@@ -14484,7 +14484,7 @@
             <a:r>
               <a:rPr sz="1250" b="1">
                 <a:solidFill>
-                  <a:srgbClr val="F2C744"/>
+                  <a:srgbClr val="569CD6"/>
                 </a:solidFill>
                 <a:latin typeface="Consolas"/>
               </a:rPr>
@@ -14493,7 +14493,7 @@
             <a:r>
               <a:rPr sz="1250" b="1">
                 <a:solidFill>
-                  <a:srgbClr val="F2C744"/>
+                  <a:srgbClr val="D4D4D4"/>
                 </a:solidFill>
                 <a:latin typeface="Consolas"/>
               </a:rPr>
@@ -14502,7 +14502,7 @@
             <a:r>
               <a:rPr sz="1250" b="1">
                 <a:solidFill>
-                  <a:srgbClr val="F2C744"/>
+                  <a:srgbClr val="4EC9B0"/>
                 </a:solidFill>
                 <a:latin typeface="Consolas"/>
               </a:rPr>
@@ -14511,7 +14511,7 @@
             <a:r>
               <a:rPr sz="1250" b="1">
                 <a:solidFill>
-                  <a:srgbClr val="F2C744"/>
+                  <a:srgbClr val="D4D4D4"/>
                 </a:solidFill>
                 <a:latin typeface="Consolas"/>
               </a:rPr>
@@ -14520,7 +14520,7 @@
             <a:r>
               <a:rPr sz="1250" b="1">
                 <a:solidFill>
-                  <a:srgbClr val="F2C744"/>
+                  <a:srgbClr val="D4D4D4"/>
                 </a:solidFill>
                 <a:latin typeface="Consolas"/>
               </a:rPr>
@@ -14529,7 +14529,7 @@
             <a:r>
               <a:rPr sz="1250" b="1">
                 <a:solidFill>
-                  <a:srgbClr val="F2C744"/>
+                  <a:srgbClr val="4EC9B0"/>
                 </a:solidFill>
                 <a:latin typeface="Consolas"/>
               </a:rPr>
@@ -14538,7 +14538,7 @@
             <a:r>
               <a:rPr sz="1250" b="1">
                 <a:solidFill>
-                  <a:srgbClr val="F2C744"/>
+                  <a:srgbClr val="D4D4D4"/>
                 </a:solidFill>
                 <a:latin typeface="Consolas"/>
               </a:rPr>
@@ -14547,7 +14547,7 @@
             <a:r>
               <a:rPr sz="1250" b="1">
                 <a:solidFill>
-                  <a:srgbClr val="F2C744"/>
+                  <a:srgbClr val="D4D4D4"/>
                 </a:solidFill>
                 <a:latin typeface="Consolas"/>
               </a:rPr>
@@ -14556,7 +14556,7 @@
             <a:r>
               <a:rPr sz="1250" b="1">
                 <a:solidFill>
-                  <a:srgbClr val="F2C744"/>
+                  <a:srgbClr val="D4D4D4"/>
                 </a:solidFill>
                 <a:latin typeface="Consolas"/>
               </a:rPr>
@@ -14565,7 +14565,7 @@
             <a:r>
               <a:rPr sz="1250" b="1">
                 <a:solidFill>
-                  <a:srgbClr val="F2C744"/>
+                  <a:srgbClr val="D4D4D4"/>
                 </a:solidFill>
                 <a:latin typeface="Consolas"/>
               </a:rPr>
@@ -14574,7 +14574,7 @@
             <a:r>
               <a:rPr sz="1250" b="1">
                 <a:solidFill>
-                  <a:srgbClr val="F2C744"/>
+                  <a:srgbClr val="D4D4D4"/>
                 </a:solidFill>
                 <a:latin typeface="Consolas"/>
               </a:rPr>
@@ -14583,7 +14583,7 @@
             <a:r>
               <a:rPr sz="1250" b="1">
                 <a:solidFill>
-                  <a:srgbClr val="F2C744"/>
+                  <a:srgbClr val="D4D4D4"/>
                 </a:solidFill>
                 <a:latin typeface="Consolas"/>
               </a:rPr>
@@ -14592,7 +14592,7 @@
             <a:r>
               <a:rPr sz="1250" b="1">
                 <a:solidFill>
-                  <a:srgbClr val="F2C744"/>
+                  <a:srgbClr val="D4D4D4"/>
                 </a:solidFill>
                 <a:latin typeface="Consolas"/>
               </a:rPr>
@@ -14601,7 +14601,7 @@
             <a:r>
               <a:rPr sz="1250" b="1">
                 <a:solidFill>
-                  <a:srgbClr val="F2C744"/>
+                  <a:srgbClr val="D4D4D4"/>
                 </a:solidFill>
                 <a:latin typeface="Consolas"/>
               </a:rPr>
@@ -19350,7 +19350,7 @@
             <a:r>
               <a:rPr sz="1400" b="1">
                 <a:solidFill>
-                  <a:srgbClr val="F2C744"/>
+                  <a:srgbClr val="6A9955"/>
                 </a:solidFill>
                 <a:latin typeface="Consolas"/>
               </a:rPr>
@@ -19366,7 +19366,7 @@
             <a:r>
               <a:rPr sz="1400" b="1">
                 <a:solidFill>
-                  <a:srgbClr val="F2C744"/>
+                  <a:srgbClr val="569CD6"/>
                 </a:solidFill>
                 <a:latin typeface="Consolas"/>
               </a:rPr>
@@ -19375,7 +19375,7 @@
             <a:r>
               <a:rPr sz="1400" b="1">
                 <a:solidFill>
-                  <a:srgbClr val="F2C744"/>
+                  <a:srgbClr val="D4D4D4"/>
                 </a:solidFill>
                 <a:latin typeface="Consolas"/>
               </a:rPr>
@@ -19384,7 +19384,7 @@
             <a:r>
               <a:rPr sz="1400" b="1">
                 <a:solidFill>
-                  <a:srgbClr val="F2C744"/>
+                  <a:srgbClr val="569CD6"/>
                 </a:solidFill>
                 <a:latin typeface="Consolas"/>
               </a:rPr>
@@ -19393,7 +19393,7 @@
             <a:r>
               <a:rPr sz="1400" b="1">
                 <a:solidFill>
-                  <a:srgbClr val="F2C744"/>
+                  <a:srgbClr val="D4D4D4"/>
                 </a:solidFill>
                 <a:latin typeface="Consolas"/>
               </a:rPr>
@@ -19402,7 +19402,7 @@
             <a:r>
               <a:rPr sz="1400" b="1">
                 <a:solidFill>
-                  <a:srgbClr val="F2C744"/>
+                  <a:srgbClr val="D4D4D4"/>
                 </a:solidFill>
                 <a:latin typeface="Consolas"/>
               </a:rPr>
@@ -19411,7 +19411,7 @@
             <a:r>
               <a:rPr sz="1400" b="1">
                 <a:solidFill>
-                  <a:srgbClr val="F2C744"/>
+                  <a:srgbClr val="D4D4D4"/>
                 </a:solidFill>
                 <a:latin typeface="Consolas"/>
               </a:rPr>
@@ -19420,7 +19420,7 @@
             <a:r>
               <a:rPr sz="1400" b="1">
                 <a:solidFill>
-                  <a:srgbClr val="F2C744"/>
+                  <a:srgbClr val="D4D4D4"/>
                 </a:solidFill>
                 <a:latin typeface="Consolas"/>
               </a:rPr>
@@ -19429,7 +19429,7 @@
             <a:r>
               <a:rPr sz="1400" b="1">
                 <a:solidFill>
-                  <a:srgbClr val="F2C744"/>
+                  <a:srgbClr val="D4D4D4"/>
                 </a:solidFill>
                 <a:latin typeface="Consolas"/>
               </a:rPr>
@@ -19438,7 +19438,7 @@
             <a:r>
               <a:rPr sz="1400" b="1">
                 <a:solidFill>
-                  <a:srgbClr val="F2C744"/>
+                  <a:srgbClr val="D4D4D4"/>
                 </a:solidFill>
                 <a:latin typeface="Consolas"/>
               </a:rPr>
@@ -19447,7 +19447,7 @@
             <a:r>
               <a:rPr sz="1400" b="1">
                 <a:solidFill>
-                  <a:srgbClr val="F2C744"/>
+                  <a:srgbClr val="D4D4D4"/>
                 </a:solidFill>
                 <a:latin typeface="Consolas"/>
               </a:rPr>
@@ -19456,7 +19456,7 @@
             <a:r>
               <a:rPr sz="1400" b="1">
                 <a:solidFill>
-                  <a:srgbClr val="F2C744"/>
+                  <a:srgbClr val="D4D4D4"/>
                 </a:solidFill>
                 <a:latin typeface="Consolas"/>
               </a:rPr>
@@ -19465,7 +19465,7 @@
             <a:r>
               <a:rPr sz="1400" b="1">
                 <a:solidFill>
-                  <a:srgbClr val="F2C744"/>
+                  <a:srgbClr val="D4D4D4"/>
                 </a:solidFill>
                 <a:latin typeface="Consolas"/>
               </a:rPr>
@@ -19474,7 +19474,7 @@
             <a:r>
               <a:rPr sz="1400" b="1">
                 <a:solidFill>
-                  <a:srgbClr val="F2C744"/>
+                  <a:srgbClr val="D4D4D4"/>
                 </a:solidFill>
                 <a:latin typeface="Consolas"/>
               </a:rPr>
@@ -19483,7 +19483,7 @@
             <a:r>
               <a:rPr sz="1400" b="1">
                 <a:solidFill>
-                  <a:srgbClr val="F2C744"/>
+                  <a:srgbClr val="4EC9B0"/>
                 </a:solidFill>
                 <a:latin typeface="Consolas"/>
               </a:rPr>
@@ -19492,7 +19492,7 @@
             <a:r>
               <a:rPr sz="1400" b="1">
                 <a:solidFill>
-                  <a:srgbClr val="F2C744"/>
+                  <a:srgbClr val="D4D4D4"/>
                 </a:solidFill>
                 <a:latin typeface="Consolas"/>
               </a:rPr>
@@ -19501,7 +19501,7 @@
             <a:r>
               <a:rPr sz="1400" b="1">
                 <a:solidFill>
-                  <a:srgbClr val="F2C744"/>
+                  <a:srgbClr val="D4D4D4"/>
                 </a:solidFill>
                 <a:latin typeface="Consolas"/>
               </a:rPr>
@@ -19510,7 +19510,7 @@
             <a:r>
               <a:rPr sz="1400" b="1">
                 <a:solidFill>
-                  <a:srgbClr val="F2C744"/>
+                  <a:srgbClr val="D4D4D4"/>
                 </a:solidFill>
                 <a:latin typeface="Consolas"/>
               </a:rPr>
@@ -19519,7 +19519,7 @@
             <a:r>
               <a:rPr sz="1400" b="1">
                 <a:solidFill>
-                  <a:srgbClr val="F2C744"/>
+                  <a:srgbClr val="D4D4D4"/>
                 </a:solidFill>
                 <a:latin typeface="Consolas"/>
               </a:rPr>
@@ -19528,7 +19528,7 @@
             <a:r>
               <a:rPr sz="1400" b="1">
                 <a:solidFill>
-                  <a:srgbClr val="F2C744"/>
+                  <a:srgbClr val="D4D4D4"/>
                 </a:solidFill>
                 <a:latin typeface="Consolas"/>
               </a:rPr>
@@ -22182,7 +22182,7 @@
             <a:r>
               <a:rPr sz="1300" b="1">
                 <a:solidFill>
-                  <a:srgbClr val="F2C744"/>
+                  <a:srgbClr val="D4D4D4"/>
                 </a:solidFill>
                 <a:latin typeface="Consolas"/>
               </a:rPr>
@@ -22191,7 +22191,7 @@
             <a:r>
               <a:rPr sz="1300" b="1">
                 <a:solidFill>
-                  <a:srgbClr val="F2C744"/>
+                  <a:srgbClr val="569CD6"/>
                 </a:solidFill>
                 <a:latin typeface="Consolas"/>
               </a:rPr>
@@ -22200,7 +22200,7 @@
             <a:r>
               <a:rPr sz="1300" b="1">
                 <a:solidFill>
-                  <a:srgbClr val="F2C744"/>
+                  <a:srgbClr val="D4D4D4"/>
                 </a:solidFill>
                 <a:latin typeface="Consolas"/>
               </a:rPr>
@@ -22209,7 +22209,7 @@
             <a:r>
               <a:rPr sz="1300" b="1">
                 <a:solidFill>
-                  <a:srgbClr val="F2C744"/>
+                  <a:srgbClr val="D4D4D4"/>
                 </a:solidFill>
                 <a:latin typeface="Consolas"/>
               </a:rPr>
@@ -22218,7 +22218,7 @@
             <a:r>
               <a:rPr sz="1300" b="1">
                 <a:solidFill>
-                  <a:srgbClr val="F2C744"/>
+                  <a:srgbClr val="4EC9B0"/>
                 </a:solidFill>
                 <a:latin typeface="Consolas"/>
               </a:rPr>
@@ -22227,7 +22227,7 @@
             <a:r>
               <a:rPr sz="1300" b="1">
                 <a:solidFill>
-                  <a:srgbClr val="F2C744"/>
+                  <a:srgbClr val="D4D4D4"/>
                 </a:solidFill>
                 <a:latin typeface="Consolas"/>
               </a:rPr>
@@ -22236,7 +22236,7 @@
             <a:r>
               <a:rPr sz="1300" b="1">
                 <a:solidFill>
-                  <a:srgbClr val="F2C744"/>
+                  <a:srgbClr val="4EC9B0"/>
                 </a:solidFill>
                 <a:latin typeface="Consolas"/>
               </a:rPr>
@@ -22245,7 +22245,7 @@
             <a:r>
               <a:rPr sz="1300" b="1">
                 <a:solidFill>
-                  <a:srgbClr val="F2C744"/>
+                  <a:srgbClr val="D4D4D4"/>
                 </a:solidFill>
                 <a:latin typeface="Consolas"/>
               </a:rPr>
@@ -22254,7 +22254,7 @@
             <a:r>
               <a:rPr sz="1300" b="1">
                 <a:solidFill>
-                  <a:srgbClr val="F2C744"/>
+                  <a:srgbClr val="D4D4D4"/>
                 </a:solidFill>
                 <a:latin typeface="Consolas"/>
               </a:rPr>
@@ -22263,7 +22263,7 @@
             <a:r>
               <a:rPr sz="1300" b="1">
                 <a:solidFill>
-                  <a:srgbClr val="F2C744"/>
+                  <a:srgbClr val="4EC9B0"/>
                 </a:solidFill>
                 <a:latin typeface="Consolas"/>
               </a:rPr>
@@ -22272,7 +22272,7 @@
             <a:r>
               <a:rPr sz="1300" b="1">
                 <a:solidFill>
-                  <a:srgbClr val="F2C744"/>
+                  <a:srgbClr val="D4D4D4"/>
                 </a:solidFill>
                 <a:latin typeface="Consolas"/>
               </a:rPr>
@@ -22281,7 +22281,7 @@
             <a:r>
               <a:rPr sz="1300" b="1">
                 <a:solidFill>
-                  <a:srgbClr val="F2C744"/>
+                  <a:srgbClr val="D4D4D4"/>
                 </a:solidFill>
                 <a:latin typeface="Consolas"/>
               </a:rPr>
@@ -22290,7 +22290,7 @@
             <a:r>
               <a:rPr sz="1300" b="1">
                 <a:solidFill>
-                  <a:srgbClr val="F2C744"/>
+                  <a:srgbClr val="D4D4D4"/>
                 </a:solidFill>
                 <a:latin typeface="Consolas"/>
               </a:rPr>
@@ -22299,7 +22299,7 @@
             <a:r>
               <a:rPr sz="1300" b="1">
                 <a:solidFill>
-                  <a:srgbClr val="F2C744"/>
+                  <a:srgbClr val="D4D4D4"/>
                 </a:solidFill>
                 <a:latin typeface="Consolas"/>
               </a:rPr>
@@ -22308,7 +22308,7 @@
             <a:r>
               <a:rPr sz="1300" b="1">
                 <a:solidFill>
-                  <a:srgbClr val="F2C744"/>
+                  <a:srgbClr val="D4D4D4"/>
                 </a:solidFill>
                 <a:latin typeface="Consolas"/>
               </a:rPr>
@@ -22317,7 +22317,7 @@
             <a:r>
               <a:rPr sz="1300" b="1">
                 <a:solidFill>
-                  <a:srgbClr val="F2C744"/>
+                  <a:srgbClr val="4EC9B0"/>
                 </a:solidFill>
                 <a:latin typeface="Consolas"/>
               </a:rPr>
@@ -22326,7 +22326,7 @@
             <a:r>
               <a:rPr sz="1300" b="1">
                 <a:solidFill>
-                  <a:srgbClr val="F2C744"/>
+                  <a:srgbClr val="D4D4D4"/>
                 </a:solidFill>
                 <a:latin typeface="Consolas"/>
               </a:rPr>
@@ -22335,7 +22335,7 @@
             <a:r>
               <a:rPr sz="1300" b="1">
                 <a:solidFill>
-                  <a:srgbClr val="F2C744"/>
+                  <a:srgbClr val="D4D4D4"/>
                 </a:solidFill>
                 <a:latin typeface="Consolas"/>
               </a:rPr>
@@ -22344,7 +22344,7 @@
             <a:r>
               <a:rPr sz="1300" b="1">
                 <a:solidFill>
-                  <a:srgbClr val="F2C744"/>
+                  <a:srgbClr val="D4D4D4"/>
                 </a:solidFill>
                 <a:latin typeface="Consolas"/>
               </a:rPr>
@@ -22353,7 +22353,7 @@
             <a:r>
               <a:rPr sz="1300" b="1">
                 <a:solidFill>
-                  <a:srgbClr val="F2C744"/>
+                  <a:srgbClr val="D4D4D4"/>
                 </a:solidFill>
                 <a:latin typeface="Consolas"/>
               </a:rPr>
@@ -22362,7 +22362,7 @@
             <a:r>
               <a:rPr sz="1300" b="1">
                 <a:solidFill>
-                  <a:srgbClr val="F2C744"/>
+                  <a:srgbClr val="D4D4D4"/>
                 </a:solidFill>
                 <a:latin typeface="Consolas"/>
               </a:rPr>
@@ -22371,7 +22371,7 @@
             <a:r>
               <a:rPr sz="1300" b="1">
                 <a:solidFill>
-                  <a:srgbClr val="F2C744"/>
+                  <a:srgbClr val="D4D4D4"/>
                 </a:solidFill>
                 <a:latin typeface="Consolas"/>
               </a:rPr>
@@ -22380,7 +22380,7 @@
             <a:r>
               <a:rPr sz="1300" b="1">
                 <a:solidFill>
-                  <a:srgbClr val="F2C744"/>
+                  <a:srgbClr val="D4D4D4"/>
                 </a:solidFill>
                 <a:latin typeface="Consolas"/>
               </a:rPr>
@@ -22389,7 +22389,7 @@
             <a:r>
               <a:rPr sz="1300" b="1">
                 <a:solidFill>
-                  <a:srgbClr val="F2C744"/>
+                  <a:srgbClr val="D4D4D4"/>
                 </a:solidFill>
                 <a:latin typeface="Consolas"/>
               </a:rPr>
@@ -22398,7 +22398,7 @@
             <a:r>
               <a:rPr sz="1300" b="1">
                 <a:solidFill>
-                  <a:srgbClr val="F2C744"/>
+                  <a:srgbClr val="D4D4D4"/>
                 </a:solidFill>
                 <a:latin typeface="Consolas"/>
               </a:rPr>
@@ -22407,7 +22407,7 @@
             <a:r>
               <a:rPr sz="1300" b="1">
                 <a:solidFill>
-                  <a:srgbClr val="F2C744"/>
+                  <a:srgbClr val="D4D4D4"/>
                 </a:solidFill>
                 <a:latin typeface="Consolas"/>
               </a:rPr>
@@ -22745,7 +22745,7 @@
             <a:r>
               <a:rPr sz="1300" b="1">
                 <a:solidFill>
-                  <a:srgbClr val="F2C744"/>
+                  <a:srgbClr val="D4D4D4"/>
                 </a:solidFill>
                 <a:latin typeface="Consolas"/>
               </a:rPr>
@@ -22754,7 +22754,7 @@
             <a:r>
               <a:rPr sz="1300" b="1">
                 <a:solidFill>
-                  <a:srgbClr val="F2C744"/>
+                  <a:srgbClr val="569CD6"/>
                 </a:solidFill>
                 <a:latin typeface="Consolas"/>
               </a:rPr>
@@ -22763,7 +22763,7 @@
             <a:r>
               <a:rPr sz="1300" b="1">
                 <a:solidFill>
-                  <a:srgbClr val="F2C744"/>
+                  <a:srgbClr val="D4D4D4"/>
                 </a:solidFill>
                 <a:latin typeface="Consolas"/>
               </a:rPr>
@@ -22772,7 +22772,7 @@
             <a:r>
               <a:rPr sz="1300" b="1">
                 <a:solidFill>
-                  <a:srgbClr val="F2C744"/>
+                  <a:srgbClr val="D4D4D4"/>
                 </a:solidFill>
                 <a:latin typeface="Consolas"/>
               </a:rPr>
@@ -22781,7 +22781,7 @@
             <a:r>
               <a:rPr sz="1300" b="1">
                 <a:solidFill>
-                  <a:srgbClr val="F2C744"/>
+                  <a:srgbClr val="D4D4D4"/>
                 </a:solidFill>
                 <a:latin typeface="Consolas"/>
               </a:rPr>
@@ -22790,7 +22790,7 @@
             <a:r>
               <a:rPr sz="1300" b="1">
                 <a:solidFill>
-                  <a:srgbClr val="F2C744"/>
+                  <a:srgbClr val="4EC9B0"/>
                 </a:solidFill>
                 <a:latin typeface="Consolas"/>
               </a:rPr>
@@ -22799,7 +22799,7 @@
             <a:r>
               <a:rPr sz="1300" b="1">
                 <a:solidFill>
-                  <a:srgbClr val="F2C744"/>
+                  <a:srgbClr val="D4D4D4"/>
                 </a:solidFill>
                 <a:latin typeface="Consolas"/>
               </a:rPr>
@@ -22808,7 +22808,7 @@
             <a:r>
               <a:rPr sz="1300" b="1">
                 <a:solidFill>
-                  <a:srgbClr val="F2C744"/>
+                  <a:srgbClr val="D4D4D4"/>
                 </a:solidFill>
                 <a:latin typeface="Consolas"/>
               </a:rPr>
@@ -22817,7 +22817,7 @@
             <a:r>
               <a:rPr sz="1300" b="1">
                 <a:solidFill>
-                  <a:srgbClr val="F2C744"/>
+                  <a:srgbClr val="D4D4D4"/>
                 </a:solidFill>
                 <a:latin typeface="Consolas"/>
               </a:rPr>
@@ -22826,7 +22826,7 @@
             <a:r>
               <a:rPr sz="1300" b="1">
                 <a:solidFill>
-                  <a:srgbClr val="F2C744"/>
+                  <a:srgbClr val="D4D4D4"/>
                 </a:solidFill>
                 <a:latin typeface="Consolas"/>
               </a:rPr>
@@ -22842,7 +22842,7 @@
             <a:r>
               <a:rPr sz="1300" b="1">
                 <a:solidFill>
-                  <a:srgbClr val="F2C744"/>
+                  <a:srgbClr val="D4D4D4"/>
                 </a:solidFill>
                 <a:latin typeface="Consolas"/>
               </a:rPr>
@@ -22851,7 +22851,7 @@
             <a:r>
               <a:rPr sz="1300" b="1">
                 <a:solidFill>
-                  <a:srgbClr val="F2C744"/>
+                  <a:srgbClr val="CE9178"/>
                 </a:solidFill>
                 <a:latin typeface="Consolas"/>
               </a:rPr>
@@ -22860,7 +22860,7 @@
             <a:r>
               <a:rPr sz="1300" b="1">
                 <a:solidFill>
-                  <a:srgbClr val="F2C744"/>
+                  <a:srgbClr val="CE9178"/>
                 </a:solidFill>
                 <a:latin typeface="Consolas"/>
               </a:rPr>
@@ -22869,7 +22869,7 @@
             <a:r>
               <a:rPr sz="1300" b="1">
                 <a:solidFill>
-                  <a:srgbClr val="F2C744"/>
+                  <a:srgbClr val="CE9178"/>
                 </a:solidFill>
                 <a:latin typeface="Consolas"/>
               </a:rPr>
@@ -22878,7 +22878,7 @@
             <a:r>
               <a:rPr sz="1300" b="1">
                 <a:solidFill>
-                  <a:srgbClr val="F2C744"/>
+                  <a:srgbClr val="D4D4D4"/>
                 </a:solidFill>
                 <a:latin typeface="Consolas"/>
               </a:rPr>
@@ -22887,7 +22887,7 @@
             <a:r>
               <a:rPr sz="1300" b="1">
                 <a:solidFill>
-                  <a:srgbClr val="F2C744"/>
+                  <a:srgbClr val="D4D4D4"/>
                 </a:solidFill>
                 <a:latin typeface="Consolas"/>
               </a:rPr>
@@ -29670,7 +29670,7 @@
             <a:r>
               <a:rPr sz="1400" b="1">
                 <a:solidFill>
-                  <a:srgbClr val="F2C744"/>
+                  <a:srgbClr val="569CD6"/>
                 </a:solidFill>
                 <a:latin typeface="Consolas"/>
               </a:rPr>
@@ -29679,7 +29679,7 @@
             <a:r>
               <a:rPr sz="1400" b="1">
                 <a:solidFill>
-                  <a:srgbClr val="F2C744"/>
+                  <a:srgbClr val="D4D4D4"/>
                 </a:solidFill>
                 <a:latin typeface="Consolas"/>
               </a:rPr>
@@ -29688,7 +29688,7 @@
             <a:r>
               <a:rPr sz="1400" b="1">
                 <a:solidFill>
-                  <a:srgbClr val="F2C744"/>
+                  <a:srgbClr val="D4D4D4"/>
                 </a:solidFill>
                 <a:latin typeface="Consolas"/>
               </a:rPr>
@@ -29697,7 +29697,7 @@
             <a:r>
               <a:rPr sz="1400" b="1">
                 <a:solidFill>
-                  <a:srgbClr val="F2C744"/>
+                  <a:srgbClr val="D4D4D4"/>
                 </a:solidFill>
                 <a:latin typeface="Consolas"/>
               </a:rPr>
@@ -29706,7 +29706,7 @@
             <a:r>
               <a:rPr sz="1400" b="1">
                 <a:solidFill>
-                  <a:srgbClr val="F2C744"/>
+                  <a:srgbClr val="D4D4D4"/>
                 </a:solidFill>
                 <a:latin typeface="Consolas"/>
               </a:rPr>
@@ -29715,7 +29715,7 @@
             <a:r>
               <a:rPr sz="1400" b="1">
                 <a:solidFill>
-                  <a:srgbClr val="F2C744"/>
+                  <a:srgbClr val="D4D4D4"/>
                 </a:solidFill>
                 <a:latin typeface="Consolas"/>
               </a:rPr>
@@ -29724,7 +29724,7 @@
             <a:r>
               <a:rPr sz="1400" b="1">
                 <a:solidFill>
-                  <a:srgbClr val="F2C744"/>
+                  <a:srgbClr val="4EC9B0"/>
                 </a:solidFill>
                 <a:latin typeface="Consolas"/>
               </a:rPr>
@@ -29733,7 +29733,7 @@
             <a:r>
               <a:rPr sz="1400" b="1">
                 <a:solidFill>
-                  <a:srgbClr val="F2C744"/>
+                  <a:srgbClr val="D4D4D4"/>
                 </a:solidFill>
                 <a:latin typeface="Consolas"/>
               </a:rPr>
@@ -29742,7 +29742,7 @@
             <a:r>
               <a:rPr sz="1400" b="1">
                 <a:solidFill>
-                  <a:srgbClr val="F2C744"/>
+                  <a:srgbClr val="4EC9B0"/>
                 </a:solidFill>
                 <a:latin typeface="Consolas"/>
               </a:rPr>
@@ -29751,7 +29751,7 @@
             <a:r>
               <a:rPr sz="1400" b="1">
                 <a:solidFill>
-                  <a:srgbClr val="F2C744"/>
+                  <a:srgbClr val="D4D4D4"/>
                 </a:solidFill>
                 <a:latin typeface="Consolas"/>
               </a:rPr>
@@ -29760,7 +29760,7 @@
             <a:r>
               <a:rPr sz="1400" b="1">
                 <a:solidFill>
-                  <a:srgbClr val="F2C744"/>
+                  <a:srgbClr val="D4D4D4"/>
                 </a:solidFill>
                 <a:latin typeface="Consolas"/>
               </a:rPr>
@@ -29769,7 +29769,7 @@
             <a:r>
               <a:rPr sz="1400" b="1">
                 <a:solidFill>
-                  <a:srgbClr val="F2C744"/>
+                  <a:srgbClr val="B5CEA8"/>
                 </a:solidFill>
                 <a:latin typeface="Consolas"/>
               </a:rPr>
@@ -29778,7 +29778,7 @@
             <a:r>
               <a:rPr sz="1400" b="1">
                 <a:solidFill>
-                  <a:srgbClr val="F2C744"/>
+                  <a:srgbClr val="D4D4D4"/>
                 </a:solidFill>
                 <a:latin typeface="Consolas"/>
               </a:rPr>
@@ -29787,7 +29787,7 @@
             <a:r>
               <a:rPr sz="1400" b="1">
                 <a:solidFill>
-                  <a:srgbClr val="F2C744"/>
+                  <a:srgbClr val="D4D4D4"/>
                 </a:solidFill>
                 <a:latin typeface="Consolas"/>
               </a:rPr>
@@ -29796,7 +29796,7 @@
             <a:r>
               <a:rPr sz="1400" b="1">
                 <a:solidFill>
-                  <a:srgbClr val="F2C744"/>
+                  <a:srgbClr val="D4D4D4"/>
                 </a:solidFill>
                 <a:latin typeface="Consolas"/>
               </a:rPr>
@@ -29805,7 +29805,7 @@
             <a:r>
               <a:rPr sz="1400" b="1">
                 <a:solidFill>
-                  <a:srgbClr val="F2C744"/>
+                  <a:srgbClr val="6A9955"/>
                 </a:solidFill>
                 <a:latin typeface="Consolas"/>
               </a:rPr>
@@ -29821,7 +29821,7 @@
             <a:r>
               <a:rPr sz="1400" b="1">
                 <a:solidFill>
-                  <a:srgbClr val="F2C744"/>
+                  <a:srgbClr val="569CD6"/>
                 </a:solidFill>
                 <a:latin typeface="Consolas"/>
               </a:rPr>
@@ -29830,7 +29830,7 @@
             <a:r>
               <a:rPr sz="1400" b="1">
                 <a:solidFill>
-                  <a:srgbClr val="F2C744"/>
+                  <a:srgbClr val="D4D4D4"/>
                 </a:solidFill>
                 <a:latin typeface="Consolas"/>
               </a:rPr>
@@ -29839,7 +29839,7 @@
             <a:r>
               <a:rPr sz="1400" b="1">
                 <a:solidFill>
-                  <a:srgbClr val="F2C744"/>
+                  <a:srgbClr val="D4D4D4"/>
                 </a:solidFill>
                 <a:latin typeface="Consolas"/>
               </a:rPr>
@@ -29848,7 +29848,7 @@
             <a:r>
               <a:rPr sz="1400" b="1">
                 <a:solidFill>
-                  <a:srgbClr val="F2C744"/>
+                  <a:srgbClr val="D4D4D4"/>
                 </a:solidFill>
                 <a:latin typeface="Consolas"/>
               </a:rPr>
@@ -29857,7 +29857,7 @@
             <a:r>
               <a:rPr sz="1400" b="1">
                 <a:solidFill>
-                  <a:srgbClr val="F2C744"/>
+                  <a:srgbClr val="D4D4D4"/>
                 </a:solidFill>
                 <a:latin typeface="Consolas"/>
               </a:rPr>
@@ -29866,7 +29866,7 @@
             <a:r>
               <a:rPr sz="1400" b="1">
                 <a:solidFill>
-                  <a:srgbClr val="F2C744"/>
+                  <a:srgbClr val="D4D4D4"/>
                 </a:solidFill>
                 <a:latin typeface="Consolas"/>
               </a:rPr>
@@ -29875,7 +29875,7 @@
             <a:r>
               <a:rPr sz="1400" b="1">
                 <a:solidFill>
-                  <a:srgbClr val="F2C744"/>
+                  <a:srgbClr val="D4D4D4"/>
                 </a:solidFill>
                 <a:latin typeface="Consolas"/>
               </a:rPr>
@@ -29884,7 +29884,7 @@
             <a:r>
               <a:rPr sz="1400" b="1">
                 <a:solidFill>
-                  <a:srgbClr val="F2C744"/>
+                  <a:srgbClr val="D4D4D4"/>
                 </a:solidFill>
                 <a:latin typeface="Consolas"/>
               </a:rPr>
@@ -29893,7 +29893,7 @@
             <a:r>
               <a:rPr sz="1400" b="1">
                 <a:solidFill>
-                  <a:srgbClr val="F2C744"/>
+                  <a:srgbClr val="D4D4D4"/>
                 </a:solidFill>
                 <a:latin typeface="Consolas"/>
               </a:rPr>
@@ -29902,7 +29902,7 @@
             <a:r>
               <a:rPr sz="1400" b="1">
                 <a:solidFill>
-                  <a:srgbClr val="F2C744"/>
+                  <a:srgbClr val="D4D4D4"/>
                 </a:solidFill>
                 <a:latin typeface="Consolas"/>
               </a:rPr>
@@ -29911,7 +29911,7 @@
             <a:r>
               <a:rPr sz="1400" b="1">
                 <a:solidFill>
-                  <a:srgbClr val="F2C744"/>
+                  <a:srgbClr val="D4D4D4"/>
                 </a:solidFill>
                 <a:latin typeface="Consolas"/>
               </a:rPr>
@@ -29920,7 +29920,7 @@
             <a:r>
               <a:rPr sz="1400" b="1">
                 <a:solidFill>
-                  <a:srgbClr val="F2C744"/>
+                  <a:srgbClr val="D4D4D4"/>
                 </a:solidFill>
                 <a:latin typeface="Consolas"/>
               </a:rPr>
@@ -29929,7 +29929,7 @@
             <a:r>
               <a:rPr sz="1400" b="1">
                 <a:solidFill>
-                  <a:srgbClr val="F2C744"/>
+                  <a:srgbClr val="D4D4D4"/>
                 </a:solidFill>
                 <a:latin typeface="Consolas"/>
               </a:rPr>
@@ -29938,7 +29938,7 @@
             <a:r>
               <a:rPr sz="1400" b="1">
                 <a:solidFill>
-                  <a:srgbClr val="F2C744"/>
+                  <a:srgbClr val="D4D4D4"/>
                 </a:solidFill>
                 <a:latin typeface="Consolas"/>
               </a:rPr>
@@ -29947,7 +29947,7 @@
             <a:r>
               <a:rPr sz="1400" b="1">
                 <a:solidFill>
-                  <a:srgbClr val="F2C744"/>
+                  <a:srgbClr val="D4D4D4"/>
                 </a:solidFill>
                 <a:latin typeface="Consolas"/>
               </a:rPr>
@@ -29956,7 +29956,7 @@
             <a:r>
               <a:rPr sz="1400" b="1">
                 <a:solidFill>
-                  <a:srgbClr val="F2C744"/>
+                  <a:srgbClr val="D4D4D4"/>
                 </a:solidFill>
                 <a:latin typeface="Consolas"/>
               </a:rPr>
@@ -29965,7 +29965,7 @@
             <a:r>
               <a:rPr sz="1400" b="1">
                 <a:solidFill>
-                  <a:srgbClr val="F2C744"/>
+                  <a:srgbClr val="D4D4D4"/>
                 </a:solidFill>
                 <a:latin typeface="Consolas"/>
               </a:rPr>

</xml_diff>

<commit_message>
Add 'compute vs query' slide to clarify provide-vs-ask
The deck used compute (provider hook), query (how you ask), and computeFunction
(registry mechanism) but only ever defined compute and computeFunction on
slides — query was used from the first walkthrough slide yet never shown. That
left the compute/query distinction unclear.

Add a slide after the registry (How It Works 3/5) that defines query and frames
it: a component PROVIDES via compute; anyone ASKS via query<Tag>(registry,
state); query is just registry.computeFunction<Tag> with friendlier syntax,
routing to the provider's compute. Renumbered the How-It-Works kickers to N/5
and fixed all subsequent page numbers. New code box is tagged code:query so the
updater maintains it. Deck is now 39 slides; PDF regenerated.

Co-Authored-By: Claude Opus 4.8 (1M context) <noreply@anthropic.com>
</commit_message>
<xml_diff>
--- a/slides/ACCU-Separation-of-Concerns-at-Zero-Cost.pptx
+++ b/slides/ACCU-Separation-of-Concerns-at-Zero-Cost.pptx
@@ -32,6 +32,7 @@
     <p:sldId id="277" r:id="rId23"/>
     <p:sldId id="278" r:id="rId24"/>
     <p:sldId id="279" r:id="rId25"/>
+    <p:sldId id="296" r:id="rId45"/>
     <p:sldId id="280" r:id="rId26"/>
     <p:sldId id="281" r:id="rId27"/>
     <p:sldId id="282" r:id="rId28"/>
@@ -21088,7 +21089,7 @@
                 </a:solidFill>
                 <a:latin typeface="Segoe UI"/>
               </a:rPr>
-              <a:t>HOW IT WORKS 1/4</a:t>
+              <a:t>HOW IT WORKS 1/5</a:t>
             </a:r>
           </a:p>
         </p:txBody>
@@ -21927,7 +21928,7 @@
                 </a:solidFill>
                 <a:latin typeface="Segoe UI"/>
               </a:rPr>
-              <a:t>HOW IT WORKS 2/4</a:t>
+              <a:t>HOW IT WORKS 2/5</a:t>
             </a:r>
           </a:p>
         </p:txBody>
@@ -23839,7 +23840,7 @@
                 </a:solidFill>
                 <a:latin typeface="Segoe UI"/>
               </a:rPr>
-              <a:t>HOW IT WORKS 3/4</a:t>
+              <a:t>HOW IT WORKS 4/5</a:t>
             </a:r>
           </a:p>
         </p:txBody>
@@ -25632,7 +25633,7 @@
                 </a:solidFill>
                 <a:latin typeface="Segoe UI"/>
               </a:rPr>
-              <a:t>25</a:t>
+              <a:t>26</a:t>
             </a:r>
           </a:p>
         </p:txBody>
@@ -25699,7 +25700,7 @@
                 </a:solidFill>
                 <a:latin typeface="Segoe UI"/>
               </a:rPr>
-              <a:t>HOW IT WORKS 4/4</a:t>
+              <a:t>HOW IT WORKS 5/5</a:t>
             </a:r>
           </a:p>
         </p:txBody>
@@ -26018,7 +26019,7 @@
                 </a:solidFill>
                 <a:latin typeface="Segoe UI"/>
               </a:rPr>
-              <a:t>26</a:t>
+              <a:t>27</a:t>
             </a:r>
           </a:p>
         </p:txBody>
@@ -26301,7 +26302,7 @@
                 </a:solidFill>
                 <a:latin typeface="Segoe UI"/>
               </a:rPr>
-              <a:t>27</a:t>
+              <a:t>28</a:t>
             </a:r>
           </a:p>
         </p:txBody>
@@ -27286,7 +27287,7 @@
                 </a:solidFill>
                 <a:latin typeface="Segoe UI"/>
               </a:rPr>
-              <a:t>28</a:t>
+              <a:t>29</a:t>
             </a:r>
           </a:p>
         </p:txBody>
@@ -27618,7 +27619,7 @@
                 </a:solidFill>
                 <a:latin typeface="Segoe UI"/>
               </a:rPr>
-              <a:t>29</a:t>
+              <a:t>30</a:t>
             </a:r>
           </a:p>
         </p:txBody>
@@ -28513,7 +28514,7 @@
                 </a:solidFill>
                 <a:latin typeface="Segoe UI"/>
               </a:rPr>
-              <a:t>30</a:t>
+              <a:t>31</a:t>
             </a:r>
           </a:p>
         </p:txBody>
@@ -28796,7 +28797,7 @@
                 </a:solidFill>
                 <a:latin typeface="Segoe UI"/>
               </a:rPr>
-              <a:t>31</a:t>
+              <a:t>32</a:t>
             </a:r>
           </a:p>
         </p:txBody>
@@ -29686,7 +29687,7 @@
                 </a:solidFill>
                 <a:latin typeface="Segoe UI"/>
               </a:rPr>
-              <a:t>32</a:t>
+              <a:t>33</a:t>
             </a:r>
           </a:p>
         </p:txBody>
@@ -30947,7 +30948,7 @@
                 </a:solidFill>
                 <a:latin typeface="Segoe UI"/>
               </a:rPr>
-              <a:t>33</a:t>
+              <a:t>34</a:t>
             </a:r>
           </a:p>
         </p:txBody>
@@ -31267,7 +31268,7 @@
                 </a:solidFill>
                 <a:latin typeface="Segoe UI"/>
               </a:rPr>
-              <a:t>34</a:t>
+              <a:t>35</a:t>
             </a:r>
           </a:p>
         </p:txBody>
@@ -31568,7 +31569,7 @@
                 </a:solidFill>
                 <a:latin typeface="Segoe UI"/>
               </a:rPr>
-              <a:t>35</a:t>
+              <a:t>36</a:t>
             </a:r>
           </a:p>
         </p:txBody>
@@ -31961,7 +31962,7 @@
                 </a:solidFill>
                 <a:latin typeface="Segoe UI"/>
               </a:rPr>
-              <a:t>36</a:t>
+              <a:t>37</a:t>
             </a:r>
           </a:p>
         </p:txBody>
@@ -32318,7 +32319,7 @@
                 </a:solidFill>
                 <a:latin typeface="Segoe UI"/>
               </a:rPr>
-              <a:t>37</a:t>
+              <a:t>38</a:t>
             </a:r>
           </a:p>
         </p:txBody>
@@ -32669,7 +32670,1339 @@
                 </a:solidFill>
                 <a:latin typeface="Segoe UI"/>
               </a:rPr>
-              <a:t>38</a:t>
+              <a:t>39</a:t>
+            </a:r>
+          </a:p>
+        </p:txBody>
+      </p:sp>
+    </p:spTree>
+  </p:cSld>
+  <p:clrMapOvr>
+    <a:masterClrMapping/>
+  </p:clrMapOvr>
+</p:sld>
+</file>
+
+<file path=ppt/slides/slide39.xml><?xml version="1.0" encoding="utf-8"?>
+<p:sld xmlns:a="http://schemas.openxmlformats.org/drawingml/2006/main" xmlns:p="http://schemas.openxmlformats.org/presentationml/2006/main" xmlns:r="http://schemas.openxmlformats.org/officeDocument/2006/relationships">
+  <p:cSld>
+    <p:bg>
+      <p:bgPr>
+        <a:solidFill>
+          <a:srgbClr val="0B1F33"/>
+        </a:solidFill>
+        <a:effectLst/>
+      </p:bgPr>
+    </p:bg>
+    <p:spTree>
+      <p:nvGrpSpPr>
+        <p:cNvPr id="1" name=""/>
+        <p:cNvGrpSpPr/>
+        <p:nvPr/>
+      </p:nvGrpSpPr>
+      <p:grpSpPr/>
+      <p:sp>
+        <p:nvSpPr>
+          <p:cNvPr id="2" name="TextBox 1"/>
+          <p:cNvSpPr txBox="1"/>
+          <p:nvPr/>
+        </p:nvSpPr>
+        <p:spPr>
+          <a:xfrm>
+            <a:off x="502920" y="384048"/>
+            <a:ext cx="11155680" cy="292608"/>
+          </a:xfrm>
+          <a:prstGeom prst="rect">
+            <a:avLst/>
+          </a:prstGeom>
+          <a:noFill/>
+        </p:spPr>
+        <p:txBody>
+          <a:bodyPr wrap="none">
+            <a:spAutoFit/>
+          </a:bodyPr>
+          <a:lstStyle/>
+          <a:p>
+            <a:r>
+              <a:rPr sz="1300" b="1">
+                <a:solidFill>
+                  <a:srgbClr val="F2C744"/>
+                </a:solidFill>
+                <a:latin typeface="Segoe UI"/>
+              </a:rPr>
+              <a:t>HOW IT WORKS 3/5</a:t>
+            </a:r>
+          </a:p>
+        </p:txBody>
+      </p:sp>
+      <p:sp>
+        <p:nvSpPr>
+          <p:cNvPr id="3" name="TextBox 2"/>
+          <p:cNvSpPr txBox="1"/>
+          <p:nvPr/>
+        </p:nvSpPr>
+        <p:spPr>
+          <a:xfrm>
+            <a:off x="457200" y="694944"/>
+            <a:ext cx="8111516" cy="569387"/>
+          </a:xfrm>
+          <a:prstGeom prst="rect">
+            <a:avLst/>
+          </a:prstGeom>
+          <a:noFill/>
+        </p:spPr>
+        <p:txBody>
+          <a:bodyPr wrap="none">
+            <a:spAutoFit/>
+          </a:bodyPr>
+          <a:lstStyle/>
+          <a:p>
+            <a:r>
+              <a:rPr sz="3100" b="1" dirty="0">
+                <a:solidFill>
+                  <a:srgbClr val="FFFFFF"/>
+                </a:solidFill>
+                <a:latin typeface="Segoe UI"/>
+              </a:rPr>
+              <a:t>compute vs query: provide vs ask</a:t>
+            </a:r>
+          </a:p>
+        </p:txBody>
+      </p:sp>
+      <p:sp>
+        <p:nvSpPr>
+          <p:cNvPr id="4" name="Rounded Rectangle 3"/>
+          <p:cNvSpPr/>
+          <p:nvPr/>
+        </p:nvSpPr>
+        <p:spPr>
+          <a:xfrm>
+            <a:off x="548640" y="1463040"/>
+            <a:ext cx="11338560" cy="3342132"/>
+          </a:xfrm>
+          <a:prstGeom prst="roundRect">
+            <a:avLst>
+              <a:gd name="adj" fmla="val 3500"/>
+            </a:avLst>
+          </a:prstGeom>
+          <a:solidFill>
+            <a:srgbClr val="081626"/>
+          </a:solidFill>
+          <a:ln w="12700">
+            <a:solidFill>
+              <a:srgbClr val="1E3A55"/>
+            </a:solidFill>
+          </a:ln>
+          <a:effectLst/>
+        </p:spPr>
+        <p:style>
+          <a:lnRef idx="1">
+            <a:schemeClr val="accent1"/>
+          </a:lnRef>
+          <a:fillRef idx="3">
+            <a:schemeClr val="accent1"/>
+          </a:fillRef>
+          <a:effectRef idx="2">
+            <a:schemeClr val="accent1"/>
+          </a:effectRef>
+          <a:fontRef idx="minor">
+            <a:schemeClr val="lt1"/>
+          </a:fontRef>
+        </p:style>
+        <p:txBody>
+          <a:bodyPr rtlCol="0" anchor="ctr"/>
+          <a:lstStyle/>
+          <a:p>
+            <a:pPr algn="ctr"/>
+            <a:endParaRPr/>
+          </a:p>
+        </p:txBody>
+      </p:sp>
+      <p:sp>
+        <p:nvSpPr>
+          <p:cNvPr id="5" name="code:query"/>
+          <p:cNvSpPr txBox="1"/>
+          <p:nvPr/>
+        </p:nvSpPr>
+        <p:spPr>
+          <a:xfrm>
+            <a:off x="731520" y="1645920"/>
+            <a:ext cx="10972800" cy="2976372"/>
+          </a:xfrm>
+          <a:prstGeom prst="rect">
+            <a:avLst/>
+          </a:prstGeom>
+          <a:noFill/>
+        </p:spPr>
+        <p:txBody>
+          <a:bodyPr wrap="none">
+            <a:spAutoFit/>
+          </a:bodyPr>
+          <a:lstStyle/>
+          <a:p>
+            <a:pPr>
+              <a:spcAft>
+                <a:spcPts val="100"/>
+              </a:spcAft>
+            </a:pPr>
+            <a:r>
+              <a:rPr sz="1600">
+                <a:solidFill>
+                  <a:srgbClr val="6A9955"/>
+                </a:solidFill>
+                <a:latin typeface="Consolas"/>
+              </a:rPr>
+              <a:t>// a component PROVIDES a quantity (one overload per tag):</a:t>
+            </a:r>
+          </a:p>
+          <a:p>
+            <a:pPr>
+              <a:spcAft>
+                <a:spcPts val="100"/>
+              </a:spcAft>
+            </a:pPr>
+            <a:r>
+              <a:rPr sz="1600">
+                <a:solidFill>
+                  <a:srgbClr val="D4D4D4"/>
+                </a:solidFill>
+                <a:latin typeface="Consolas"/>
+              </a:rPr>
+              <a:t>T</a:t>
+            </a:r>
+            <a:r>
+              <a:rPr sz="1600">
+                <a:solidFill>
+                  <a:srgbClr val="D4D4D4"/>
+                </a:solidFill>
+                <a:latin typeface="Consolas"/>
+              </a:rPr>
+              <a:t> </a:t>
+            </a:r>
+            <a:r>
+              <a:rPr sz="1600">
+                <a:solidFill>
+                  <a:srgbClr val="D4D4D4"/>
+                </a:solidFill>
+                <a:latin typeface="Consolas"/>
+              </a:rPr>
+              <a:t>compute</a:t>
+            </a:r>
+            <a:r>
+              <a:rPr sz="1600">
+                <a:solidFill>
+                  <a:srgbClr val="D4D4D4"/>
+                </a:solidFill>
+                <a:latin typeface="Consolas"/>
+              </a:rPr>
+              <a:t>(</a:t>
+            </a:r>
+            <a:r>
+              <a:rPr sz="1600">
+                <a:solidFill>
+                  <a:srgbClr val="D4D4D4"/>
+                </a:solidFill>
+                <a:latin typeface="Consolas"/>
+              </a:rPr>
+              <a:t>mass1</a:t>
+            </a:r>
+            <a:r>
+              <a:rPr sz="1600">
+                <a:solidFill>
+                  <a:srgbClr val="D4D4D4"/>
+                </a:solidFill>
+                <a:latin typeface="Consolas"/>
+              </a:rPr>
+              <a:t>:</a:t>
+            </a:r>
+            <a:r>
+              <a:rPr sz="1600">
+                <a:solidFill>
+                  <a:srgbClr val="D4D4D4"/>
+                </a:solidFill>
+                <a:latin typeface="Consolas"/>
+              </a:rPr>
+              <a:t>:</a:t>
+            </a:r>
+            <a:r>
+              <a:rPr sz="1600">
+                <a:solidFill>
+                  <a:srgbClr val="4EC9B0"/>
+                </a:solidFill>
+                <a:latin typeface="Consolas"/>
+              </a:rPr>
+              <a:t>Force</a:t>
+            </a:r>
+            <a:r>
+              <a:rPr sz="1600">
+                <a:solidFill>
+                  <a:srgbClr val="D4D4D4"/>
+                </a:solidFill>
+                <a:latin typeface="Consolas"/>
+              </a:rPr>
+              <a:t>,</a:t>
+            </a:r>
+            <a:r>
+              <a:rPr sz="1600">
+                <a:solidFill>
+                  <a:srgbClr val="D4D4D4"/>
+                </a:solidFill>
+                <a:latin typeface="Consolas"/>
+              </a:rPr>
+              <a:t> </a:t>
+            </a:r>
+            <a:r>
+              <a:rPr sz="1600">
+                <a:solidFill>
+                  <a:srgbClr val="D4D4D4"/>
+                </a:solidFill>
+                <a:latin typeface="Consolas"/>
+              </a:rPr>
+              <a:t>std</a:t>
+            </a:r>
+            <a:r>
+              <a:rPr sz="1600">
+                <a:solidFill>
+                  <a:srgbClr val="D4D4D4"/>
+                </a:solidFill>
+                <a:latin typeface="Consolas"/>
+              </a:rPr>
+              <a:t>:</a:t>
+            </a:r>
+            <a:r>
+              <a:rPr sz="1600">
+                <a:solidFill>
+                  <a:srgbClr val="D4D4D4"/>
+                </a:solidFill>
+                <a:latin typeface="Consolas"/>
+              </a:rPr>
+              <a:t>:</a:t>
+            </a:r>
+            <a:r>
+              <a:rPr sz="1600">
+                <a:solidFill>
+                  <a:srgbClr val="D4D4D4"/>
+                </a:solidFill>
+                <a:latin typeface="Consolas"/>
+              </a:rPr>
+              <a:t>span</a:t>
+            </a:r>
+            <a:r>
+              <a:rPr sz="1600">
+                <a:solidFill>
+                  <a:srgbClr val="D4D4D4"/>
+                </a:solidFill>
+                <a:latin typeface="Consolas"/>
+              </a:rPr>
+              <a:t>&lt;</a:t>
+            </a:r>
+            <a:r>
+              <a:rPr sz="1600">
+                <a:solidFill>
+                  <a:srgbClr val="569CD6"/>
+                </a:solidFill>
+                <a:latin typeface="Consolas"/>
+              </a:rPr>
+              <a:t>const</a:t>
+            </a:r>
+            <a:r>
+              <a:rPr sz="1600">
+                <a:solidFill>
+                  <a:srgbClr val="D4D4D4"/>
+                </a:solidFill>
+                <a:latin typeface="Consolas"/>
+              </a:rPr>
+              <a:t> </a:t>
+            </a:r>
+            <a:r>
+              <a:rPr sz="1600">
+                <a:solidFill>
+                  <a:srgbClr val="D4D4D4"/>
+                </a:solidFill>
+                <a:latin typeface="Consolas"/>
+              </a:rPr>
+              <a:t>T</a:t>
+            </a:r>
+            <a:r>
+              <a:rPr sz="1600">
+                <a:solidFill>
+                  <a:srgbClr val="D4D4D4"/>
+                </a:solidFill>
+                <a:latin typeface="Consolas"/>
+              </a:rPr>
+              <a:t>&gt;</a:t>
+            </a:r>
+            <a:r>
+              <a:rPr sz="1600">
+                <a:solidFill>
+                  <a:srgbClr val="D4D4D4"/>
+                </a:solidFill>
+                <a:latin typeface="Consolas"/>
+              </a:rPr>
+              <a:t> </a:t>
+            </a:r>
+            <a:r>
+              <a:rPr sz="1600">
+                <a:solidFill>
+                  <a:srgbClr val="D4D4D4"/>
+                </a:solidFill>
+                <a:latin typeface="Consolas"/>
+              </a:rPr>
+              <a:t>s</a:t>
+            </a:r>
+            <a:r>
+              <a:rPr sz="1600">
+                <a:solidFill>
+                  <a:srgbClr val="D4D4D4"/>
+                </a:solidFill>
+                <a:latin typeface="Consolas"/>
+              </a:rPr>
+              <a:t>,</a:t>
+            </a:r>
+            <a:r>
+              <a:rPr sz="1600">
+                <a:solidFill>
+                  <a:srgbClr val="D4D4D4"/>
+                </a:solidFill>
+                <a:latin typeface="Consolas"/>
+              </a:rPr>
+              <a:t> </a:t>
+            </a:r>
+            <a:r>
+              <a:rPr sz="1600">
+                <a:solidFill>
+                  <a:srgbClr val="569CD6"/>
+                </a:solidFill>
+                <a:latin typeface="Consolas"/>
+              </a:rPr>
+              <a:t>const</a:t>
+            </a:r>
+            <a:r>
+              <a:rPr sz="1600">
+                <a:solidFill>
+                  <a:srgbClr val="D4D4D4"/>
+                </a:solidFill>
+                <a:latin typeface="Consolas"/>
+              </a:rPr>
+              <a:t> </a:t>
+            </a:r>
+            <a:r>
+              <a:rPr sz="1600">
+                <a:solidFill>
+                  <a:srgbClr val="4EC9B0"/>
+                </a:solidFill>
+                <a:latin typeface="Consolas"/>
+              </a:rPr>
+              <a:t>Registry</a:t>
+            </a:r>
+            <a:r>
+              <a:rPr sz="1600">
+                <a:solidFill>
+                  <a:srgbClr val="D4D4D4"/>
+                </a:solidFill>
+                <a:latin typeface="Consolas"/>
+              </a:rPr>
+              <a:t>&amp;</a:t>
+            </a:r>
+            <a:r>
+              <a:rPr sz="1600">
+                <a:solidFill>
+                  <a:srgbClr val="D4D4D4"/>
+                </a:solidFill>
+                <a:latin typeface="Consolas"/>
+              </a:rPr>
+              <a:t>)</a:t>
+            </a:r>
+            <a:r>
+              <a:rPr sz="1600">
+                <a:solidFill>
+                  <a:srgbClr val="D4D4D4"/>
+                </a:solidFill>
+                <a:latin typeface="Consolas"/>
+              </a:rPr>
+              <a:t> </a:t>
+            </a:r>
+            <a:r>
+              <a:rPr sz="1600">
+                <a:solidFill>
+                  <a:srgbClr val="569CD6"/>
+                </a:solidFill>
+                <a:latin typeface="Consolas"/>
+              </a:rPr>
+              <a:t>const</a:t>
+            </a:r>
+            <a:r>
+              <a:rPr sz="1600">
+                <a:solidFill>
+                  <a:srgbClr val="D4D4D4"/>
+                </a:solidFill>
+                <a:latin typeface="Consolas"/>
+              </a:rPr>
+              <a:t>;</a:t>
+            </a:r>
+          </a:p>
+          <a:p>
+            <a:pPr>
+              <a:spcAft>
+                <a:spcPts val="100"/>
+              </a:spcAft>
+            </a:pPr>
+            <a:r>
+              <a:rPr sz="1600">
+                <a:latin typeface="Consolas"/>
+              </a:rPr>
+              <a:t> </a:t>
+            </a:r>
+          </a:p>
+          <a:p>
+            <a:pPr>
+              <a:spcAft>
+                <a:spcPts val="100"/>
+              </a:spcAft>
+            </a:pPr>
+            <a:r>
+              <a:rPr sz="1600">
+                <a:solidFill>
+                  <a:srgbClr val="6A9955"/>
+                </a:solidFill>
+                <a:latin typeface="Consolas"/>
+              </a:rPr>
+              <a:t>// anyone ASKS for one, by tag — component or driver:</a:t>
+            </a:r>
+          </a:p>
+          <a:p>
+            <a:pPr>
+              <a:spcAft>
+                <a:spcPts val="100"/>
+              </a:spcAft>
+            </a:pPr>
+            <a:r>
+              <a:rPr sz="1600" b="1">
+                <a:solidFill>
+                  <a:srgbClr val="D4D4D4"/>
+                </a:solidFill>
+                <a:latin typeface="Consolas"/>
+              </a:rPr>
+              <a:t>T</a:t>
+            </a:r>
+            <a:r>
+              <a:rPr sz="1600" b="1">
+                <a:solidFill>
+                  <a:srgbClr val="D4D4D4"/>
+                </a:solidFill>
+                <a:latin typeface="Consolas"/>
+              </a:rPr>
+              <a:t> </a:t>
+            </a:r>
+            <a:r>
+              <a:rPr sz="1600" b="1">
+                <a:solidFill>
+                  <a:srgbClr val="D4D4D4"/>
+                </a:solidFill>
+                <a:latin typeface="Consolas"/>
+              </a:rPr>
+              <a:t>f</a:t>
+            </a:r>
+            <a:r>
+              <a:rPr sz="1600" b="1">
+                <a:solidFill>
+                  <a:srgbClr val="D4D4D4"/>
+                </a:solidFill>
+                <a:latin typeface="Consolas"/>
+              </a:rPr>
+              <a:t> </a:t>
+            </a:r>
+            <a:r>
+              <a:rPr sz="1600" b="1">
+                <a:solidFill>
+                  <a:srgbClr val="D4D4D4"/>
+                </a:solidFill>
+                <a:latin typeface="Consolas"/>
+              </a:rPr>
+              <a:t>=</a:t>
+            </a:r>
+            <a:r>
+              <a:rPr sz="1600" b="1">
+                <a:solidFill>
+                  <a:srgbClr val="D4D4D4"/>
+                </a:solidFill>
+                <a:latin typeface="Consolas"/>
+              </a:rPr>
+              <a:t> </a:t>
+            </a:r>
+            <a:r>
+              <a:rPr sz="1600" b="1">
+                <a:solidFill>
+                  <a:srgbClr val="D4D4D4"/>
+                </a:solidFill>
+                <a:latin typeface="Consolas"/>
+              </a:rPr>
+              <a:t>query</a:t>
+            </a:r>
+            <a:r>
+              <a:rPr sz="1600" b="1">
+                <a:solidFill>
+                  <a:srgbClr val="D4D4D4"/>
+                </a:solidFill>
+                <a:latin typeface="Consolas"/>
+              </a:rPr>
+              <a:t>&lt;</a:t>
+            </a:r>
+            <a:r>
+              <a:rPr sz="1600" b="1">
+                <a:solidFill>
+                  <a:srgbClr val="D4D4D4"/>
+                </a:solidFill>
+                <a:latin typeface="Consolas"/>
+              </a:rPr>
+              <a:t>mass1</a:t>
+            </a:r>
+            <a:r>
+              <a:rPr sz="1600" b="1">
+                <a:solidFill>
+                  <a:srgbClr val="D4D4D4"/>
+                </a:solidFill>
+                <a:latin typeface="Consolas"/>
+              </a:rPr>
+              <a:t>:</a:t>
+            </a:r>
+            <a:r>
+              <a:rPr sz="1600" b="1">
+                <a:solidFill>
+                  <a:srgbClr val="D4D4D4"/>
+                </a:solidFill>
+                <a:latin typeface="Consolas"/>
+              </a:rPr>
+              <a:t>:</a:t>
+            </a:r>
+            <a:r>
+              <a:rPr sz="1600" b="1">
+                <a:solidFill>
+                  <a:srgbClr val="4EC9B0"/>
+                </a:solidFill>
+                <a:latin typeface="Consolas"/>
+              </a:rPr>
+              <a:t>Force</a:t>
+            </a:r>
+            <a:r>
+              <a:rPr sz="1600" b="1">
+                <a:solidFill>
+                  <a:srgbClr val="D4D4D4"/>
+                </a:solidFill>
+                <a:latin typeface="Consolas"/>
+              </a:rPr>
+              <a:t>&gt;</a:t>
+            </a:r>
+            <a:r>
+              <a:rPr sz="1600" b="1">
+                <a:solidFill>
+                  <a:srgbClr val="D4D4D4"/>
+                </a:solidFill>
+                <a:latin typeface="Consolas"/>
+              </a:rPr>
+              <a:t>(</a:t>
+            </a:r>
+            <a:r>
+              <a:rPr sz="1600" b="1">
+                <a:solidFill>
+                  <a:srgbClr val="D4D4D4"/>
+                </a:solidFill>
+                <a:latin typeface="Consolas"/>
+              </a:rPr>
+              <a:t>registry</a:t>
+            </a:r>
+            <a:r>
+              <a:rPr sz="1600" b="1">
+                <a:solidFill>
+                  <a:srgbClr val="D4D4D4"/>
+                </a:solidFill>
+                <a:latin typeface="Consolas"/>
+              </a:rPr>
+              <a:t>,</a:t>
+            </a:r>
+            <a:r>
+              <a:rPr sz="1600" b="1">
+                <a:solidFill>
+                  <a:srgbClr val="D4D4D4"/>
+                </a:solidFill>
+                <a:latin typeface="Consolas"/>
+              </a:rPr>
+              <a:t> </a:t>
+            </a:r>
+            <a:r>
+              <a:rPr sz="1600" b="1">
+                <a:solidFill>
+                  <a:srgbClr val="D4D4D4"/>
+                </a:solidFill>
+                <a:latin typeface="Consolas"/>
+              </a:rPr>
+              <a:t>state</a:t>
+            </a:r>
+            <a:r>
+              <a:rPr sz="1600" b="1">
+                <a:solidFill>
+                  <a:srgbClr val="D4D4D4"/>
+                </a:solidFill>
+                <a:latin typeface="Consolas"/>
+              </a:rPr>
+              <a:t>)</a:t>
+            </a:r>
+            <a:r>
+              <a:rPr sz="1600" b="1">
+                <a:solidFill>
+                  <a:srgbClr val="D4D4D4"/>
+                </a:solidFill>
+                <a:latin typeface="Consolas"/>
+              </a:rPr>
+              <a:t>;</a:t>
+            </a:r>
+          </a:p>
+          <a:p>
+            <a:pPr>
+              <a:spcAft>
+                <a:spcPts val="100"/>
+              </a:spcAft>
+            </a:pPr>
+            <a:r>
+              <a:rPr sz="1600">
+                <a:latin typeface="Consolas"/>
+              </a:rPr>
+              <a:t> </a:t>
+            </a:r>
+          </a:p>
+          <a:p>
+            <a:pPr>
+              <a:spcAft>
+                <a:spcPts val="100"/>
+              </a:spcAft>
+            </a:pPr>
+            <a:r>
+              <a:rPr sz="1600">
+                <a:solidFill>
+                  <a:srgbClr val="6A9955"/>
+                </a:solidFill>
+                <a:latin typeface="Consolas"/>
+              </a:rPr>
+              <a:t>// query is just the registry call with friendlier syntax:</a:t>
+            </a:r>
+          </a:p>
+          <a:p>
+            <a:pPr>
+              <a:spcAft>
+                <a:spcPts val="100"/>
+              </a:spcAft>
+            </a:pPr>
+            <a:r>
+              <a:rPr sz="1600">
+                <a:solidFill>
+                  <a:srgbClr val="569CD6"/>
+                </a:solidFill>
+                <a:latin typeface="Consolas"/>
+              </a:rPr>
+              <a:t>template</a:t>
+            </a:r>
+            <a:r>
+              <a:rPr sz="1600">
+                <a:solidFill>
+                  <a:srgbClr val="D4D4D4"/>
+                </a:solidFill>
+                <a:latin typeface="Consolas"/>
+              </a:rPr>
+              <a:t>&lt;</a:t>
+            </a:r>
+            <a:r>
+              <a:rPr sz="1600">
+                <a:solidFill>
+                  <a:srgbClr val="4EC9B0"/>
+                </a:solidFill>
+                <a:latin typeface="Consolas"/>
+              </a:rPr>
+              <a:t>StateTagConcept</a:t>
+            </a:r>
+            <a:r>
+              <a:rPr sz="1600">
+                <a:solidFill>
+                  <a:srgbClr val="D4D4D4"/>
+                </a:solidFill>
+                <a:latin typeface="Consolas"/>
+              </a:rPr>
+              <a:t> </a:t>
+            </a:r>
+            <a:r>
+              <a:rPr sz="1600">
+                <a:solidFill>
+                  <a:srgbClr val="4EC9B0"/>
+                </a:solidFill>
+                <a:latin typeface="Consolas"/>
+              </a:rPr>
+              <a:t>Tag</a:t>
+            </a:r>
+            <a:r>
+              <a:rPr sz="1600">
+                <a:solidFill>
+                  <a:srgbClr val="D4D4D4"/>
+                </a:solidFill>
+                <a:latin typeface="Consolas"/>
+              </a:rPr>
+              <a:t>,</a:t>
+            </a:r>
+            <a:r>
+              <a:rPr sz="1600">
+                <a:solidFill>
+                  <a:srgbClr val="D4D4D4"/>
+                </a:solidFill>
+                <a:latin typeface="Consolas"/>
+              </a:rPr>
+              <a:t> </a:t>
+            </a:r>
+            <a:r>
+              <a:rPr sz="1600">
+                <a:solidFill>
+                  <a:srgbClr val="569CD6"/>
+                </a:solidFill>
+                <a:latin typeface="Consolas"/>
+              </a:rPr>
+              <a:t>typename</a:t>
+            </a:r>
+            <a:r>
+              <a:rPr sz="1600">
+                <a:solidFill>
+                  <a:srgbClr val="D4D4D4"/>
+                </a:solidFill>
+                <a:latin typeface="Consolas"/>
+              </a:rPr>
+              <a:t> </a:t>
+            </a:r>
+            <a:r>
+              <a:rPr sz="1600">
+                <a:solidFill>
+                  <a:srgbClr val="4EC9B0"/>
+                </a:solidFill>
+                <a:latin typeface="Consolas"/>
+              </a:rPr>
+              <a:t>Registry</a:t>
+            </a:r>
+            <a:r>
+              <a:rPr sz="1600">
+                <a:solidFill>
+                  <a:srgbClr val="D4D4D4"/>
+                </a:solidFill>
+                <a:latin typeface="Consolas"/>
+              </a:rPr>
+              <a:t>,</a:t>
+            </a:r>
+            <a:r>
+              <a:rPr sz="1600">
+                <a:solidFill>
+                  <a:srgbClr val="D4D4D4"/>
+                </a:solidFill>
+                <a:latin typeface="Consolas"/>
+              </a:rPr>
+              <a:t> </a:t>
+            </a:r>
+            <a:r>
+              <a:rPr sz="1600">
+                <a:solidFill>
+                  <a:srgbClr val="569CD6"/>
+                </a:solidFill>
+                <a:latin typeface="Consolas"/>
+              </a:rPr>
+              <a:t>typename</a:t>
+            </a:r>
+            <a:r>
+              <a:rPr sz="1600">
+                <a:solidFill>
+                  <a:srgbClr val="D4D4D4"/>
+                </a:solidFill>
+                <a:latin typeface="Consolas"/>
+              </a:rPr>
+              <a:t> </a:t>
+            </a:r>
+            <a:r>
+              <a:rPr sz="1600">
+                <a:solidFill>
+                  <a:srgbClr val="4EC9B0"/>
+                </a:solidFill>
+                <a:latin typeface="Consolas"/>
+              </a:rPr>
+              <a:t>T</a:t>
+            </a:r>
+            <a:r>
+              <a:rPr sz="1600">
+                <a:solidFill>
+                  <a:srgbClr val="D4D4D4"/>
+                </a:solidFill>
+                <a:latin typeface="Consolas"/>
+              </a:rPr>
+              <a:t>&gt;</a:t>
+            </a:r>
+          </a:p>
+          <a:p>
+            <a:pPr>
+              <a:spcAft>
+                <a:spcPts val="100"/>
+              </a:spcAft>
+            </a:pPr>
+            <a:r>
+              <a:rPr sz="1600">
+                <a:solidFill>
+                  <a:srgbClr val="569CD6"/>
+                </a:solidFill>
+                <a:latin typeface="Consolas"/>
+              </a:rPr>
+              <a:t>auto</a:t>
+            </a:r>
+            <a:r>
+              <a:rPr sz="1600">
+                <a:solidFill>
+                  <a:srgbClr val="D4D4D4"/>
+                </a:solidFill>
+                <a:latin typeface="Consolas"/>
+              </a:rPr>
+              <a:t> </a:t>
+            </a:r>
+            <a:r>
+              <a:rPr sz="1600">
+                <a:solidFill>
+                  <a:srgbClr val="D4D4D4"/>
+                </a:solidFill>
+                <a:latin typeface="Consolas"/>
+              </a:rPr>
+              <a:t>query</a:t>
+            </a:r>
+            <a:r>
+              <a:rPr sz="1600">
+                <a:solidFill>
+                  <a:srgbClr val="D4D4D4"/>
+                </a:solidFill>
+                <a:latin typeface="Consolas"/>
+              </a:rPr>
+              <a:t>(</a:t>
+            </a:r>
+            <a:r>
+              <a:rPr sz="1600">
+                <a:solidFill>
+                  <a:srgbClr val="569CD6"/>
+                </a:solidFill>
+                <a:latin typeface="Consolas"/>
+              </a:rPr>
+              <a:t>const</a:t>
+            </a:r>
+            <a:r>
+              <a:rPr sz="1600">
+                <a:solidFill>
+                  <a:srgbClr val="D4D4D4"/>
+                </a:solidFill>
+                <a:latin typeface="Consolas"/>
+              </a:rPr>
+              <a:t> </a:t>
+            </a:r>
+            <a:r>
+              <a:rPr sz="1600">
+                <a:solidFill>
+                  <a:srgbClr val="4EC9B0"/>
+                </a:solidFill>
+                <a:latin typeface="Consolas"/>
+              </a:rPr>
+              <a:t>Registry</a:t>
+            </a:r>
+            <a:r>
+              <a:rPr sz="1600">
+                <a:solidFill>
+                  <a:srgbClr val="D4D4D4"/>
+                </a:solidFill>
+                <a:latin typeface="Consolas"/>
+              </a:rPr>
+              <a:t>&amp;</a:t>
+            </a:r>
+            <a:r>
+              <a:rPr sz="1600">
+                <a:solidFill>
+                  <a:srgbClr val="D4D4D4"/>
+                </a:solidFill>
+                <a:latin typeface="Consolas"/>
+              </a:rPr>
+              <a:t> </a:t>
+            </a:r>
+            <a:r>
+              <a:rPr sz="1600">
+                <a:solidFill>
+                  <a:srgbClr val="D4D4D4"/>
+                </a:solidFill>
+                <a:latin typeface="Consolas"/>
+              </a:rPr>
+              <a:t>reg</a:t>
+            </a:r>
+            <a:r>
+              <a:rPr sz="1600">
+                <a:solidFill>
+                  <a:srgbClr val="D4D4D4"/>
+                </a:solidFill>
+                <a:latin typeface="Consolas"/>
+              </a:rPr>
+              <a:t>,</a:t>
+            </a:r>
+            <a:r>
+              <a:rPr sz="1600">
+                <a:solidFill>
+                  <a:srgbClr val="D4D4D4"/>
+                </a:solidFill>
+                <a:latin typeface="Consolas"/>
+              </a:rPr>
+              <a:t> </a:t>
+            </a:r>
+            <a:r>
+              <a:rPr sz="1600">
+                <a:solidFill>
+                  <a:srgbClr val="D4D4D4"/>
+                </a:solidFill>
+                <a:latin typeface="Consolas"/>
+              </a:rPr>
+              <a:t>std</a:t>
+            </a:r>
+            <a:r>
+              <a:rPr sz="1600">
+                <a:solidFill>
+                  <a:srgbClr val="D4D4D4"/>
+                </a:solidFill>
+                <a:latin typeface="Consolas"/>
+              </a:rPr>
+              <a:t>:</a:t>
+            </a:r>
+            <a:r>
+              <a:rPr sz="1600">
+                <a:solidFill>
+                  <a:srgbClr val="D4D4D4"/>
+                </a:solidFill>
+                <a:latin typeface="Consolas"/>
+              </a:rPr>
+              <a:t>:</a:t>
+            </a:r>
+            <a:r>
+              <a:rPr sz="1600">
+                <a:solidFill>
+                  <a:srgbClr val="D4D4D4"/>
+                </a:solidFill>
+                <a:latin typeface="Consolas"/>
+              </a:rPr>
+              <a:t>span</a:t>
+            </a:r>
+            <a:r>
+              <a:rPr sz="1600">
+                <a:solidFill>
+                  <a:srgbClr val="D4D4D4"/>
+                </a:solidFill>
+                <a:latin typeface="Consolas"/>
+              </a:rPr>
+              <a:t>&lt;</a:t>
+            </a:r>
+            <a:r>
+              <a:rPr sz="1600">
+                <a:solidFill>
+                  <a:srgbClr val="569CD6"/>
+                </a:solidFill>
+                <a:latin typeface="Consolas"/>
+              </a:rPr>
+              <a:t>const</a:t>
+            </a:r>
+            <a:r>
+              <a:rPr sz="1600">
+                <a:solidFill>
+                  <a:srgbClr val="D4D4D4"/>
+                </a:solidFill>
+                <a:latin typeface="Consolas"/>
+              </a:rPr>
+              <a:t> </a:t>
+            </a:r>
+            <a:r>
+              <a:rPr sz="1600">
+                <a:solidFill>
+                  <a:srgbClr val="D4D4D4"/>
+                </a:solidFill>
+                <a:latin typeface="Consolas"/>
+              </a:rPr>
+              <a:t>T</a:t>
+            </a:r>
+            <a:r>
+              <a:rPr sz="1600">
+                <a:solidFill>
+                  <a:srgbClr val="D4D4D4"/>
+                </a:solidFill>
+                <a:latin typeface="Consolas"/>
+              </a:rPr>
+              <a:t>&gt;</a:t>
+            </a:r>
+            <a:r>
+              <a:rPr sz="1600">
+                <a:solidFill>
+                  <a:srgbClr val="D4D4D4"/>
+                </a:solidFill>
+                <a:latin typeface="Consolas"/>
+              </a:rPr>
+              <a:t> </a:t>
+            </a:r>
+            <a:r>
+              <a:rPr sz="1600">
+                <a:solidFill>
+                  <a:srgbClr val="D4D4D4"/>
+                </a:solidFill>
+                <a:latin typeface="Consolas"/>
+              </a:rPr>
+              <a:t>s</a:t>
+            </a:r>
+            <a:r>
+              <a:rPr sz="1600">
+                <a:solidFill>
+                  <a:srgbClr val="D4D4D4"/>
+                </a:solidFill>
+                <a:latin typeface="Consolas"/>
+              </a:rPr>
+              <a:t>)</a:t>
+            </a:r>
+            <a:r>
+              <a:rPr sz="1600">
+                <a:solidFill>
+                  <a:srgbClr val="D4D4D4"/>
+                </a:solidFill>
+                <a:latin typeface="Consolas"/>
+              </a:rPr>
+              <a:t> </a:t>
+            </a:r>
+            <a:r>
+              <a:rPr sz="1600">
+                <a:solidFill>
+                  <a:srgbClr val="D4D4D4"/>
+                </a:solidFill>
+                <a:latin typeface="Consolas"/>
+              </a:rPr>
+              <a:t>{</a:t>
+            </a:r>
+          </a:p>
+          <a:p>
+            <a:pPr>
+              <a:spcAft>
+                <a:spcPts val="100"/>
+              </a:spcAft>
+            </a:pPr>
+            <a:r>
+              <a:rPr sz="1600" b="1">
+                <a:solidFill>
+                  <a:srgbClr val="D4D4D4"/>
+                </a:solidFill>
+                <a:latin typeface="Consolas"/>
+              </a:rPr>
+              <a:t>    </a:t>
+            </a:r>
+            <a:r>
+              <a:rPr sz="1600" b="1">
+                <a:solidFill>
+                  <a:srgbClr val="569CD6"/>
+                </a:solidFill>
+                <a:latin typeface="Consolas"/>
+              </a:rPr>
+              <a:t>return</a:t>
+            </a:r>
+            <a:r>
+              <a:rPr sz="1600" b="1">
+                <a:solidFill>
+                  <a:srgbClr val="D4D4D4"/>
+                </a:solidFill>
+                <a:latin typeface="Consolas"/>
+              </a:rPr>
+              <a:t> </a:t>
+            </a:r>
+            <a:r>
+              <a:rPr sz="1600" b="1">
+                <a:solidFill>
+                  <a:srgbClr val="D4D4D4"/>
+                </a:solidFill>
+                <a:latin typeface="Consolas"/>
+              </a:rPr>
+              <a:t>reg</a:t>
+            </a:r>
+            <a:r>
+              <a:rPr sz="1600" b="1">
+                <a:solidFill>
+                  <a:srgbClr val="D4D4D4"/>
+                </a:solidFill>
+                <a:latin typeface="Consolas"/>
+              </a:rPr>
+              <a:t>.</a:t>
+            </a:r>
+            <a:r>
+              <a:rPr sz="1600" b="1">
+                <a:solidFill>
+                  <a:srgbClr val="D4D4D4"/>
+                </a:solidFill>
+                <a:latin typeface="Consolas"/>
+              </a:rPr>
+              <a:t>computeFunction</a:t>
+            </a:r>
+            <a:r>
+              <a:rPr sz="1600" b="1">
+                <a:solidFill>
+                  <a:srgbClr val="D4D4D4"/>
+                </a:solidFill>
+                <a:latin typeface="Consolas"/>
+              </a:rPr>
+              <a:t>&lt;</a:t>
+            </a:r>
+            <a:r>
+              <a:rPr sz="1600" b="1">
+                <a:solidFill>
+                  <a:srgbClr val="4EC9B0"/>
+                </a:solidFill>
+                <a:latin typeface="Consolas"/>
+              </a:rPr>
+              <a:t>Tag</a:t>
+            </a:r>
+            <a:r>
+              <a:rPr sz="1600" b="1">
+                <a:solidFill>
+                  <a:srgbClr val="D4D4D4"/>
+                </a:solidFill>
+                <a:latin typeface="Consolas"/>
+              </a:rPr>
+              <a:t>&gt;</a:t>
+            </a:r>
+            <a:r>
+              <a:rPr sz="1600" b="1">
+                <a:solidFill>
+                  <a:srgbClr val="D4D4D4"/>
+                </a:solidFill>
+                <a:latin typeface="Consolas"/>
+              </a:rPr>
+              <a:t>(</a:t>
+            </a:r>
+            <a:r>
+              <a:rPr sz="1600" b="1">
+                <a:solidFill>
+                  <a:srgbClr val="D4D4D4"/>
+                </a:solidFill>
+                <a:latin typeface="Consolas"/>
+              </a:rPr>
+              <a:t>s</a:t>
+            </a:r>
+            <a:r>
+              <a:rPr sz="1600" b="1">
+                <a:solidFill>
+                  <a:srgbClr val="D4D4D4"/>
+                </a:solidFill>
+                <a:latin typeface="Consolas"/>
+              </a:rPr>
+              <a:t>)</a:t>
+            </a:r>
+            <a:r>
+              <a:rPr sz="1600" b="1">
+                <a:solidFill>
+                  <a:srgbClr val="D4D4D4"/>
+                </a:solidFill>
+                <a:latin typeface="Consolas"/>
+              </a:rPr>
+              <a:t>;</a:t>
+            </a:r>
+            <a:r>
+              <a:rPr sz="1600" b="1">
+                <a:solidFill>
+                  <a:srgbClr val="D4D4D4"/>
+                </a:solidFill>
+                <a:latin typeface="Consolas"/>
+              </a:rPr>
+              <a:t>   </a:t>
+            </a:r>
+            <a:r>
+              <a:rPr sz="1600" b="1">
+                <a:solidFill>
+                  <a:srgbClr val="6A9955"/>
+                </a:solidFill>
+                <a:latin typeface="Consolas"/>
+              </a:rPr>
+              <a:t>// find provider -&gt; provider.compute(...)</a:t>
+            </a:r>
+          </a:p>
+          <a:p>
+            <a:pPr>
+              <a:spcAft>
+                <a:spcPts val="100"/>
+              </a:spcAft>
+            </a:pPr>
+            <a:r>
+              <a:rPr sz="1600">
+                <a:solidFill>
+                  <a:srgbClr val="D4D4D4"/>
+                </a:solidFill>
+                <a:latin typeface="Consolas"/>
+              </a:rPr>
+              <a:t>}</a:t>
+            </a:r>
+          </a:p>
+        </p:txBody>
+      </p:sp>
+      <p:sp>
+        <p:nvSpPr>
+          <p:cNvPr id="7" name="TextBox 6"/>
+          <p:cNvSpPr txBox="1"/>
+          <p:nvPr/>
+        </p:nvSpPr>
+        <p:spPr>
+          <a:xfrm>
+            <a:off x="411480" y="6446520"/>
+            <a:ext cx="10058400" cy="320040"/>
+          </a:xfrm>
+          <a:prstGeom prst="rect">
+            <a:avLst/>
+          </a:prstGeom>
+          <a:noFill/>
+        </p:spPr>
+        <p:txBody>
+          <a:bodyPr wrap="none">
+            <a:spAutoFit/>
+          </a:bodyPr>
+          <a:lstStyle/>
+          <a:p>
+            <a:r>
+              <a:rPr sz="1000">
+                <a:solidFill>
+                  <a:srgbClr val="8CA3B8"/>
+                </a:solidFill>
+                <a:latin typeface="Segoe UI"/>
+              </a:rPr>
+              <a:t>Separation of Concerns at Zero Cost — ACCU on Sea 2026</a:t>
+            </a:r>
+          </a:p>
+        </p:txBody>
+      </p:sp>
+      <p:sp>
+        <p:nvSpPr>
+          <p:cNvPr id="8" name="TextBox 7"/>
+          <p:cNvSpPr txBox="1"/>
+          <p:nvPr/>
+        </p:nvSpPr>
+        <p:spPr>
+          <a:xfrm>
+            <a:off x="11384280" y="6446520"/>
+            <a:ext cx="548640" cy="320040"/>
+          </a:xfrm>
+          <a:prstGeom prst="rect">
+            <a:avLst/>
+          </a:prstGeom>
+          <a:noFill/>
+        </p:spPr>
+        <p:txBody>
+          <a:bodyPr wrap="none">
+            <a:spAutoFit/>
+          </a:bodyPr>
+          <a:lstStyle/>
+          <a:p>
+            <a:pPr algn="r"/>
+            <a:r>
+              <a:rPr sz="1000">
+                <a:solidFill>
+                  <a:srgbClr val="8CA3B8"/>
+                </a:solidFill>
+                <a:latin typeface="Segoe UI"/>
+              </a:rPr>
+              <a:t>25</a:t>
             </a:r>
           </a:p>
         </p:txBody>

</xml_diff>

<commit_message>
Improve the assembly slide and the Numbers slide
Assembly slide ("The abstraction compiles away"): removed the side bullets,
widened the asm to full width at 16pt, and condensed the punchline into a
single green takeaway line below the code (0 calls / 0 jumps / 0 vtables).

Numbers slide: restyled the "1000x faster than OO C#" line to match the other
two headline stats — a big bold coloured "1000×" (green) + small description,
instead of flat grey text.

PDF regenerated.

Co-Authored-By: Claude Opus 4.8 (1M context) <noreply@anthropic.com>
</commit_message>
<xml_diff>
--- a/slides/ACCU-Separation-of-Concerns-at-Zero-Cost.pptx
+++ b/slides/ACCU-Separation-of-Concerns-at-Zero-Cost.pptx
@@ -19882,8 +19882,8 @@
         </p:nvSpPr>
         <p:spPr>
           <a:xfrm>
-            <a:off x="548640" y="1463040"/>
-            <a:ext cx="6035040" cy="3794760"/>
+            <a:off x="548640" y="1371600"/>
+            <a:ext cx="11338560" cy="4123943"/>
           </a:xfrm>
           <a:prstGeom prst="roundRect">
             <a:avLst>
@@ -19931,8 +19931,8 @@
         </p:nvSpPr>
         <p:spPr>
           <a:xfrm>
-            <a:off x="713232" y="1627632"/>
-            <a:ext cx="5705856" cy="3465576"/>
+            <a:off x="731520" y="1554480"/>
+            <a:ext cx="10972800" cy="3758183"/>
           </a:xfrm>
           <a:prstGeom prst="rect">
             <a:avLst/>
@@ -19951,7 +19951,7 @@
               </a:spcAft>
             </a:pPr>
             <a:r>
-              <a:rPr sz="1250">
+              <a:rPr sz="1600">
                 <a:solidFill>
                   <a:srgbClr val="DCDCAA"/>
                 </a:solidFill>
@@ -19960,7 +19960,7 @@
               <a:t>energy_sopot</a:t>
             </a:r>
             <a:r>
-              <a:rPr sz="1250">
+              <a:rPr sz="1600">
                 <a:solidFill>
                   <a:srgbClr val="D4D4D4"/>
                 </a:solidFill>
@@ -19969,7 +19969,7 @@
               <a:t>(span&lt;const double&gt;):     </a:t>
             </a:r>
             <a:r>
-              <a:rPr sz="1250">
+              <a:rPr sz="1600">
                 <a:solidFill>
                   <a:srgbClr val="6A9955"/>
                 </a:solidFill>
@@ -19985,7 +19985,7 @@
               </a:spcAft>
             </a:pPr>
             <a:r>
-              <a:rPr sz="1250">
+              <a:rPr sz="1600">
                 <a:solidFill>
                   <a:srgbClr val="D4D4D4"/>
                 </a:solidFill>
@@ -19994,7 +19994,7 @@
               <a:t>    </a:t>
             </a:r>
             <a:r>
-              <a:rPr sz="1250">
+              <a:rPr sz="1600">
                 <a:solidFill>
                   <a:srgbClr val="DCDCAA"/>
                 </a:solidFill>
@@ -20003,7 +20003,7 @@
               <a:t>mov</a:t>
             </a:r>
             <a:r>
-              <a:rPr sz="1250">
+              <a:rPr sz="1600">
                 <a:solidFill>
                   <a:srgbClr val="D4D4D4"/>
                 </a:solidFill>
@@ -20012,7 +20012,7 @@
               <a:t>   r10, [sys+</a:t>
             </a:r>
             <a:r>
-              <a:rPr sz="1250">
+              <a:rPr sz="1600">
                 <a:solidFill>
                   <a:srgbClr val="B5CEA8"/>
                 </a:solidFill>
@@ -20021,7 +20021,7 @@
               <a:t>272</a:t>
             </a:r>
             <a:r>
-              <a:rPr sz="1250">
+              <a:rPr sz="1600">
                 <a:solidFill>
                   <a:srgbClr val="D4D4D4"/>
                 </a:solidFill>
@@ -20037,7 +20037,7 @@
               </a:spcAft>
             </a:pPr>
             <a:r>
-              <a:rPr sz="1250">
+              <a:rPr sz="1600">
                 <a:solidFill>
                   <a:srgbClr val="D4D4D4"/>
                 </a:solidFill>
@@ -20046,7 +20046,7 @@
               <a:t>    </a:t>
             </a:r>
             <a:r>
-              <a:rPr sz="1250">
+              <a:rPr sz="1600">
                 <a:solidFill>
                   <a:srgbClr val="DCDCAA"/>
                 </a:solidFill>
@@ -20055,7 +20055,7 @@
               <a:t>movsd</a:t>
             </a:r>
             <a:r>
-              <a:rPr sz="1250">
+              <a:rPr sz="1600">
                 <a:solidFill>
                   <a:srgbClr val="D4D4D4"/>
                 </a:solidFill>
@@ -20064,7 +20064,7 @@
               <a:t> xmm1, [.LC0]        </a:t>
             </a:r>
             <a:r>
-              <a:rPr sz="1250">
+              <a:rPr sz="1600">
                 <a:solidFill>
                   <a:srgbClr val="6A9955"/>
                 </a:solidFill>
@@ -20080,7 +20080,7 @@
               </a:spcAft>
             </a:pPr>
             <a:r>
-              <a:rPr sz="1250">
+              <a:rPr sz="1600">
                 <a:solidFill>
                   <a:srgbClr val="D4D4D4"/>
                 </a:solidFill>
@@ -20089,7 +20089,7 @@
               <a:t>    </a:t>
             </a:r>
             <a:r>
-              <a:rPr sz="1250">
+              <a:rPr sz="1600">
                 <a:solidFill>
                   <a:srgbClr val="DCDCAA"/>
                 </a:solidFill>
@@ -20098,7 +20098,7 @@
               <a:t>mov</a:t>
             </a:r>
             <a:r>
-              <a:rPr sz="1250">
+              <a:rPr sz="1600">
                 <a:solidFill>
                   <a:srgbClr val="D4D4D4"/>
                 </a:solidFill>
@@ -20114,7 +20114,7 @@
               </a:spcAft>
             </a:pPr>
             <a:r>
-              <a:rPr sz="1250">
+              <a:rPr sz="1600">
                 <a:solidFill>
                   <a:srgbClr val="D4D4D4"/>
                 </a:solidFill>
@@ -20123,7 +20123,7 @@
               <a:t>    </a:t>
             </a:r>
             <a:r>
-              <a:rPr sz="1250">
+              <a:rPr sz="1600">
                 <a:solidFill>
                   <a:srgbClr val="DCDCAA"/>
                 </a:solidFill>
@@ -20132,7 +20132,7 @@
               <a:t>movsd</a:t>
             </a:r>
             <a:r>
-              <a:rPr sz="1250">
+              <a:rPr sz="1600">
                 <a:solidFill>
                   <a:srgbClr val="D4D4D4"/>
                 </a:solidFill>
@@ -20141,7 +20141,7 @@
               <a:t> xmm0, [r10+</a:t>
             </a:r>
             <a:r>
-              <a:rPr sz="1250">
+              <a:rPr sz="1600">
                 <a:solidFill>
                   <a:srgbClr val="B5CEA8"/>
                 </a:solidFill>
@@ -20150,7 +20150,7 @@
               <a:t>8</a:t>
             </a:r>
             <a:r>
-              <a:rPr sz="1250">
+              <a:rPr sz="1600">
                 <a:solidFill>
                   <a:srgbClr val="D4D4D4"/>
                 </a:solidFill>
@@ -20159,7 +20159,7 @@
               <a:t>]       </a:t>
             </a:r>
             <a:r>
-              <a:rPr sz="1250">
+              <a:rPr sz="1600">
                 <a:solidFill>
                   <a:srgbClr val="6A9955"/>
                 </a:solidFill>
@@ -20175,7 +20175,7 @@
               </a:spcAft>
             </a:pPr>
             <a:r>
-              <a:rPr sz="1250">
+              <a:rPr sz="1600">
                 <a:solidFill>
                   <a:srgbClr val="D4D4D4"/>
                 </a:solidFill>
@@ -20184,7 +20184,7 @@
               <a:t>    </a:t>
             </a:r>
             <a:r>
-              <a:rPr sz="1250">
+              <a:rPr sz="1600">
                 <a:solidFill>
                   <a:srgbClr val="DCDCAA"/>
                 </a:solidFill>
@@ -20193,7 +20193,7 @@
               <a:t>movsd</a:t>
             </a:r>
             <a:r>
-              <a:rPr sz="1250">
+              <a:rPr sz="1600">
                 <a:solidFill>
                   <a:srgbClr val="D4D4D4"/>
                 </a:solidFill>
@@ -20202,7 +20202,7 @@
               <a:t> xmm3, [rax+rcx*</a:t>
             </a:r>
             <a:r>
-              <a:rPr sz="1250">
+              <a:rPr sz="1600">
                 <a:solidFill>
                   <a:srgbClr val="B5CEA8"/>
                 </a:solidFill>
@@ -20211,7 +20211,7 @@
               <a:t>8</a:t>
             </a:r>
             <a:r>
-              <a:rPr sz="1250">
+              <a:rPr sz="1600">
                 <a:solidFill>
                   <a:srgbClr val="D4D4D4"/>
                 </a:solidFill>
@@ -20220,7 +20220,7 @@
               <a:t>]   </a:t>
             </a:r>
             <a:r>
-              <a:rPr sz="1250">
+              <a:rPr sz="1600">
                 <a:solidFill>
                   <a:srgbClr val="6A9955"/>
                 </a:solidFill>
@@ -20236,7 +20236,7 @@
               </a:spcAft>
             </a:pPr>
             <a:r>
-              <a:rPr sz="1250">
+              <a:rPr sz="1600">
                 <a:solidFill>
                   <a:srgbClr val="D4D4D4"/>
                 </a:solidFill>
@@ -20245,7 +20245,7 @@
               <a:t>    </a:t>
             </a:r>
             <a:r>
-              <a:rPr sz="1250">
+              <a:rPr sz="1600">
                 <a:solidFill>
                   <a:srgbClr val="DCDCAA"/>
                 </a:solidFill>
@@ -20254,7 +20254,7 @@
               <a:t>mulsd</a:t>
             </a:r>
             <a:r>
-              <a:rPr sz="1250">
+              <a:rPr sz="1600">
                 <a:solidFill>
                   <a:srgbClr val="D4D4D4"/>
                 </a:solidFill>
@@ -20270,7 +20270,7 @@
               </a:spcAft>
             </a:pPr>
             <a:r>
-              <a:rPr sz="1250">
+              <a:rPr sz="1600">
                 <a:solidFill>
                   <a:srgbClr val="D4D4D4"/>
                 </a:solidFill>
@@ -20279,7 +20279,7 @@
               <a:t>    </a:t>
             </a:r>
             <a:r>
-              <a:rPr sz="1250">
+              <a:rPr sz="1600">
                 <a:solidFill>
                   <a:srgbClr val="DCDCAA"/>
                 </a:solidFill>
@@ -20288,7 +20288,7 @@
               <a:t>mulsd</a:t>
             </a:r>
             <a:r>
-              <a:rPr sz="1250">
+              <a:rPr sz="1600">
                 <a:solidFill>
                   <a:srgbClr val="D4D4D4"/>
                 </a:solidFill>
@@ -20297,7 +20297,7 @@
               <a:t> xmm0, xmm3          </a:t>
             </a:r>
             <a:r>
-              <a:rPr sz="1250">
+              <a:rPr sz="1600">
                 <a:solidFill>
                   <a:srgbClr val="6A9955"/>
                 </a:solidFill>
@@ -20313,7 +20313,7 @@
               </a:spcAft>
             </a:pPr>
             <a:r>
-              <a:rPr sz="1250">
+              <a:rPr sz="1600">
                 <a:solidFill>
                   <a:srgbClr val="D4D4D4"/>
                 </a:solidFill>
@@ -20322,7 +20322,7 @@
               <a:t>    </a:t>
             </a:r>
             <a:r>
-              <a:rPr sz="1250">
+              <a:rPr sz="1600">
                 <a:solidFill>
                   <a:srgbClr val="DCDCAA"/>
                 </a:solidFill>
@@ -20331,7 +20331,7 @@
               <a:t>mulsd</a:t>
             </a:r>
             <a:r>
-              <a:rPr sz="1250">
+              <a:rPr sz="1600">
                 <a:solidFill>
                   <a:srgbClr val="D4D4D4"/>
                 </a:solidFill>
@@ -20340,7 +20340,7 @@
               <a:t> xmm0, xmm3          </a:t>
             </a:r>
             <a:r>
-              <a:rPr sz="1250">
+              <a:rPr sz="1600">
                 <a:solidFill>
                   <a:srgbClr val="6A9955"/>
                 </a:solidFill>
@@ -20356,7 +20356,7 @@
               </a:spcAft>
             </a:pPr>
             <a:r>
-              <a:rPr sz="1250">
+              <a:rPr sz="1600">
                 <a:solidFill>
                   <a:srgbClr val="D4D4D4"/>
                 </a:solidFill>
@@ -20365,7 +20365,7 @@
               <a:t>    </a:t>
             </a:r>
             <a:r>
-              <a:rPr sz="1250">
+              <a:rPr sz="1600">
                 <a:solidFill>
                   <a:srgbClr val="DCDCAA"/>
                 </a:solidFill>
@@ -20374,7 +20374,7 @@
               <a:t>subsd</a:t>
             </a:r>
             <a:r>
-              <a:rPr sz="1250">
+              <a:rPr sz="1600">
                 <a:solidFill>
                   <a:srgbClr val="D4D4D4"/>
                 </a:solidFill>
@@ -20383,7 +20383,7 @@
               <a:t> xmm2, [r8+</a:t>
             </a:r>
             <a:r>
-              <a:rPr sz="1250">
+              <a:rPr sz="1600">
                 <a:solidFill>
                   <a:srgbClr val="B5CEA8"/>
                 </a:solidFill>
@@ -20392,7 +20392,7 @@
               <a:t>16</a:t>
             </a:r>
             <a:r>
-              <a:rPr sz="1250">
+              <a:rPr sz="1600">
                 <a:solidFill>
                   <a:srgbClr val="D4D4D4"/>
                 </a:solidFill>
@@ -20401,7 +20401,7 @@
               <a:t>]       </a:t>
             </a:r>
             <a:r>
-              <a:rPr sz="1250">
+              <a:rPr sz="1600">
                 <a:solidFill>
                   <a:srgbClr val="6A9955"/>
                 </a:solidFill>
@@ -20417,7 +20417,7 @@
               </a:spcAft>
             </a:pPr>
             <a:r>
-              <a:rPr sz="1250">
+              <a:rPr sz="1600">
                 <a:solidFill>
                   <a:srgbClr val="D4D4D4"/>
                 </a:solidFill>
@@ -20426,7 +20426,7 @@
               <a:t>    </a:t>
             </a:r>
             <a:r>
-              <a:rPr sz="1250">
+              <a:rPr sz="1600">
                 <a:solidFill>
                   <a:srgbClr val="DCDCAA"/>
                 </a:solidFill>
@@ -20435,7 +20435,7 @@
               <a:t>mulsd</a:t>
             </a:r>
             <a:r>
-              <a:rPr sz="1250">
+              <a:rPr sz="1600">
                 <a:solidFill>
                   <a:srgbClr val="D4D4D4"/>
                 </a:solidFill>
@@ -20444,7 +20444,7 @@
               <a:t> xmm1, xmm2          </a:t>
             </a:r>
             <a:r>
-              <a:rPr sz="1250">
+              <a:rPr sz="1600">
                 <a:solidFill>
                   <a:srgbClr val="6A9955"/>
                 </a:solidFill>
@@ -20460,7 +20460,7 @@
               </a:spcAft>
             </a:pPr>
             <a:r>
-              <a:rPr sz="1250">
+              <a:rPr sz="1600">
                 <a:solidFill>
                   <a:srgbClr val="D4D4D4"/>
                 </a:solidFill>
@@ -20469,7 +20469,7 @@
               <a:t>    </a:t>
             </a:r>
             <a:r>
-              <a:rPr sz="1250">
+              <a:rPr sz="1600">
                 <a:solidFill>
                   <a:srgbClr val="DCDCAA"/>
                 </a:solidFill>
@@ -20478,7 +20478,7 @@
               <a:t>addsd</a:t>
             </a:r>
             <a:r>
-              <a:rPr sz="1250">
+              <a:rPr sz="1600">
                 <a:solidFill>
                   <a:srgbClr val="D4D4D4"/>
                 </a:solidFill>
@@ -20494,7 +20494,7 @@
               </a:spcAft>
             </a:pPr>
             <a:r>
-              <a:rPr sz="1250">
+              <a:rPr sz="1600">
                 <a:solidFill>
                   <a:srgbClr val="D4D4D4"/>
                 </a:solidFill>
@@ -20503,7 +20503,7 @@
               <a:t>    </a:t>
             </a:r>
             <a:r>
-              <a:rPr sz="1250">
+              <a:rPr sz="1600">
                 <a:solidFill>
                   <a:srgbClr val="DCDCAA"/>
                 </a:solidFill>
@@ -20512,7 +20512,7 @@
               <a:t>addsd</a:t>
             </a:r>
             <a:r>
-              <a:rPr sz="1250">
+              <a:rPr sz="1600">
                 <a:solidFill>
                   <a:srgbClr val="D4D4D4"/>
                 </a:solidFill>
@@ -20521,7 +20521,7 @@
               <a:t> xmm0, xmm1          </a:t>
             </a:r>
             <a:r>
-              <a:rPr sz="1250">
+              <a:rPr sz="1600">
                 <a:solidFill>
                   <a:srgbClr val="6A9955"/>
                 </a:solidFill>
@@ -20537,7 +20537,7 @@
               </a:spcAft>
             </a:pPr>
             <a:r>
-              <a:rPr sz="1250">
+              <a:rPr sz="1600">
                 <a:solidFill>
                   <a:srgbClr val="D4D4D4"/>
                 </a:solidFill>
@@ -20546,7 +20546,7 @@
               <a:t>    </a:t>
             </a:r>
             <a:r>
-              <a:rPr sz="1250">
+              <a:rPr sz="1600">
                 <a:solidFill>
                   <a:srgbClr val="DCDCAA"/>
                 </a:solidFill>
@@ -20559,14 +20559,14 @@
       </p:sp>
       <p:sp>
         <p:nvSpPr>
-          <p:cNvPr id="6" name="TextBox 5"/>
+          <p:cNvPr id="7" name="TextBox 6"/>
           <p:cNvSpPr txBox="1"/>
           <p:nvPr/>
         </p:nvSpPr>
         <p:spPr>
           <a:xfrm>
-            <a:off x="6858000" y="1828800"/>
-            <a:ext cx="4937760" cy="4572000"/>
+            <a:off x="411480" y="6446520"/>
+            <a:ext cx="10058400" cy="320040"/>
           </a:xfrm>
           <a:prstGeom prst="rect">
             <a:avLst/>
@@ -20574,131 +20574,33 @@
           <a:noFill/>
         </p:spPr>
         <p:txBody>
-          <a:bodyPr wrap="square">
+          <a:bodyPr wrap="none">
             <a:spAutoFit/>
           </a:bodyPr>
           <a:lstStyle/>
           <a:p>
-            <a:pPr>
-              <a:spcAft>
-                <a:spcPts val="800"/>
-              </a:spcAft>
-            </a:pPr>
-            <a:r>
-              <a:rPr sz="1800">
-                <a:solidFill>
-                  <a:srgbClr val="35C4E8"/>
-                </a:solidFill>
-                <a:latin typeface="Segoe UI"/>
-              </a:rPr>
-              <a:t>•  </a:t>
-            </a:r>
-            <a:r>
-              <a:rPr sz="1800" b="1">
-                <a:solidFill>
-                  <a:srgbClr val="7EE08A"/>
-                </a:solidFill>
-                <a:latin typeface="Segoe UI"/>
-              </a:rPr>
-              <a:t>0 call   0 jmp   0 vtable</a:t>
-            </a:r>
-          </a:p>
-          <a:p>
-            <a:pPr>
-              <a:spcAft>
-                <a:spcPts val="800"/>
-              </a:spcAft>
-            </a:pPr>
-            <a:r>
-              <a:rPr sz="1800">
-                <a:solidFill>
-                  <a:srgbClr val="35C4E8"/>
-                </a:solidFill>
-                <a:latin typeface="Segoe UI"/>
-              </a:rPr>
-              <a:t>•  </a:t>
-            </a:r>
-            <a:r>
-              <a:rPr sz="1800" b="0">
-                <a:solidFill>
-                  <a:srgbClr val="D8E2EC"/>
-                </a:solidFill>
-                <a:latin typeface="Segoe UI"/>
-              </a:rPr>
-              <a:t>Straight-line floating point — identical shape to the hand-written formula</a:t>
-            </a:r>
-          </a:p>
-          <a:p>
-            <a:pPr>
-              <a:spcAft>
-                <a:spcPts val="800"/>
-              </a:spcAft>
-            </a:pPr>
-            <a:r>
-              <a:rPr sz="1800">
-                <a:solidFill>
-                  <a:srgbClr val="35C4E8"/>
-                </a:solidFill>
-                <a:latin typeface="Segoe UI"/>
-              </a:rPr>
-              <a:t>•  </a:t>
-            </a:r>
-            <a:r>
-              <a:rPr sz="1800" b="0">
-                <a:solidFill>
-                  <a:srgbClr val="D8E2EC"/>
-                </a:solidFill>
-                <a:latin typeface="Segoe UI"/>
-              </a:rPr>
-              <a:t>Only difference: the monolith constant-folds m and k; the framework reads them as parameters</a:t>
-            </a:r>
-          </a:p>
-          <a:p>
-            <a:pPr>
-              <a:spcAft>
-                <a:spcPts val="800"/>
-              </a:spcAft>
-            </a:pPr>
-            <a:r>
-              <a:rPr sz="1800">
-                <a:solidFill>
-                  <a:srgbClr val="35C4E8"/>
-                </a:solidFill>
-                <a:latin typeface="Segoe UI"/>
-              </a:rPr>
-              <a:t>•  </a:t>
-            </a:r>
-            <a:r>
-              <a:rPr sz="1800" b="0">
-                <a:solidFill>
-                  <a:srgbClr val="D8E2EC"/>
-                </a:solidFill>
-                <a:latin typeface="Segoe UI"/>
-              </a:rPr>
-              <a:t>Registry, tags, concepts: </a:t>
-            </a:r>
-            <a:r>
-              <a:rPr sz="1800" b="1">
-                <a:solidFill>
-                  <a:srgbClr val="F2C744"/>
-                </a:solidFill>
-                <a:latin typeface="Segoe UI"/>
-              </a:rPr>
-              <a:t>zero instructions</a:t>
-            </a:r>
-          </a:p>
-        </p:txBody>
-      </p:sp>
-      <p:sp>
-        <p:nvSpPr>
-          <p:cNvPr id="7" name="TextBox 6"/>
+            <a:r>
+              <a:rPr sz="1000">
+                <a:solidFill>
+                  <a:srgbClr val="8CA3B8"/>
+                </a:solidFill>
+                <a:latin typeface="Segoe UI"/>
+              </a:rPr>
+              <a:t>Separation of Concerns at Zero Cost — ACCU on Sea 2026</a:t>
+            </a:r>
+          </a:p>
+        </p:txBody>
+      </p:sp>
+      <p:sp>
+        <p:nvSpPr>
+          <p:cNvPr id="8" name="TextBox 7"/>
           <p:cNvSpPr txBox="1"/>
           <p:nvPr/>
         </p:nvSpPr>
         <p:spPr>
           <a:xfrm>
-            <a:off x="411480" y="6446520"/>
-            <a:ext cx="10058400" cy="320040"/>
+            <a:off x="11384280" y="6446520"/>
+            <a:ext cx="548640" cy="320040"/>
           </a:xfrm>
           <a:prstGeom prst="rect">
             <a:avLst/>
@@ -20711,6 +20613,7 @@
           </a:bodyPr>
           <a:lstStyle/>
           <a:p>
+            <a:pPr algn="r"/>
             <a:r>
               <a:rPr sz="1000">
                 <a:solidFill>
@@ -20718,21 +20621,21 @@
                 </a:solidFill>
                 <a:latin typeface="Segoe UI"/>
               </a:rPr>
-              <a:t>Separation of Concerns at Zero Cost — ACCU on Sea 2026</a:t>
-            </a:r>
-          </a:p>
-        </p:txBody>
-      </p:sp>
-      <p:sp>
-        <p:nvSpPr>
-          <p:cNvPr id="8" name="TextBox 7"/>
+              <a:t>29</a:t>
+            </a:r>
+          </a:p>
+        </p:txBody>
+      </p:sp>
+      <p:sp>
+        <p:nvSpPr>
+          <p:cNvPr id="9" name="asm takeaway"/>
           <p:cNvSpPr txBox="1"/>
           <p:nvPr/>
         </p:nvSpPr>
         <p:spPr>
           <a:xfrm>
-            <a:off x="11384280" y="6446520"/>
-            <a:ext cx="548640" cy="320040"/>
+            <a:off x="731520" y="5678423"/>
+            <a:ext cx="10972800" cy="548640"/>
           </a:xfrm>
           <a:prstGeom prst="rect">
             <a:avLst/>
@@ -20745,15 +20648,14 @@
           </a:bodyPr>
           <a:lstStyle/>
           <a:p>
-            <a:pPr algn="r"/>
-            <a:r>
-              <a:rPr sz="1000">
-                <a:solidFill>
-                  <a:srgbClr val="8CA3B8"/>
-                </a:solidFill>
-                <a:latin typeface="Segoe UI"/>
-              </a:rPr>
-              <a:t>29</a:t>
+            <a:r>
+              <a:rPr sz="1900" i="1">
+                <a:solidFill>
+                  <a:srgbClr val="7EE08A"/>
+                </a:solidFill>
+                <a:latin typeface="Segoe UI"/>
+              </a:rPr>
+              <a:t>0 calls · 0 jumps · 0 vtables — straight-line FP, the same shape as the hand-written formula.</a:t>
             </a:r>
           </a:p>
         </p:txBody>
@@ -21465,49 +21367,22 @@
           <a:lstStyle/>
           <a:p>
             <a:r>
-              <a:rPr lang="pl-PL" sz="2000" dirty="0">
+              <a:rPr sz="4000" b="1">
+                <a:solidFill>
+                  <a:srgbClr val="7EE08A"/>
+                </a:solidFill>
+                <a:latin typeface="Segoe UI"/>
+              </a:rPr>
+              <a:t>1000×</a:t>
+            </a:r>
+            <a:r>
+              <a:rPr sz="2000" b="0">
                 <a:solidFill>
                   <a:srgbClr val="D8E2EC"/>
                 </a:solidFill>
                 <a:latin typeface="Segoe UI"/>
               </a:rPr>
-              <a:t>1000 x </a:t>
-            </a:r>
-            <a:r>
-              <a:rPr lang="pl-PL" sz="2000" dirty="0" err="1">
-                <a:solidFill>
-                  <a:srgbClr val="D8E2EC"/>
-                </a:solidFill>
-                <a:latin typeface="Segoe UI"/>
-              </a:rPr>
-              <a:t>faster</a:t>
-            </a:r>
-            <a:r>
-              <a:rPr lang="pl-PL" sz="2000" dirty="0">
-                <a:solidFill>
-                  <a:srgbClr val="D8E2EC"/>
-                </a:solidFill>
-                <a:latin typeface="Segoe UI"/>
-              </a:rPr>
-              <a:t> </a:t>
-            </a:r>
-            <a:r>
-              <a:rPr lang="pl-PL" sz="2000" dirty="0" err="1">
-                <a:solidFill>
-                  <a:srgbClr val="D8E2EC"/>
-                </a:solidFill>
-                <a:latin typeface="Segoe UI"/>
-              </a:rPr>
-              <a:t>than</a:t>
-            </a:r>
-            <a:r>
-              <a:rPr lang="pl-PL" sz="2000" dirty="0">
-                <a:solidFill>
-                  <a:srgbClr val="D8E2EC"/>
-                </a:solidFill>
-                <a:latin typeface="Segoe UI"/>
-              </a:rPr>
-              <a:t> OO C# version</a:t>
+              <a:t>   faster than an equivalent OO C# version</a:t>
             </a:r>
             <a:endParaRPr sz="2000" dirty="0">
               <a:solidFill>

</xml_diff>

<commit_message>
Add Zarchan booster-sim 'old way' slides to the history-lesson section
Filled the slide-37 placeholder ("We've been here before") with the real
gravity-turn booster simulation from Zarchan, Tactical & Strategic Missile
Guidance, 6th ed. — a wall of bare globals + staging math — credited and
MATLAB-highlighted at 16pt. Added a following slide showing the integration
loop, where staging, gravity/thrust, and the integrator all share one scope of
globals, with a green takeaway. (Listing is MATLAB in the 6th ed., labelled as
such.) Deck now 41 slides; page numbers renumbered; PDF regenerated.

Co-Authored-By: Claude Opus 4.8 (1M context) <noreply@anthropic.com>
</commit_message>
<xml_diff>
--- a/slides/ACCU-Separation-of-Concerns-at-Zero-Cost.pptx
+++ b/slides/ACCU-Separation-of-Concerns-at-Zero-Cost.pptx
@@ -45,6 +45,7 @@
     <p:sldId id="288" r:id="rId35"/>
     <p:sldId id="289" r:id="rId36"/>
     <p:sldId id="290" r:id="rId37"/>
+    <p:sldId id="298" r:id="rId47"/>
     <p:sldId id="291" r:id="rId38"/>
     <p:sldId id="292" r:id="rId39"/>
     <p:sldId id="293" r:id="rId40"/>
@@ -24709,8 +24710,8 @@
         </p:nvSpPr>
         <p:spPr>
           <a:xfrm>
-            <a:off x="1097280" y="1737360"/>
-            <a:ext cx="9966960" cy="3108960"/>
+            <a:off x="548640" y="1554480"/>
+            <a:ext cx="11338560" cy="3017520"/>
           </a:xfrm>
           <a:prstGeom prst="roundRect">
             <a:avLst>
@@ -24746,16 +24747,6 @@
           <a:lstStyle/>
           <a:p>
             <a:pPr algn="ctr"/>
-            <a:r>
-              <a:rPr sz="1600" b="0">
-                <a:solidFill>
-                  <a:srgbClr val="8CA3B8"/>
-                </a:solidFill>
-                <a:latin typeface="Segoe UI"/>
-              </a:rPr>
-              <a:t>[ PLACEHOLDER — scan of rocket-control code from a classic textbook
-(Zipfel / 1960s–90s Fortran, zero modularity) ]</a:t>
-            </a:r>
           </a:p>
         </p:txBody>
       </p:sp>
@@ -24901,6 +24892,1476 @@
           </a:p>
         </p:txBody>
       </p:sp>
+      <p:sp>
+        <p:nvSpPr>
+          <p:cNvPr id="8" name="zarchan setup"/>
+          <p:cNvSpPr txBox="1"/>
+          <p:nvPr/>
+        </p:nvSpPr>
+        <p:spPr>
+          <a:xfrm>
+            <a:off x="777240" y="1691640"/>
+            <a:ext cx="10881360" cy="2743200"/>
+          </a:xfrm>
+          <a:prstGeom prst="rect">
+            <a:avLst/>
+          </a:prstGeom>
+          <a:noFill/>
+        </p:spPr>
+        <p:txBody>
+          <a:bodyPr wrap="none">
+            <a:spAutoFit/>
+          </a:bodyPr>
+          <a:lstStyle/>
+          <a:p>
+            <a:pPr>
+              <a:spcAft>
+                <a:spcPts val="100"/>
+              </a:spcAft>
+            </a:pPr>
+            <a:r>
+              <a:rPr sz="1600">
+                <a:solidFill>
+                  <a:srgbClr val="D4D4D4"/>
+                </a:solidFill>
+                <a:latin typeface="Consolas"/>
+              </a:rPr>
+              <a:t>XISP1</a:t>
+            </a:r>
+            <a:r>
+              <a:rPr sz="1600">
+                <a:solidFill>
+                  <a:srgbClr val="D4D4D4"/>
+                </a:solidFill>
+                <a:latin typeface="Consolas"/>
+              </a:rPr>
+              <a:t>=</a:t>
+            </a:r>
+            <a:r>
+              <a:rPr sz="1600">
+                <a:solidFill>
+                  <a:srgbClr val="B5CEA8"/>
+                </a:solidFill>
+                <a:latin typeface="Consolas"/>
+              </a:rPr>
+              <a:t>250.</a:t>
+            </a:r>
+            <a:r>
+              <a:rPr sz="1600">
+                <a:solidFill>
+                  <a:srgbClr val="D4D4D4"/>
+                </a:solidFill>
+                <a:latin typeface="Consolas"/>
+              </a:rPr>
+              <a:t>;</a:t>
+            </a:r>
+            <a:r>
+              <a:rPr sz="1600">
+                <a:solidFill>
+                  <a:srgbClr val="D4D4D4"/>
+                </a:solidFill>
+                <a:latin typeface="Consolas"/>
+              </a:rPr>
+              <a:t>  </a:t>
+            </a:r>
+            <a:r>
+              <a:rPr sz="1600">
+                <a:solidFill>
+                  <a:srgbClr val="D4D4D4"/>
+                </a:solidFill>
+                <a:latin typeface="Consolas"/>
+              </a:rPr>
+              <a:t>XISP2</a:t>
+            </a:r>
+            <a:r>
+              <a:rPr sz="1600">
+                <a:solidFill>
+                  <a:srgbClr val="D4D4D4"/>
+                </a:solidFill>
+                <a:latin typeface="Consolas"/>
+              </a:rPr>
+              <a:t>=</a:t>
+            </a:r>
+            <a:r>
+              <a:rPr sz="1600">
+                <a:solidFill>
+                  <a:srgbClr val="B5CEA8"/>
+                </a:solidFill>
+                <a:latin typeface="Consolas"/>
+              </a:rPr>
+              <a:t>250.</a:t>
+            </a:r>
+            <a:r>
+              <a:rPr sz="1600">
+                <a:solidFill>
+                  <a:srgbClr val="D4D4D4"/>
+                </a:solidFill>
+                <a:latin typeface="Consolas"/>
+              </a:rPr>
+              <a:t>;</a:t>
+            </a:r>
+            <a:r>
+              <a:rPr sz="1600">
+                <a:solidFill>
+                  <a:srgbClr val="D4D4D4"/>
+                </a:solidFill>
+                <a:latin typeface="Consolas"/>
+              </a:rPr>
+              <a:t>  </a:t>
+            </a:r>
+            <a:r>
+              <a:rPr sz="1600">
+                <a:solidFill>
+                  <a:srgbClr val="D4D4D4"/>
+                </a:solidFill>
+                <a:latin typeface="Consolas"/>
+              </a:rPr>
+              <a:t>XMF1</a:t>
+            </a:r>
+            <a:r>
+              <a:rPr sz="1600">
+                <a:solidFill>
+                  <a:srgbClr val="D4D4D4"/>
+                </a:solidFill>
+                <a:latin typeface="Consolas"/>
+              </a:rPr>
+              <a:t>=</a:t>
+            </a:r>
+            <a:r>
+              <a:rPr sz="1600">
+                <a:solidFill>
+                  <a:srgbClr val="B5CEA8"/>
+                </a:solidFill>
+                <a:latin typeface="Consolas"/>
+              </a:rPr>
+              <a:t>.85</a:t>
+            </a:r>
+            <a:r>
+              <a:rPr sz="1600">
+                <a:solidFill>
+                  <a:srgbClr val="D4D4D4"/>
+                </a:solidFill>
+                <a:latin typeface="Consolas"/>
+              </a:rPr>
+              <a:t>;</a:t>
+            </a:r>
+            <a:r>
+              <a:rPr sz="1600">
+                <a:solidFill>
+                  <a:srgbClr val="D4D4D4"/>
+                </a:solidFill>
+                <a:latin typeface="Consolas"/>
+              </a:rPr>
+              <a:t>  </a:t>
+            </a:r>
+            <a:r>
+              <a:rPr sz="1600">
+                <a:solidFill>
+                  <a:srgbClr val="D4D4D4"/>
+                </a:solidFill>
+                <a:latin typeface="Consolas"/>
+              </a:rPr>
+              <a:t>XMF2</a:t>
+            </a:r>
+            <a:r>
+              <a:rPr sz="1600">
+                <a:solidFill>
+                  <a:srgbClr val="D4D4D4"/>
+                </a:solidFill>
+                <a:latin typeface="Consolas"/>
+              </a:rPr>
+              <a:t>=</a:t>
+            </a:r>
+            <a:r>
+              <a:rPr sz="1600">
+                <a:solidFill>
+                  <a:srgbClr val="B5CEA8"/>
+                </a:solidFill>
+                <a:latin typeface="Consolas"/>
+              </a:rPr>
+              <a:t>.85</a:t>
+            </a:r>
+            <a:r>
+              <a:rPr sz="1600">
+                <a:solidFill>
+                  <a:srgbClr val="D4D4D4"/>
+                </a:solidFill>
+                <a:latin typeface="Consolas"/>
+              </a:rPr>
+              <a:t>;</a:t>
+            </a:r>
+          </a:p>
+          <a:p>
+            <a:pPr>
+              <a:spcAft>
+                <a:spcPts val="100"/>
+              </a:spcAft>
+            </a:pPr>
+            <a:r>
+              <a:rPr sz="1600">
+                <a:solidFill>
+                  <a:srgbClr val="D4D4D4"/>
+                </a:solidFill>
+                <a:latin typeface="Consolas"/>
+              </a:rPr>
+              <a:t>WPAY</a:t>
+            </a:r>
+            <a:r>
+              <a:rPr sz="1600">
+                <a:solidFill>
+                  <a:srgbClr val="D4D4D4"/>
+                </a:solidFill>
+                <a:latin typeface="Consolas"/>
+              </a:rPr>
+              <a:t>=</a:t>
+            </a:r>
+            <a:r>
+              <a:rPr sz="1600">
+                <a:solidFill>
+                  <a:srgbClr val="B5CEA8"/>
+                </a:solidFill>
+                <a:latin typeface="Consolas"/>
+              </a:rPr>
+              <a:t>100.</a:t>
+            </a:r>
+            <a:r>
+              <a:rPr sz="1600">
+                <a:solidFill>
+                  <a:srgbClr val="D4D4D4"/>
+                </a:solidFill>
+                <a:latin typeface="Consolas"/>
+              </a:rPr>
+              <a:t>;</a:t>
+            </a:r>
+            <a:r>
+              <a:rPr sz="1600">
+                <a:solidFill>
+                  <a:srgbClr val="D4D4D4"/>
+                </a:solidFill>
+                <a:latin typeface="Consolas"/>
+              </a:rPr>
+              <a:t>   </a:t>
+            </a:r>
+            <a:r>
+              <a:rPr sz="1600">
+                <a:solidFill>
+                  <a:srgbClr val="D4D4D4"/>
+                </a:solidFill>
+                <a:latin typeface="Consolas"/>
+              </a:rPr>
+              <a:t>DELV</a:t>
+            </a:r>
+            <a:r>
+              <a:rPr sz="1600">
+                <a:solidFill>
+                  <a:srgbClr val="D4D4D4"/>
+                </a:solidFill>
+                <a:latin typeface="Consolas"/>
+              </a:rPr>
+              <a:t>=</a:t>
+            </a:r>
+            <a:r>
+              <a:rPr sz="1600">
+                <a:solidFill>
+                  <a:srgbClr val="B5CEA8"/>
+                </a:solidFill>
+                <a:latin typeface="Consolas"/>
+              </a:rPr>
+              <a:t>20000.</a:t>
+            </a:r>
+            <a:r>
+              <a:rPr sz="1600">
+                <a:solidFill>
+                  <a:srgbClr val="D4D4D4"/>
+                </a:solidFill>
+                <a:latin typeface="Consolas"/>
+              </a:rPr>
+              <a:t>;</a:t>
+            </a:r>
+          </a:p>
+          <a:p>
+            <a:pPr>
+              <a:spcAft>
+                <a:spcPts val="100"/>
+              </a:spcAft>
+            </a:pPr>
+            <a:r>
+              <a:rPr sz="1600">
+                <a:solidFill>
+                  <a:srgbClr val="D4D4D4"/>
+                </a:solidFill>
+                <a:latin typeface="Consolas"/>
+              </a:rPr>
+              <a:t>DELV1</a:t>
+            </a:r>
+            <a:r>
+              <a:rPr sz="1600">
+                <a:solidFill>
+                  <a:srgbClr val="D4D4D4"/>
+                </a:solidFill>
+                <a:latin typeface="Consolas"/>
+              </a:rPr>
+              <a:t>=</a:t>
+            </a:r>
+            <a:r>
+              <a:rPr sz="1600">
+                <a:solidFill>
+                  <a:srgbClr val="B5CEA8"/>
+                </a:solidFill>
+                <a:latin typeface="Consolas"/>
+              </a:rPr>
+              <a:t>.3333</a:t>
+            </a:r>
+            <a:r>
+              <a:rPr sz="1600">
+                <a:solidFill>
+                  <a:srgbClr val="D4D4D4"/>
+                </a:solidFill>
+                <a:latin typeface="Consolas"/>
+              </a:rPr>
+              <a:t>*</a:t>
+            </a:r>
+            <a:r>
+              <a:rPr sz="1600">
+                <a:solidFill>
+                  <a:srgbClr val="D4D4D4"/>
+                </a:solidFill>
+                <a:latin typeface="Consolas"/>
+              </a:rPr>
+              <a:t>DELV</a:t>
+            </a:r>
+            <a:r>
+              <a:rPr sz="1600">
+                <a:solidFill>
+                  <a:srgbClr val="D4D4D4"/>
+                </a:solidFill>
+                <a:latin typeface="Consolas"/>
+              </a:rPr>
+              <a:t>;</a:t>
+            </a:r>
+            <a:r>
+              <a:rPr sz="1600">
+                <a:solidFill>
+                  <a:srgbClr val="D4D4D4"/>
+                </a:solidFill>
+                <a:latin typeface="Consolas"/>
+              </a:rPr>
+              <a:t>   </a:t>
+            </a:r>
+            <a:r>
+              <a:rPr sz="1600">
+                <a:solidFill>
+                  <a:srgbClr val="D4D4D4"/>
+                </a:solidFill>
+                <a:latin typeface="Consolas"/>
+              </a:rPr>
+              <a:t>DELV2</a:t>
+            </a:r>
+            <a:r>
+              <a:rPr sz="1600">
+                <a:solidFill>
+                  <a:srgbClr val="D4D4D4"/>
+                </a:solidFill>
+                <a:latin typeface="Consolas"/>
+              </a:rPr>
+              <a:t>=</a:t>
+            </a:r>
+            <a:r>
+              <a:rPr sz="1600">
+                <a:solidFill>
+                  <a:srgbClr val="B5CEA8"/>
+                </a:solidFill>
+                <a:latin typeface="Consolas"/>
+              </a:rPr>
+              <a:t>.6667</a:t>
+            </a:r>
+            <a:r>
+              <a:rPr sz="1600">
+                <a:solidFill>
+                  <a:srgbClr val="D4D4D4"/>
+                </a:solidFill>
+                <a:latin typeface="Consolas"/>
+              </a:rPr>
+              <a:t>*</a:t>
+            </a:r>
+            <a:r>
+              <a:rPr sz="1600">
+                <a:solidFill>
+                  <a:srgbClr val="D4D4D4"/>
+                </a:solidFill>
+                <a:latin typeface="Consolas"/>
+              </a:rPr>
+              <a:t>DELV</a:t>
+            </a:r>
+            <a:r>
+              <a:rPr sz="1600">
+                <a:solidFill>
+                  <a:srgbClr val="D4D4D4"/>
+                </a:solidFill>
+                <a:latin typeface="Consolas"/>
+              </a:rPr>
+              <a:t>;</a:t>
+            </a:r>
+          </a:p>
+          <a:p>
+            <a:pPr>
+              <a:spcAft>
+                <a:spcPts val="100"/>
+              </a:spcAft>
+            </a:pPr>
+            <a:r>
+              <a:rPr sz="1600">
+                <a:solidFill>
+                  <a:srgbClr val="D4D4D4"/>
+                </a:solidFill>
+                <a:latin typeface="Consolas"/>
+              </a:rPr>
+              <a:t>AMAX1</a:t>
+            </a:r>
+            <a:r>
+              <a:rPr sz="1600">
+                <a:solidFill>
+                  <a:srgbClr val="D4D4D4"/>
+                </a:solidFill>
+                <a:latin typeface="Consolas"/>
+              </a:rPr>
+              <a:t>=</a:t>
+            </a:r>
+            <a:r>
+              <a:rPr sz="1600">
+                <a:solidFill>
+                  <a:srgbClr val="B5CEA8"/>
+                </a:solidFill>
+                <a:latin typeface="Consolas"/>
+              </a:rPr>
+              <a:t>10.</a:t>
+            </a:r>
+            <a:r>
+              <a:rPr sz="1600">
+                <a:solidFill>
+                  <a:srgbClr val="D4D4D4"/>
+                </a:solidFill>
+                <a:latin typeface="Consolas"/>
+              </a:rPr>
+              <a:t>;</a:t>
+            </a:r>
+            <a:r>
+              <a:rPr sz="1600">
+                <a:solidFill>
+                  <a:srgbClr val="D4D4D4"/>
+                </a:solidFill>
+                <a:latin typeface="Consolas"/>
+              </a:rPr>
+              <a:t>   </a:t>
+            </a:r>
+            <a:r>
+              <a:rPr sz="1600">
+                <a:solidFill>
+                  <a:srgbClr val="D4D4D4"/>
+                </a:solidFill>
+                <a:latin typeface="Consolas"/>
+              </a:rPr>
+              <a:t>AMAX2</a:t>
+            </a:r>
+            <a:r>
+              <a:rPr sz="1600">
+                <a:solidFill>
+                  <a:srgbClr val="D4D4D4"/>
+                </a:solidFill>
+                <a:latin typeface="Consolas"/>
+              </a:rPr>
+              <a:t>=</a:t>
+            </a:r>
+            <a:r>
+              <a:rPr sz="1600">
+                <a:solidFill>
+                  <a:srgbClr val="B5CEA8"/>
+                </a:solidFill>
+                <a:latin typeface="Consolas"/>
+              </a:rPr>
+              <a:t>10.</a:t>
+            </a:r>
+            <a:r>
+              <a:rPr sz="1600">
+                <a:solidFill>
+                  <a:srgbClr val="D4D4D4"/>
+                </a:solidFill>
+                <a:latin typeface="Consolas"/>
+              </a:rPr>
+              <a:t>;</a:t>
+            </a:r>
+            <a:r>
+              <a:rPr sz="1600">
+                <a:solidFill>
+                  <a:srgbClr val="D4D4D4"/>
+                </a:solidFill>
+                <a:latin typeface="Consolas"/>
+              </a:rPr>
+              <a:t>   </a:t>
+            </a:r>
+            <a:r>
+              <a:rPr sz="1600">
+                <a:solidFill>
+                  <a:srgbClr val="D4D4D4"/>
+                </a:solidFill>
+                <a:latin typeface="Consolas"/>
+              </a:rPr>
+              <a:t>GAMDEG</a:t>
+            </a:r>
+            <a:r>
+              <a:rPr sz="1600">
+                <a:solidFill>
+                  <a:srgbClr val="D4D4D4"/>
+                </a:solidFill>
+                <a:latin typeface="Consolas"/>
+              </a:rPr>
+              <a:t>=</a:t>
+            </a:r>
+            <a:r>
+              <a:rPr sz="1600">
+                <a:solidFill>
+                  <a:srgbClr val="B5CEA8"/>
+                </a:solidFill>
+                <a:latin typeface="Consolas"/>
+              </a:rPr>
+              <a:t>85.</a:t>
+            </a:r>
+            <a:r>
+              <a:rPr sz="1600">
+                <a:solidFill>
+                  <a:srgbClr val="D4D4D4"/>
+                </a:solidFill>
+                <a:latin typeface="Consolas"/>
+              </a:rPr>
+              <a:t>;</a:t>
+            </a:r>
+          </a:p>
+          <a:p>
+            <a:pPr>
+              <a:spcAft>
+                <a:spcPts val="100"/>
+              </a:spcAft>
+            </a:pPr>
+            <a:r>
+              <a:rPr sz="1600">
+                <a:solidFill>
+                  <a:srgbClr val="D4D4D4"/>
+                </a:solidFill>
+                <a:latin typeface="Consolas"/>
+              </a:rPr>
+              <a:t>TOP2</a:t>
+            </a:r>
+            <a:r>
+              <a:rPr sz="1600">
+                <a:solidFill>
+                  <a:srgbClr val="D4D4D4"/>
+                </a:solidFill>
+                <a:latin typeface="Consolas"/>
+              </a:rPr>
+              <a:t>=</a:t>
+            </a:r>
+            <a:r>
+              <a:rPr sz="1600">
+                <a:solidFill>
+                  <a:srgbClr val="D4D4D4"/>
+                </a:solidFill>
+                <a:latin typeface="Consolas"/>
+              </a:rPr>
+              <a:t>WPAY</a:t>
+            </a:r>
+            <a:r>
+              <a:rPr sz="1600">
+                <a:solidFill>
+                  <a:srgbClr val="D4D4D4"/>
+                </a:solidFill>
+                <a:latin typeface="Consolas"/>
+              </a:rPr>
+              <a:t>*</a:t>
+            </a:r>
+            <a:r>
+              <a:rPr sz="1600">
+                <a:solidFill>
+                  <a:srgbClr val="D4D4D4"/>
+                </a:solidFill>
+                <a:latin typeface="Consolas"/>
+              </a:rPr>
+              <a:t>(</a:t>
+            </a:r>
+            <a:r>
+              <a:rPr sz="1600">
+                <a:solidFill>
+                  <a:srgbClr val="4EC9B0"/>
+                </a:solidFill>
+                <a:latin typeface="Consolas"/>
+              </a:rPr>
+              <a:t>exp</a:t>
+            </a:r>
+            <a:r>
+              <a:rPr sz="1600">
+                <a:solidFill>
+                  <a:srgbClr val="D4D4D4"/>
+                </a:solidFill>
+                <a:latin typeface="Consolas"/>
+              </a:rPr>
+              <a:t>(</a:t>
+            </a:r>
+            <a:r>
+              <a:rPr sz="1600">
+                <a:solidFill>
+                  <a:srgbClr val="D4D4D4"/>
+                </a:solidFill>
+                <a:latin typeface="Consolas"/>
+              </a:rPr>
+              <a:t>DELV2</a:t>
+            </a:r>
+            <a:r>
+              <a:rPr sz="1600">
+                <a:solidFill>
+                  <a:srgbClr val="D4D4D4"/>
+                </a:solidFill>
+                <a:latin typeface="Consolas"/>
+              </a:rPr>
+              <a:t>/</a:t>
+            </a:r>
+            <a:r>
+              <a:rPr sz="1600">
+                <a:solidFill>
+                  <a:srgbClr val="D4D4D4"/>
+                </a:solidFill>
+                <a:latin typeface="Consolas"/>
+              </a:rPr>
+              <a:t>(</a:t>
+            </a:r>
+            <a:r>
+              <a:rPr sz="1600">
+                <a:solidFill>
+                  <a:srgbClr val="D4D4D4"/>
+                </a:solidFill>
+                <a:latin typeface="Consolas"/>
+              </a:rPr>
+              <a:t>XISP2</a:t>
+            </a:r>
+            <a:r>
+              <a:rPr sz="1600">
+                <a:solidFill>
+                  <a:srgbClr val="D4D4D4"/>
+                </a:solidFill>
+                <a:latin typeface="Consolas"/>
+              </a:rPr>
+              <a:t>*</a:t>
+            </a:r>
+            <a:r>
+              <a:rPr sz="1600">
+                <a:solidFill>
+                  <a:srgbClr val="B5CEA8"/>
+                </a:solidFill>
+                <a:latin typeface="Consolas"/>
+              </a:rPr>
+              <a:t>32.2</a:t>
+            </a:r>
+            <a:r>
+              <a:rPr sz="1600">
+                <a:solidFill>
+                  <a:srgbClr val="D4D4D4"/>
+                </a:solidFill>
+                <a:latin typeface="Consolas"/>
+              </a:rPr>
+              <a:t>)</a:t>
+            </a:r>
+            <a:r>
+              <a:rPr sz="1600">
+                <a:solidFill>
+                  <a:srgbClr val="D4D4D4"/>
+                </a:solidFill>
+                <a:latin typeface="Consolas"/>
+              </a:rPr>
+              <a:t>)</a:t>
+            </a:r>
+            <a:r>
+              <a:rPr sz="1600">
+                <a:solidFill>
+                  <a:srgbClr val="D4D4D4"/>
+                </a:solidFill>
+                <a:latin typeface="Consolas"/>
+              </a:rPr>
+              <a:t>-</a:t>
+            </a:r>
+            <a:r>
+              <a:rPr sz="1600">
+                <a:solidFill>
+                  <a:srgbClr val="B5CEA8"/>
+                </a:solidFill>
+                <a:latin typeface="Consolas"/>
+              </a:rPr>
+              <a:t>1.</a:t>
+            </a:r>
+            <a:r>
+              <a:rPr sz="1600">
+                <a:solidFill>
+                  <a:srgbClr val="D4D4D4"/>
+                </a:solidFill>
+                <a:latin typeface="Consolas"/>
+              </a:rPr>
+              <a:t>)</a:t>
+            </a:r>
+            <a:r>
+              <a:rPr sz="1600">
+                <a:solidFill>
+                  <a:srgbClr val="D4D4D4"/>
+                </a:solidFill>
+                <a:latin typeface="Consolas"/>
+              </a:rPr>
+              <a:t>;</a:t>
+            </a:r>
+          </a:p>
+          <a:p>
+            <a:pPr>
+              <a:spcAft>
+                <a:spcPts val="100"/>
+              </a:spcAft>
+            </a:pPr>
+            <a:r>
+              <a:rPr sz="1600">
+                <a:solidFill>
+                  <a:srgbClr val="D4D4D4"/>
+                </a:solidFill>
+                <a:latin typeface="Consolas"/>
+              </a:rPr>
+              <a:t>BOT2</a:t>
+            </a:r>
+            <a:r>
+              <a:rPr sz="1600">
+                <a:solidFill>
+                  <a:srgbClr val="D4D4D4"/>
+                </a:solidFill>
+                <a:latin typeface="Consolas"/>
+              </a:rPr>
+              <a:t>=</a:t>
+            </a:r>
+            <a:r>
+              <a:rPr sz="1600">
+                <a:solidFill>
+                  <a:srgbClr val="B5CEA8"/>
+                </a:solidFill>
+                <a:latin typeface="Consolas"/>
+              </a:rPr>
+              <a:t>1</a:t>
+            </a:r>
+            <a:r>
+              <a:rPr sz="1600">
+                <a:solidFill>
+                  <a:srgbClr val="D4D4D4"/>
+                </a:solidFill>
+                <a:latin typeface="Consolas"/>
+              </a:rPr>
+              <a:t>/</a:t>
+            </a:r>
+            <a:r>
+              <a:rPr sz="1600">
+                <a:solidFill>
+                  <a:srgbClr val="D4D4D4"/>
+                </a:solidFill>
+                <a:latin typeface="Consolas"/>
+              </a:rPr>
+              <a:t>XMF2</a:t>
+            </a:r>
+            <a:r>
+              <a:rPr sz="1600">
+                <a:solidFill>
+                  <a:srgbClr val="D4D4D4"/>
+                </a:solidFill>
+                <a:latin typeface="Consolas"/>
+              </a:rPr>
+              <a:t>-</a:t>
+            </a:r>
+            <a:r>
+              <a:rPr sz="1600">
+                <a:solidFill>
+                  <a:srgbClr val="D4D4D4"/>
+                </a:solidFill>
+                <a:latin typeface="Consolas"/>
+              </a:rPr>
+              <a:t>(</a:t>
+            </a:r>
+            <a:r>
+              <a:rPr sz="1600">
+                <a:solidFill>
+                  <a:srgbClr val="D4D4D4"/>
+                </a:solidFill>
+                <a:latin typeface="Consolas"/>
+              </a:rPr>
+              <a:t>(</a:t>
+            </a:r>
+            <a:r>
+              <a:rPr sz="1600">
+                <a:solidFill>
+                  <a:srgbClr val="B5CEA8"/>
+                </a:solidFill>
+                <a:latin typeface="Consolas"/>
+              </a:rPr>
+              <a:t>1</a:t>
+            </a:r>
+            <a:r>
+              <a:rPr sz="1600">
+                <a:solidFill>
+                  <a:srgbClr val="D4D4D4"/>
+                </a:solidFill>
+                <a:latin typeface="Consolas"/>
+              </a:rPr>
+              <a:t>.</a:t>
+            </a:r>
+            <a:r>
+              <a:rPr sz="1600">
+                <a:solidFill>
+                  <a:srgbClr val="D4D4D4"/>
+                </a:solidFill>
+                <a:latin typeface="Consolas"/>
+              </a:rPr>
+              <a:t>-</a:t>
+            </a:r>
+            <a:r>
+              <a:rPr sz="1600">
+                <a:solidFill>
+                  <a:srgbClr val="D4D4D4"/>
+                </a:solidFill>
+                <a:latin typeface="Consolas"/>
+              </a:rPr>
+              <a:t>XMF2</a:t>
+            </a:r>
+            <a:r>
+              <a:rPr sz="1600">
+                <a:solidFill>
+                  <a:srgbClr val="D4D4D4"/>
+                </a:solidFill>
+                <a:latin typeface="Consolas"/>
+              </a:rPr>
+              <a:t>)</a:t>
+            </a:r>
+            <a:r>
+              <a:rPr sz="1600">
+                <a:solidFill>
+                  <a:srgbClr val="D4D4D4"/>
+                </a:solidFill>
+                <a:latin typeface="Consolas"/>
+              </a:rPr>
+              <a:t>/</a:t>
+            </a:r>
+            <a:r>
+              <a:rPr sz="1600">
+                <a:solidFill>
+                  <a:srgbClr val="D4D4D4"/>
+                </a:solidFill>
+                <a:latin typeface="Consolas"/>
+              </a:rPr>
+              <a:t>XMF2</a:t>
+            </a:r>
+            <a:r>
+              <a:rPr sz="1600">
+                <a:solidFill>
+                  <a:srgbClr val="D4D4D4"/>
+                </a:solidFill>
+                <a:latin typeface="Consolas"/>
+              </a:rPr>
+              <a:t>)</a:t>
+            </a:r>
+            <a:r>
+              <a:rPr sz="1600">
+                <a:solidFill>
+                  <a:srgbClr val="D4D4D4"/>
+                </a:solidFill>
+                <a:latin typeface="Consolas"/>
+              </a:rPr>
+              <a:t>*</a:t>
+            </a:r>
+            <a:r>
+              <a:rPr sz="1600">
+                <a:solidFill>
+                  <a:srgbClr val="4EC9B0"/>
+                </a:solidFill>
+                <a:latin typeface="Consolas"/>
+              </a:rPr>
+              <a:t>exp</a:t>
+            </a:r>
+            <a:r>
+              <a:rPr sz="1600">
+                <a:solidFill>
+                  <a:srgbClr val="D4D4D4"/>
+                </a:solidFill>
+                <a:latin typeface="Consolas"/>
+              </a:rPr>
+              <a:t>(</a:t>
+            </a:r>
+            <a:r>
+              <a:rPr sz="1600">
+                <a:solidFill>
+                  <a:srgbClr val="D4D4D4"/>
+                </a:solidFill>
+                <a:latin typeface="Consolas"/>
+              </a:rPr>
+              <a:t>DELV2</a:t>
+            </a:r>
+            <a:r>
+              <a:rPr sz="1600">
+                <a:solidFill>
+                  <a:srgbClr val="D4D4D4"/>
+                </a:solidFill>
+                <a:latin typeface="Consolas"/>
+              </a:rPr>
+              <a:t>/</a:t>
+            </a:r>
+            <a:r>
+              <a:rPr sz="1600">
+                <a:solidFill>
+                  <a:srgbClr val="D4D4D4"/>
+                </a:solidFill>
+                <a:latin typeface="Consolas"/>
+              </a:rPr>
+              <a:t>(</a:t>
+            </a:r>
+            <a:r>
+              <a:rPr sz="1600">
+                <a:solidFill>
+                  <a:srgbClr val="D4D4D4"/>
+                </a:solidFill>
+                <a:latin typeface="Consolas"/>
+              </a:rPr>
+              <a:t>XISP2</a:t>
+            </a:r>
+            <a:r>
+              <a:rPr sz="1600">
+                <a:solidFill>
+                  <a:srgbClr val="D4D4D4"/>
+                </a:solidFill>
+                <a:latin typeface="Consolas"/>
+              </a:rPr>
+              <a:t>*</a:t>
+            </a:r>
+            <a:r>
+              <a:rPr sz="1600">
+                <a:solidFill>
+                  <a:srgbClr val="B5CEA8"/>
+                </a:solidFill>
+                <a:latin typeface="Consolas"/>
+              </a:rPr>
+              <a:t>32.2</a:t>
+            </a:r>
+            <a:r>
+              <a:rPr sz="1600">
+                <a:solidFill>
+                  <a:srgbClr val="D4D4D4"/>
+                </a:solidFill>
+                <a:latin typeface="Consolas"/>
+              </a:rPr>
+              <a:t>)</a:t>
+            </a:r>
+            <a:r>
+              <a:rPr sz="1600">
+                <a:solidFill>
+                  <a:srgbClr val="D4D4D4"/>
+                </a:solidFill>
+                <a:latin typeface="Consolas"/>
+              </a:rPr>
+              <a:t>)</a:t>
+            </a:r>
+            <a:r>
+              <a:rPr sz="1600">
+                <a:solidFill>
+                  <a:srgbClr val="D4D4D4"/>
+                </a:solidFill>
+                <a:latin typeface="Consolas"/>
+              </a:rPr>
+              <a:t>;</a:t>
+            </a:r>
+          </a:p>
+          <a:p>
+            <a:pPr>
+              <a:spcAft>
+                <a:spcPts val="100"/>
+              </a:spcAft>
+            </a:pPr>
+            <a:r>
+              <a:rPr sz="1600">
+                <a:solidFill>
+                  <a:srgbClr val="D4D4D4"/>
+                </a:solidFill>
+                <a:latin typeface="Consolas"/>
+              </a:rPr>
+              <a:t>WP2</a:t>
+            </a:r>
+            <a:r>
+              <a:rPr sz="1600">
+                <a:solidFill>
+                  <a:srgbClr val="D4D4D4"/>
+                </a:solidFill>
+                <a:latin typeface="Consolas"/>
+              </a:rPr>
+              <a:t>=</a:t>
+            </a:r>
+            <a:r>
+              <a:rPr sz="1600">
+                <a:solidFill>
+                  <a:srgbClr val="D4D4D4"/>
+                </a:solidFill>
+                <a:latin typeface="Consolas"/>
+              </a:rPr>
+              <a:t>TOP2</a:t>
+            </a:r>
+            <a:r>
+              <a:rPr sz="1600">
+                <a:solidFill>
+                  <a:srgbClr val="D4D4D4"/>
+                </a:solidFill>
+                <a:latin typeface="Consolas"/>
+              </a:rPr>
+              <a:t>/</a:t>
+            </a:r>
+            <a:r>
+              <a:rPr sz="1600">
+                <a:solidFill>
+                  <a:srgbClr val="D4D4D4"/>
+                </a:solidFill>
+                <a:latin typeface="Consolas"/>
+              </a:rPr>
+              <a:t>BOT2</a:t>
+            </a:r>
+            <a:r>
+              <a:rPr sz="1600">
+                <a:solidFill>
+                  <a:srgbClr val="D4D4D4"/>
+                </a:solidFill>
+                <a:latin typeface="Consolas"/>
+              </a:rPr>
+              <a:t>;</a:t>
+            </a:r>
+            <a:r>
+              <a:rPr sz="1600">
+                <a:solidFill>
+                  <a:srgbClr val="D4D4D4"/>
+                </a:solidFill>
+                <a:latin typeface="Consolas"/>
+              </a:rPr>
+              <a:t>   </a:t>
+            </a:r>
+            <a:r>
+              <a:rPr sz="1600">
+                <a:solidFill>
+                  <a:srgbClr val="D4D4D4"/>
+                </a:solidFill>
+                <a:latin typeface="Consolas"/>
+              </a:rPr>
+              <a:t>WS2</a:t>
+            </a:r>
+            <a:r>
+              <a:rPr sz="1600">
+                <a:solidFill>
+                  <a:srgbClr val="D4D4D4"/>
+                </a:solidFill>
+                <a:latin typeface="Consolas"/>
+              </a:rPr>
+              <a:t>=</a:t>
+            </a:r>
+            <a:r>
+              <a:rPr sz="1600">
+                <a:solidFill>
+                  <a:srgbClr val="D4D4D4"/>
+                </a:solidFill>
+                <a:latin typeface="Consolas"/>
+              </a:rPr>
+              <a:t>WP2</a:t>
+            </a:r>
+            <a:r>
+              <a:rPr sz="1600">
+                <a:solidFill>
+                  <a:srgbClr val="D4D4D4"/>
+                </a:solidFill>
+                <a:latin typeface="Consolas"/>
+              </a:rPr>
+              <a:t>*</a:t>
+            </a:r>
+            <a:r>
+              <a:rPr sz="1600">
+                <a:solidFill>
+                  <a:srgbClr val="D4D4D4"/>
+                </a:solidFill>
+                <a:latin typeface="Consolas"/>
+              </a:rPr>
+              <a:t>(</a:t>
+            </a:r>
+            <a:r>
+              <a:rPr sz="1600">
+                <a:solidFill>
+                  <a:srgbClr val="B5CEA8"/>
+                </a:solidFill>
+                <a:latin typeface="Consolas"/>
+              </a:rPr>
+              <a:t>1</a:t>
+            </a:r>
+            <a:r>
+              <a:rPr sz="1600">
+                <a:solidFill>
+                  <a:srgbClr val="D4D4D4"/>
+                </a:solidFill>
+                <a:latin typeface="Consolas"/>
+              </a:rPr>
+              <a:t>-</a:t>
+            </a:r>
+            <a:r>
+              <a:rPr sz="1600">
+                <a:solidFill>
+                  <a:srgbClr val="D4D4D4"/>
+                </a:solidFill>
+                <a:latin typeface="Consolas"/>
+              </a:rPr>
+              <a:t>XMF2</a:t>
+            </a:r>
+            <a:r>
+              <a:rPr sz="1600">
+                <a:solidFill>
+                  <a:srgbClr val="D4D4D4"/>
+                </a:solidFill>
+                <a:latin typeface="Consolas"/>
+              </a:rPr>
+              <a:t>)</a:t>
+            </a:r>
+            <a:r>
+              <a:rPr sz="1600">
+                <a:solidFill>
+                  <a:srgbClr val="D4D4D4"/>
+                </a:solidFill>
+                <a:latin typeface="Consolas"/>
+              </a:rPr>
+              <a:t>/</a:t>
+            </a:r>
+            <a:r>
+              <a:rPr sz="1600">
+                <a:solidFill>
+                  <a:srgbClr val="D4D4D4"/>
+                </a:solidFill>
+                <a:latin typeface="Consolas"/>
+              </a:rPr>
+              <a:t>XMF2</a:t>
+            </a:r>
+            <a:r>
+              <a:rPr sz="1600">
+                <a:solidFill>
+                  <a:srgbClr val="D4D4D4"/>
+                </a:solidFill>
+                <a:latin typeface="Consolas"/>
+              </a:rPr>
+              <a:t>;</a:t>
+            </a:r>
+            <a:r>
+              <a:rPr sz="1600">
+                <a:solidFill>
+                  <a:srgbClr val="D4D4D4"/>
+                </a:solidFill>
+                <a:latin typeface="Consolas"/>
+              </a:rPr>
+              <a:t>   </a:t>
+            </a:r>
+            <a:r>
+              <a:rPr sz="1600">
+                <a:solidFill>
+                  <a:srgbClr val="D4D4D4"/>
+                </a:solidFill>
+                <a:latin typeface="Consolas"/>
+              </a:rPr>
+              <a:t>WTOT2</a:t>
+            </a:r>
+            <a:r>
+              <a:rPr sz="1600">
+                <a:solidFill>
+                  <a:srgbClr val="D4D4D4"/>
+                </a:solidFill>
+                <a:latin typeface="Consolas"/>
+              </a:rPr>
+              <a:t>=</a:t>
+            </a:r>
+            <a:r>
+              <a:rPr sz="1600">
+                <a:solidFill>
+                  <a:srgbClr val="D4D4D4"/>
+                </a:solidFill>
+                <a:latin typeface="Consolas"/>
+              </a:rPr>
+              <a:t>WP2</a:t>
+            </a:r>
+            <a:r>
+              <a:rPr sz="1600">
+                <a:solidFill>
+                  <a:srgbClr val="D4D4D4"/>
+                </a:solidFill>
+                <a:latin typeface="Consolas"/>
+              </a:rPr>
+              <a:t>+</a:t>
+            </a:r>
+            <a:r>
+              <a:rPr sz="1600">
+                <a:solidFill>
+                  <a:srgbClr val="D4D4D4"/>
+                </a:solidFill>
+                <a:latin typeface="Consolas"/>
+              </a:rPr>
+              <a:t>WS2</a:t>
+            </a:r>
+            <a:r>
+              <a:rPr sz="1600">
+                <a:solidFill>
+                  <a:srgbClr val="D4D4D4"/>
+                </a:solidFill>
+                <a:latin typeface="Consolas"/>
+              </a:rPr>
+              <a:t>+</a:t>
+            </a:r>
+            <a:r>
+              <a:rPr sz="1600">
+                <a:solidFill>
+                  <a:srgbClr val="D4D4D4"/>
+                </a:solidFill>
+                <a:latin typeface="Consolas"/>
+              </a:rPr>
+              <a:t>WPAY</a:t>
+            </a:r>
+            <a:r>
+              <a:rPr sz="1600">
+                <a:solidFill>
+                  <a:srgbClr val="D4D4D4"/>
+                </a:solidFill>
+                <a:latin typeface="Consolas"/>
+              </a:rPr>
+              <a:t>;</a:t>
+            </a:r>
+          </a:p>
+          <a:p>
+            <a:pPr>
+              <a:spcAft>
+                <a:spcPts val="100"/>
+              </a:spcAft>
+            </a:pPr>
+            <a:r>
+              <a:rPr sz="1600">
+                <a:solidFill>
+                  <a:srgbClr val="D4D4D4"/>
+                </a:solidFill>
+                <a:latin typeface="Consolas"/>
+              </a:rPr>
+              <a:t>TRST2</a:t>
+            </a:r>
+            <a:r>
+              <a:rPr sz="1600">
+                <a:solidFill>
+                  <a:srgbClr val="D4D4D4"/>
+                </a:solidFill>
+                <a:latin typeface="Consolas"/>
+              </a:rPr>
+              <a:t>=</a:t>
+            </a:r>
+            <a:r>
+              <a:rPr sz="1600">
+                <a:solidFill>
+                  <a:srgbClr val="D4D4D4"/>
+                </a:solidFill>
+                <a:latin typeface="Consolas"/>
+              </a:rPr>
+              <a:t>AMAX2</a:t>
+            </a:r>
+            <a:r>
+              <a:rPr sz="1600">
+                <a:solidFill>
+                  <a:srgbClr val="D4D4D4"/>
+                </a:solidFill>
+                <a:latin typeface="Consolas"/>
+              </a:rPr>
+              <a:t>*</a:t>
+            </a:r>
+            <a:r>
+              <a:rPr sz="1600">
+                <a:solidFill>
+                  <a:srgbClr val="D4D4D4"/>
+                </a:solidFill>
+                <a:latin typeface="Consolas"/>
+              </a:rPr>
+              <a:t>(</a:t>
+            </a:r>
+            <a:r>
+              <a:rPr sz="1600">
+                <a:solidFill>
+                  <a:srgbClr val="D4D4D4"/>
+                </a:solidFill>
+                <a:latin typeface="Consolas"/>
+              </a:rPr>
+              <a:t>WPAY</a:t>
+            </a:r>
+            <a:r>
+              <a:rPr sz="1600">
+                <a:solidFill>
+                  <a:srgbClr val="D4D4D4"/>
+                </a:solidFill>
+                <a:latin typeface="Consolas"/>
+              </a:rPr>
+              <a:t>+</a:t>
+            </a:r>
+            <a:r>
+              <a:rPr sz="1600">
+                <a:solidFill>
+                  <a:srgbClr val="D4D4D4"/>
+                </a:solidFill>
+                <a:latin typeface="Consolas"/>
+              </a:rPr>
+              <a:t>WS2</a:t>
+            </a:r>
+            <a:r>
+              <a:rPr sz="1600">
+                <a:solidFill>
+                  <a:srgbClr val="D4D4D4"/>
+                </a:solidFill>
+                <a:latin typeface="Consolas"/>
+              </a:rPr>
+              <a:t>)</a:t>
+            </a:r>
+            <a:r>
+              <a:rPr sz="1600">
+                <a:solidFill>
+                  <a:srgbClr val="D4D4D4"/>
+                </a:solidFill>
+                <a:latin typeface="Consolas"/>
+              </a:rPr>
+              <a:t>;</a:t>
+            </a:r>
+            <a:r>
+              <a:rPr sz="1600">
+                <a:solidFill>
+                  <a:srgbClr val="D4D4D4"/>
+                </a:solidFill>
+                <a:latin typeface="Consolas"/>
+              </a:rPr>
+              <a:t>   </a:t>
+            </a:r>
+            <a:r>
+              <a:rPr sz="1600">
+                <a:solidFill>
+                  <a:srgbClr val="D4D4D4"/>
+                </a:solidFill>
+                <a:latin typeface="Consolas"/>
+              </a:rPr>
+              <a:t>TB2</a:t>
+            </a:r>
+            <a:r>
+              <a:rPr sz="1600">
+                <a:solidFill>
+                  <a:srgbClr val="D4D4D4"/>
+                </a:solidFill>
+                <a:latin typeface="Consolas"/>
+              </a:rPr>
+              <a:t>=</a:t>
+            </a:r>
+            <a:r>
+              <a:rPr sz="1600">
+                <a:solidFill>
+                  <a:srgbClr val="D4D4D4"/>
+                </a:solidFill>
+                <a:latin typeface="Consolas"/>
+              </a:rPr>
+              <a:t>XISP2</a:t>
+            </a:r>
+            <a:r>
+              <a:rPr sz="1600">
+                <a:solidFill>
+                  <a:srgbClr val="D4D4D4"/>
+                </a:solidFill>
+                <a:latin typeface="Consolas"/>
+              </a:rPr>
+              <a:t>*</a:t>
+            </a:r>
+            <a:r>
+              <a:rPr sz="1600">
+                <a:solidFill>
+                  <a:srgbClr val="D4D4D4"/>
+                </a:solidFill>
+                <a:latin typeface="Consolas"/>
+              </a:rPr>
+              <a:t>WP2</a:t>
+            </a:r>
+            <a:r>
+              <a:rPr sz="1600">
+                <a:solidFill>
+                  <a:srgbClr val="D4D4D4"/>
+                </a:solidFill>
+                <a:latin typeface="Consolas"/>
+              </a:rPr>
+              <a:t>/</a:t>
+            </a:r>
+            <a:r>
+              <a:rPr sz="1600">
+                <a:solidFill>
+                  <a:srgbClr val="D4D4D4"/>
+                </a:solidFill>
+                <a:latin typeface="Consolas"/>
+              </a:rPr>
+              <a:t>TRST2</a:t>
+            </a:r>
+            <a:r>
+              <a:rPr sz="1600">
+                <a:solidFill>
+                  <a:srgbClr val="D4D4D4"/>
+                </a:solidFill>
+                <a:latin typeface="Consolas"/>
+              </a:rPr>
+              <a:t>;</a:t>
+            </a:r>
+          </a:p>
+          <a:p>
+            <a:pPr>
+              <a:spcAft>
+                <a:spcPts val="100"/>
+              </a:spcAft>
+            </a:pPr>
+            <a:r>
+              <a:rPr sz="1600">
+                <a:solidFill>
+                  <a:srgbClr val="6A9955"/>
+                </a:solidFill>
+                <a:latin typeface="Consolas"/>
+              </a:rPr>
+              <a:t>% ... then TOP1,BOT1,WP1,WS1,WTOT,TRST1,TB1 -- same again for stage 1</a:t>
+            </a:r>
+          </a:p>
+        </p:txBody>
+      </p:sp>
+      <p:sp>
+        <p:nvSpPr>
+          <p:cNvPr id="9" name="TextBox 8"/>
+          <p:cNvSpPr txBox="1"/>
+          <p:nvPr/>
+        </p:nvSpPr>
+        <p:spPr>
+          <a:xfrm>
+            <a:off x="777240" y="4617720"/>
+            <a:ext cx="10972800" cy="274320"/>
+          </a:xfrm>
+          <a:prstGeom prst="rect">
+            <a:avLst/>
+          </a:prstGeom>
+          <a:noFill/>
+        </p:spPr>
+        <p:txBody>
+          <a:bodyPr wrap="none">
+            <a:spAutoFit/>
+          </a:bodyPr>
+          <a:lstStyle/>
+          <a:p>
+            <a:r>
+              <a:rPr sz="1200" i="1">
+                <a:solidFill>
+                  <a:srgbClr val="8CA3B8"/>
+                </a:solidFill>
+                <a:latin typeface="Segoe UI"/>
+              </a:rPr>
+              <a:t>Zarchan, Tactical &amp; Strategic Missile Guidance, 6th ed. (MATLAB) — gravity-turn booster sim</a:t>
+            </a:r>
+          </a:p>
+        </p:txBody>
+      </p:sp>
     </p:spTree>
   </p:cSld>
   <p:clrMapOvr>
@@ -24910,6 +26371,1828 @@
 </file>
 
 <file path=ppt/slides/slide38.xml><?xml version="1.0" encoding="utf-8"?>
+<p:sld xmlns:a="http://schemas.openxmlformats.org/drawingml/2006/main" xmlns:p="http://schemas.openxmlformats.org/presentationml/2006/main" xmlns:r="http://schemas.openxmlformats.org/officeDocument/2006/relationships">
+  <p:cSld>
+    <p:bg>
+      <p:bgPr>
+        <a:solidFill>
+          <a:srgbClr val="0B1F33"/>
+        </a:solidFill>
+        <a:effectLst/>
+      </p:bgPr>
+    </p:bg>
+    <p:spTree>
+      <p:nvGrpSpPr>
+        <p:cNvPr id="1" name=""/>
+        <p:cNvGrpSpPr/>
+        <p:nvPr/>
+      </p:nvGrpSpPr>
+      <p:grpSpPr/>
+      <p:sp>
+        <p:nvSpPr>
+          <p:cNvPr id="2" name="TextBox 1"/>
+          <p:cNvSpPr txBox="1"/>
+          <p:nvPr/>
+        </p:nvSpPr>
+        <p:spPr>
+          <a:xfrm>
+            <a:off x="502920" y="384048"/>
+            <a:ext cx="11155680" cy="292608"/>
+          </a:xfrm>
+          <a:prstGeom prst="rect">
+            <a:avLst/>
+          </a:prstGeom>
+          <a:noFill/>
+        </p:spPr>
+        <p:txBody>
+          <a:bodyPr wrap="none">
+            <a:spAutoFit/>
+          </a:bodyPr>
+          <a:lstStyle/>
+          <a:p>
+            <a:r>
+              <a:rPr sz="1300" b="1">
+                <a:solidFill>
+                  <a:srgbClr val="F2C744"/>
+                </a:solidFill>
+                <a:latin typeface="Segoe UI"/>
+              </a:rPr>
+              <a:t>A SHORT HISTORY LESSON</a:t>
+            </a:r>
+          </a:p>
+        </p:txBody>
+      </p:sp>
+      <p:sp>
+        <p:nvSpPr>
+          <p:cNvPr id="3" name="TextBox 2"/>
+          <p:cNvSpPr txBox="1"/>
+          <p:nvPr/>
+        </p:nvSpPr>
+        <p:spPr>
+          <a:xfrm>
+            <a:off x="457200" y="694944"/>
+            <a:ext cx="11247120" cy="777240"/>
+          </a:xfrm>
+          <a:prstGeom prst="rect">
+            <a:avLst/>
+          </a:prstGeom>
+          <a:noFill/>
+        </p:spPr>
+        <p:txBody>
+          <a:bodyPr wrap="none">
+            <a:spAutoFit/>
+          </a:bodyPr>
+          <a:lstStyle/>
+          <a:p>
+            <a:r>
+              <a:rPr sz="3100" b="1">
+                <a:solidFill>
+                  <a:srgbClr val="FFFFFF"/>
+                </a:solidFill>
+                <a:latin typeface="Segoe UI"/>
+              </a:rPr>
+              <a:t>One loop, every variable global</a:t>
+            </a:r>
+          </a:p>
+        </p:txBody>
+      </p:sp>
+      <p:sp>
+        <p:nvSpPr>
+          <p:cNvPr id="4" name="Rounded Rectangle 3"/>
+          <p:cNvSpPr/>
+          <p:nvPr/>
+        </p:nvSpPr>
+        <p:spPr>
+          <a:xfrm>
+            <a:off x="548640" y="1463040"/>
+            <a:ext cx="11338560" cy="3767328"/>
+          </a:xfrm>
+          <a:prstGeom prst="roundRect">
+            <a:avLst>
+              <a:gd name="adj" fmla="val 10000"/>
+            </a:avLst>
+          </a:prstGeom>
+          <a:solidFill>
+            <a:srgbClr val="081626"/>
+          </a:solidFill>
+          <a:ln w="12700">
+            <a:solidFill>
+              <a:srgbClr val="1E3A55"/>
+            </a:solidFill>
+          </a:ln>
+          <a:effectLst/>
+        </p:spPr>
+        <p:style>
+          <a:lnRef idx="1">
+            <a:schemeClr val="accent1"/>
+          </a:lnRef>
+          <a:fillRef idx="3">
+            <a:schemeClr val="accent1"/>
+          </a:fillRef>
+          <a:effectRef idx="2">
+            <a:schemeClr val="accent1"/>
+          </a:effectRef>
+          <a:fontRef idx="minor">
+            <a:schemeClr val="lt1"/>
+          </a:fontRef>
+        </p:style>
+        <p:txBody>
+          <a:bodyPr wrap="square" rtlCol="0" anchor="ctr"/>
+          <a:lstStyle/>
+          <a:p>
+            <a:pPr algn="ctr"/>
+          </a:p>
+        </p:txBody>
+      </p:sp>
+      <p:sp>
+        <p:nvSpPr>
+          <p:cNvPr id="6" name="TextBox 5"/>
+          <p:cNvSpPr txBox="1"/>
+          <p:nvPr/>
+        </p:nvSpPr>
+        <p:spPr>
+          <a:xfrm>
+            <a:off x="411480" y="6446520"/>
+            <a:ext cx="10058400" cy="320040"/>
+          </a:xfrm>
+          <a:prstGeom prst="rect">
+            <a:avLst/>
+          </a:prstGeom>
+          <a:noFill/>
+        </p:spPr>
+        <p:txBody>
+          <a:bodyPr wrap="none">
+            <a:spAutoFit/>
+          </a:bodyPr>
+          <a:lstStyle/>
+          <a:p>
+            <a:r>
+              <a:rPr sz="1000">
+                <a:solidFill>
+                  <a:srgbClr val="8CA3B8"/>
+                </a:solidFill>
+                <a:latin typeface="Segoe UI"/>
+              </a:rPr>
+              <a:t>Separation of Concerns at Zero Cost — ACCU on Sea 2026</a:t>
+            </a:r>
+          </a:p>
+        </p:txBody>
+      </p:sp>
+      <p:sp>
+        <p:nvSpPr>
+          <p:cNvPr id="7" name="TextBox 6"/>
+          <p:cNvSpPr txBox="1"/>
+          <p:nvPr/>
+        </p:nvSpPr>
+        <p:spPr>
+          <a:xfrm>
+            <a:off x="11384280" y="6446520"/>
+            <a:ext cx="548640" cy="320040"/>
+          </a:xfrm>
+          <a:prstGeom prst="rect">
+            <a:avLst/>
+          </a:prstGeom>
+          <a:noFill/>
+        </p:spPr>
+        <p:txBody>
+          <a:bodyPr wrap="none">
+            <a:spAutoFit/>
+          </a:bodyPr>
+          <a:lstStyle/>
+          <a:p>
+            <a:pPr algn="r"/>
+            <a:r>
+              <a:rPr sz="1000">
+                <a:solidFill>
+                  <a:srgbClr val="8CA3B8"/>
+                </a:solidFill>
+                <a:latin typeface="Segoe UI"/>
+              </a:rPr>
+              <a:t>38</a:t>
+            </a:r>
+          </a:p>
+        </p:txBody>
+      </p:sp>
+      <p:sp>
+        <p:nvSpPr>
+          <p:cNvPr id="8" name="zarchan loop"/>
+          <p:cNvSpPr txBox="1"/>
+          <p:nvPr/>
+        </p:nvSpPr>
+        <p:spPr>
+          <a:xfrm>
+            <a:off x="777240" y="1600200"/>
+            <a:ext cx="10881360" cy="3566160"/>
+          </a:xfrm>
+          <a:prstGeom prst="rect">
+            <a:avLst/>
+          </a:prstGeom>
+          <a:noFill/>
+        </p:spPr>
+        <p:txBody>
+          <a:bodyPr wrap="none">
+            <a:spAutoFit/>
+          </a:bodyPr>
+          <a:lstStyle/>
+          <a:p>
+            <a:pPr>
+              <a:spcAft>
+                <a:spcPts val="100"/>
+              </a:spcAft>
+            </a:pPr>
+            <a:r>
+              <a:rPr sz="1600">
+                <a:solidFill>
+                  <a:srgbClr val="569CD6"/>
+                </a:solidFill>
+                <a:latin typeface="Consolas"/>
+              </a:rPr>
+              <a:t>while</a:t>
+            </a:r>
+            <a:r>
+              <a:rPr sz="1600">
+                <a:solidFill>
+                  <a:srgbClr val="D4D4D4"/>
+                </a:solidFill>
+                <a:latin typeface="Consolas"/>
+              </a:rPr>
+              <a:t> </a:t>
+            </a:r>
+            <a:r>
+              <a:rPr sz="1600">
+                <a:solidFill>
+                  <a:srgbClr val="D4D4D4"/>
+                </a:solidFill>
+                <a:latin typeface="Consolas"/>
+              </a:rPr>
+              <a:t>~</a:t>
+            </a:r>
+            <a:r>
+              <a:rPr sz="1600">
+                <a:solidFill>
+                  <a:srgbClr val="D4D4D4"/>
+                </a:solidFill>
+                <a:latin typeface="Consolas"/>
+              </a:rPr>
+              <a:t>(</a:t>
+            </a:r>
+            <a:r>
+              <a:rPr sz="1600">
+                <a:solidFill>
+                  <a:srgbClr val="D4D4D4"/>
+                </a:solidFill>
+                <a:latin typeface="Consolas"/>
+              </a:rPr>
+              <a:t>ALT</a:t>
+            </a:r>
+            <a:r>
+              <a:rPr sz="1600">
+                <a:solidFill>
+                  <a:srgbClr val="D4D4D4"/>
+                </a:solidFill>
+                <a:latin typeface="Consolas"/>
+              </a:rPr>
+              <a:t>&lt;</a:t>
+            </a:r>
+            <a:r>
+              <a:rPr sz="1600">
+                <a:solidFill>
+                  <a:srgbClr val="B5CEA8"/>
+                </a:solidFill>
+                <a:latin typeface="Consolas"/>
+              </a:rPr>
+              <a:t>0</a:t>
+            </a:r>
+            <a:r>
+              <a:rPr sz="1600">
+                <a:solidFill>
+                  <a:srgbClr val="D4D4D4"/>
+                </a:solidFill>
+                <a:latin typeface="Consolas"/>
+              </a:rPr>
+              <a:t> </a:t>
+            </a:r>
+            <a:r>
+              <a:rPr sz="1600">
+                <a:solidFill>
+                  <a:srgbClr val="D4D4D4"/>
+                </a:solidFill>
+                <a:latin typeface="Consolas"/>
+              </a:rPr>
+              <a:t>&amp;</a:t>
+            </a:r>
+            <a:r>
+              <a:rPr sz="1600">
+                <a:solidFill>
+                  <a:srgbClr val="D4D4D4"/>
+                </a:solidFill>
+                <a:latin typeface="Consolas"/>
+              </a:rPr>
+              <a:t> </a:t>
+            </a:r>
+            <a:r>
+              <a:rPr sz="1600">
+                <a:solidFill>
+                  <a:srgbClr val="D4D4D4"/>
+                </a:solidFill>
+                <a:latin typeface="Consolas"/>
+              </a:rPr>
+              <a:t>T</a:t>
+            </a:r>
+            <a:r>
+              <a:rPr sz="1600">
+                <a:solidFill>
+                  <a:srgbClr val="D4D4D4"/>
+                </a:solidFill>
+                <a:latin typeface="Consolas"/>
+              </a:rPr>
+              <a:t>&gt;</a:t>
+            </a:r>
+            <a:r>
+              <a:rPr sz="1600">
+                <a:solidFill>
+                  <a:srgbClr val="B5CEA8"/>
+                </a:solidFill>
+                <a:latin typeface="Consolas"/>
+              </a:rPr>
+              <a:t>10</a:t>
+            </a:r>
+            <a:r>
+              <a:rPr sz="1600">
+                <a:solidFill>
+                  <a:srgbClr val="D4D4D4"/>
+                </a:solidFill>
+                <a:latin typeface="Consolas"/>
+              </a:rPr>
+              <a:t>)</a:t>
+            </a:r>
+          </a:p>
+          <a:p>
+            <a:pPr>
+              <a:spcAft>
+                <a:spcPts val="100"/>
+              </a:spcAft>
+            </a:pPr>
+            <a:r>
+              <a:rPr sz="1600">
+                <a:solidFill>
+                  <a:srgbClr val="D4D4D4"/>
+                </a:solidFill>
+                <a:latin typeface="Consolas"/>
+              </a:rPr>
+              <a:t>    </a:t>
+            </a:r>
+            <a:r>
+              <a:rPr sz="1600">
+                <a:solidFill>
+                  <a:srgbClr val="569CD6"/>
+                </a:solidFill>
+                <a:latin typeface="Consolas"/>
+              </a:rPr>
+              <a:t>if</a:t>
+            </a:r>
+            <a:r>
+              <a:rPr sz="1600">
+                <a:solidFill>
+                  <a:srgbClr val="D4D4D4"/>
+                </a:solidFill>
+                <a:latin typeface="Consolas"/>
+              </a:rPr>
+              <a:t> </a:t>
+            </a:r>
+            <a:r>
+              <a:rPr sz="1600">
+                <a:solidFill>
+                  <a:srgbClr val="D4D4D4"/>
+                </a:solidFill>
+                <a:latin typeface="Consolas"/>
+              </a:rPr>
+              <a:t>T</a:t>
+            </a:r>
+            <a:r>
+              <a:rPr sz="1600">
+                <a:solidFill>
+                  <a:srgbClr val="D4D4D4"/>
+                </a:solidFill>
+                <a:latin typeface="Consolas"/>
+              </a:rPr>
+              <a:t>&lt;</a:t>
+            </a:r>
+            <a:r>
+              <a:rPr sz="1600">
+                <a:solidFill>
+                  <a:srgbClr val="D4D4D4"/>
+                </a:solidFill>
+                <a:latin typeface="Consolas"/>
+              </a:rPr>
+              <a:t>TB1</a:t>
+            </a:r>
+          </a:p>
+          <a:p>
+            <a:pPr>
+              <a:spcAft>
+                <a:spcPts val="100"/>
+              </a:spcAft>
+            </a:pPr>
+            <a:r>
+              <a:rPr sz="1600">
+                <a:solidFill>
+                  <a:srgbClr val="D4D4D4"/>
+                </a:solidFill>
+                <a:latin typeface="Consolas"/>
+              </a:rPr>
+              <a:t>        </a:t>
+            </a:r>
+            <a:r>
+              <a:rPr sz="1600">
+                <a:solidFill>
+                  <a:srgbClr val="D4D4D4"/>
+                </a:solidFill>
+                <a:latin typeface="Consolas"/>
+              </a:rPr>
+              <a:t>WGT</a:t>
+            </a:r>
+            <a:r>
+              <a:rPr sz="1600">
+                <a:solidFill>
+                  <a:srgbClr val="D4D4D4"/>
+                </a:solidFill>
+                <a:latin typeface="Consolas"/>
+              </a:rPr>
+              <a:t>=</a:t>
+            </a:r>
+            <a:r>
+              <a:rPr sz="1600">
+                <a:solidFill>
+                  <a:srgbClr val="D4D4D4"/>
+                </a:solidFill>
+                <a:latin typeface="Consolas"/>
+              </a:rPr>
+              <a:t>-</a:t>
+            </a:r>
+            <a:r>
+              <a:rPr sz="1600">
+                <a:solidFill>
+                  <a:srgbClr val="D4D4D4"/>
+                </a:solidFill>
+                <a:latin typeface="Consolas"/>
+              </a:rPr>
+              <a:t>WP1</a:t>
+            </a:r>
+            <a:r>
+              <a:rPr sz="1600">
+                <a:solidFill>
+                  <a:srgbClr val="D4D4D4"/>
+                </a:solidFill>
+                <a:latin typeface="Consolas"/>
+              </a:rPr>
+              <a:t>*</a:t>
+            </a:r>
+            <a:r>
+              <a:rPr sz="1600">
+                <a:solidFill>
+                  <a:srgbClr val="D4D4D4"/>
+                </a:solidFill>
+                <a:latin typeface="Consolas"/>
+              </a:rPr>
+              <a:t>T</a:t>
+            </a:r>
+            <a:r>
+              <a:rPr sz="1600">
+                <a:solidFill>
+                  <a:srgbClr val="D4D4D4"/>
+                </a:solidFill>
+                <a:latin typeface="Consolas"/>
+              </a:rPr>
+              <a:t>/</a:t>
+            </a:r>
+            <a:r>
+              <a:rPr sz="1600">
+                <a:solidFill>
+                  <a:srgbClr val="D4D4D4"/>
+                </a:solidFill>
+                <a:latin typeface="Consolas"/>
+              </a:rPr>
+              <a:t>TB1</a:t>
+            </a:r>
+            <a:r>
+              <a:rPr sz="1600">
+                <a:solidFill>
+                  <a:srgbClr val="D4D4D4"/>
+                </a:solidFill>
+                <a:latin typeface="Consolas"/>
+              </a:rPr>
+              <a:t>+</a:t>
+            </a:r>
+            <a:r>
+              <a:rPr sz="1600">
+                <a:solidFill>
+                  <a:srgbClr val="D4D4D4"/>
+                </a:solidFill>
+                <a:latin typeface="Consolas"/>
+              </a:rPr>
+              <a:t>WTOT</a:t>
+            </a:r>
+            <a:r>
+              <a:rPr sz="1600">
+                <a:solidFill>
+                  <a:srgbClr val="D4D4D4"/>
+                </a:solidFill>
+                <a:latin typeface="Consolas"/>
+              </a:rPr>
+              <a:t>;</a:t>
+            </a:r>
+            <a:r>
+              <a:rPr sz="1600">
+                <a:solidFill>
+                  <a:srgbClr val="D4D4D4"/>
+                </a:solidFill>
+                <a:latin typeface="Consolas"/>
+              </a:rPr>
+              <a:t>   </a:t>
+            </a:r>
+            <a:r>
+              <a:rPr sz="1600">
+                <a:solidFill>
+                  <a:srgbClr val="D4D4D4"/>
+                </a:solidFill>
+                <a:latin typeface="Consolas"/>
+              </a:rPr>
+              <a:t>TRST</a:t>
+            </a:r>
+            <a:r>
+              <a:rPr sz="1600">
+                <a:solidFill>
+                  <a:srgbClr val="D4D4D4"/>
+                </a:solidFill>
+                <a:latin typeface="Consolas"/>
+              </a:rPr>
+              <a:t>=</a:t>
+            </a:r>
+            <a:r>
+              <a:rPr sz="1600">
+                <a:solidFill>
+                  <a:srgbClr val="D4D4D4"/>
+                </a:solidFill>
+                <a:latin typeface="Consolas"/>
+              </a:rPr>
+              <a:t>TRST1</a:t>
+            </a:r>
+            <a:r>
+              <a:rPr sz="1600">
+                <a:solidFill>
+                  <a:srgbClr val="D4D4D4"/>
+                </a:solidFill>
+                <a:latin typeface="Consolas"/>
+              </a:rPr>
+              <a:t>;</a:t>
+            </a:r>
+          </a:p>
+          <a:p>
+            <a:pPr>
+              <a:spcAft>
+                <a:spcPts val="100"/>
+              </a:spcAft>
+            </a:pPr>
+            <a:r>
+              <a:rPr sz="1600">
+                <a:solidFill>
+                  <a:srgbClr val="D4D4D4"/>
+                </a:solidFill>
+                <a:latin typeface="Consolas"/>
+              </a:rPr>
+              <a:t>    </a:t>
+            </a:r>
+            <a:r>
+              <a:rPr sz="1600">
+                <a:solidFill>
+                  <a:srgbClr val="569CD6"/>
+                </a:solidFill>
+                <a:latin typeface="Consolas"/>
+              </a:rPr>
+              <a:t>elseif</a:t>
+            </a:r>
+            <a:r>
+              <a:rPr sz="1600">
+                <a:solidFill>
+                  <a:srgbClr val="D4D4D4"/>
+                </a:solidFill>
+                <a:latin typeface="Consolas"/>
+              </a:rPr>
+              <a:t> </a:t>
+            </a:r>
+            <a:r>
+              <a:rPr sz="1600">
+                <a:solidFill>
+                  <a:srgbClr val="D4D4D4"/>
+                </a:solidFill>
+                <a:latin typeface="Consolas"/>
+              </a:rPr>
+              <a:t>T</a:t>
+            </a:r>
+            <a:r>
+              <a:rPr sz="1600">
+                <a:solidFill>
+                  <a:srgbClr val="D4D4D4"/>
+                </a:solidFill>
+                <a:latin typeface="Consolas"/>
+              </a:rPr>
+              <a:t>&lt;</a:t>
+            </a:r>
+            <a:r>
+              <a:rPr sz="1600">
+                <a:solidFill>
+                  <a:srgbClr val="D4D4D4"/>
+                </a:solidFill>
+                <a:latin typeface="Consolas"/>
+              </a:rPr>
+              <a:t>(</a:t>
+            </a:r>
+            <a:r>
+              <a:rPr sz="1600">
+                <a:solidFill>
+                  <a:srgbClr val="D4D4D4"/>
+                </a:solidFill>
+                <a:latin typeface="Consolas"/>
+              </a:rPr>
+              <a:t>TB1</a:t>
+            </a:r>
+            <a:r>
+              <a:rPr sz="1600">
+                <a:solidFill>
+                  <a:srgbClr val="D4D4D4"/>
+                </a:solidFill>
+                <a:latin typeface="Consolas"/>
+              </a:rPr>
+              <a:t>+</a:t>
+            </a:r>
+            <a:r>
+              <a:rPr sz="1600">
+                <a:solidFill>
+                  <a:srgbClr val="D4D4D4"/>
+                </a:solidFill>
+                <a:latin typeface="Consolas"/>
+              </a:rPr>
+              <a:t>TB2</a:t>
+            </a:r>
+            <a:r>
+              <a:rPr sz="1600">
+                <a:solidFill>
+                  <a:srgbClr val="D4D4D4"/>
+                </a:solidFill>
+                <a:latin typeface="Consolas"/>
+              </a:rPr>
+              <a:t>)</a:t>
+            </a:r>
+          </a:p>
+          <a:p>
+            <a:pPr>
+              <a:spcAft>
+                <a:spcPts val="100"/>
+              </a:spcAft>
+            </a:pPr>
+            <a:r>
+              <a:rPr sz="1600">
+                <a:solidFill>
+                  <a:srgbClr val="D4D4D4"/>
+                </a:solidFill>
+                <a:latin typeface="Consolas"/>
+              </a:rPr>
+              <a:t>        </a:t>
+            </a:r>
+            <a:r>
+              <a:rPr sz="1600">
+                <a:solidFill>
+                  <a:srgbClr val="D4D4D4"/>
+                </a:solidFill>
+                <a:latin typeface="Consolas"/>
+              </a:rPr>
+              <a:t>WGT</a:t>
+            </a:r>
+            <a:r>
+              <a:rPr sz="1600">
+                <a:solidFill>
+                  <a:srgbClr val="D4D4D4"/>
+                </a:solidFill>
+                <a:latin typeface="Consolas"/>
+              </a:rPr>
+              <a:t>=</a:t>
+            </a:r>
+            <a:r>
+              <a:rPr sz="1600">
+                <a:solidFill>
+                  <a:srgbClr val="D4D4D4"/>
+                </a:solidFill>
+                <a:latin typeface="Consolas"/>
+              </a:rPr>
+              <a:t>-</a:t>
+            </a:r>
+            <a:r>
+              <a:rPr sz="1600">
+                <a:solidFill>
+                  <a:srgbClr val="D4D4D4"/>
+                </a:solidFill>
+                <a:latin typeface="Consolas"/>
+              </a:rPr>
+              <a:t>WP2</a:t>
+            </a:r>
+            <a:r>
+              <a:rPr sz="1600">
+                <a:solidFill>
+                  <a:srgbClr val="D4D4D4"/>
+                </a:solidFill>
+                <a:latin typeface="Consolas"/>
+              </a:rPr>
+              <a:t>*</a:t>
+            </a:r>
+            <a:r>
+              <a:rPr sz="1600">
+                <a:solidFill>
+                  <a:srgbClr val="D4D4D4"/>
+                </a:solidFill>
+                <a:latin typeface="Consolas"/>
+              </a:rPr>
+              <a:t>T</a:t>
+            </a:r>
+            <a:r>
+              <a:rPr sz="1600">
+                <a:solidFill>
+                  <a:srgbClr val="D4D4D4"/>
+                </a:solidFill>
+                <a:latin typeface="Consolas"/>
+              </a:rPr>
+              <a:t>/</a:t>
+            </a:r>
+            <a:r>
+              <a:rPr sz="1600">
+                <a:solidFill>
+                  <a:srgbClr val="D4D4D4"/>
+                </a:solidFill>
+                <a:latin typeface="Consolas"/>
+              </a:rPr>
+              <a:t>TB2</a:t>
+            </a:r>
+            <a:r>
+              <a:rPr sz="1600">
+                <a:solidFill>
+                  <a:srgbClr val="D4D4D4"/>
+                </a:solidFill>
+                <a:latin typeface="Consolas"/>
+              </a:rPr>
+              <a:t>+</a:t>
+            </a:r>
+            <a:r>
+              <a:rPr sz="1600">
+                <a:solidFill>
+                  <a:srgbClr val="D4D4D4"/>
+                </a:solidFill>
+                <a:latin typeface="Consolas"/>
+              </a:rPr>
+              <a:t>WTOT2</a:t>
+            </a:r>
+            <a:r>
+              <a:rPr sz="1600">
+                <a:solidFill>
+                  <a:srgbClr val="D4D4D4"/>
+                </a:solidFill>
+                <a:latin typeface="Consolas"/>
+              </a:rPr>
+              <a:t>+</a:t>
+            </a:r>
+            <a:r>
+              <a:rPr sz="1600">
+                <a:solidFill>
+                  <a:srgbClr val="D4D4D4"/>
+                </a:solidFill>
+                <a:latin typeface="Consolas"/>
+              </a:rPr>
+              <a:t>WP2</a:t>
+            </a:r>
+            <a:r>
+              <a:rPr sz="1600">
+                <a:solidFill>
+                  <a:srgbClr val="D4D4D4"/>
+                </a:solidFill>
+                <a:latin typeface="Consolas"/>
+              </a:rPr>
+              <a:t>*</a:t>
+            </a:r>
+            <a:r>
+              <a:rPr sz="1600">
+                <a:solidFill>
+                  <a:srgbClr val="D4D4D4"/>
+                </a:solidFill>
+                <a:latin typeface="Consolas"/>
+              </a:rPr>
+              <a:t>TB1</a:t>
+            </a:r>
+            <a:r>
+              <a:rPr sz="1600">
+                <a:solidFill>
+                  <a:srgbClr val="D4D4D4"/>
+                </a:solidFill>
+                <a:latin typeface="Consolas"/>
+              </a:rPr>
+              <a:t>/</a:t>
+            </a:r>
+            <a:r>
+              <a:rPr sz="1600">
+                <a:solidFill>
+                  <a:srgbClr val="D4D4D4"/>
+                </a:solidFill>
+                <a:latin typeface="Consolas"/>
+              </a:rPr>
+              <a:t>TB2</a:t>
+            </a:r>
+            <a:r>
+              <a:rPr sz="1600">
+                <a:solidFill>
+                  <a:srgbClr val="D4D4D4"/>
+                </a:solidFill>
+                <a:latin typeface="Consolas"/>
+              </a:rPr>
+              <a:t>;</a:t>
+            </a:r>
+            <a:r>
+              <a:rPr sz="1600">
+                <a:solidFill>
+                  <a:srgbClr val="D4D4D4"/>
+                </a:solidFill>
+                <a:latin typeface="Consolas"/>
+              </a:rPr>
+              <a:t>   </a:t>
+            </a:r>
+            <a:r>
+              <a:rPr sz="1600">
+                <a:solidFill>
+                  <a:srgbClr val="D4D4D4"/>
+                </a:solidFill>
+                <a:latin typeface="Consolas"/>
+              </a:rPr>
+              <a:t>TRST</a:t>
+            </a:r>
+            <a:r>
+              <a:rPr sz="1600">
+                <a:solidFill>
+                  <a:srgbClr val="D4D4D4"/>
+                </a:solidFill>
+                <a:latin typeface="Consolas"/>
+              </a:rPr>
+              <a:t>=</a:t>
+            </a:r>
+            <a:r>
+              <a:rPr sz="1600">
+                <a:solidFill>
+                  <a:srgbClr val="D4D4D4"/>
+                </a:solidFill>
+                <a:latin typeface="Consolas"/>
+              </a:rPr>
+              <a:t>TRST2</a:t>
+            </a:r>
+            <a:r>
+              <a:rPr sz="1600">
+                <a:solidFill>
+                  <a:srgbClr val="D4D4D4"/>
+                </a:solidFill>
+                <a:latin typeface="Consolas"/>
+              </a:rPr>
+              <a:t>;</a:t>
+            </a:r>
+          </a:p>
+          <a:p>
+            <a:pPr>
+              <a:spcAft>
+                <a:spcPts val="100"/>
+              </a:spcAft>
+            </a:pPr>
+            <a:r>
+              <a:rPr sz="1600">
+                <a:solidFill>
+                  <a:srgbClr val="D4D4D4"/>
+                </a:solidFill>
+                <a:latin typeface="Consolas"/>
+              </a:rPr>
+              <a:t>    </a:t>
+            </a:r>
+            <a:r>
+              <a:rPr sz="1600">
+                <a:solidFill>
+                  <a:srgbClr val="569CD6"/>
+                </a:solidFill>
+                <a:latin typeface="Consolas"/>
+              </a:rPr>
+              <a:t>else</a:t>
+            </a:r>
+          </a:p>
+          <a:p>
+            <a:pPr>
+              <a:spcAft>
+                <a:spcPts val="100"/>
+              </a:spcAft>
+            </a:pPr>
+            <a:r>
+              <a:rPr sz="1600">
+                <a:solidFill>
+                  <a:srgbClr val="D4D4D4"/>
+                </a:solidFill>
+                <a:latin typeface="Consolas"/>
+              </a:rPr>
+              <a:t>        </a:t>
+            </a:r>
+            <a:r>
+              <a:rPr sz="1600">
+                <a:solidFill>
+                  <a:srgbClr val="D4D4D4"/>
+                </a:solidFill>
+                <a:latin typeface="Consolas"/>
+              </a:rPr>
+              <a:t>WGT</a:t>
+            </a:r>
+            <a:r>
+              <a:rPr sz="1600">
+                <a:solidFill>
+                  <a:srgbClr val="D4D4D4"/>
+                </a:solidFill>
+                <a:latin typeface="Consolas"/>
+              </a:rPr>
+              <a:t>=</a:t>
+            </a:r>
+            <a:r>
+              <a:rPr sz="1600">
+                <a:solidFill>
+                  <a:srgbClr val="D4D4D4"/>
+                </a:solidFill>
+                <a:latin typeface="Consolas"/>
+              </a:rPr>
+              <a:t>WPAY</a:t>
+            </a:r>
+            <a:r>
+              <a:rPr sz="1600">
+                <a:solidFill>
+                  <a:srgbClr val="D4D4D4"/>
+                </a:solidFill>
+                <a:latin typeface="Consolas"/>
+              </a:rPr>
+              <a:t>;</a:t>
+            </a:r>
+            <a:r>
+              <a:rPr sz="1600">
+                <a:solidFill>
+                  <a:srgbClr val="D4D4D4"/>
+                </a:solidFill>
+                <a:latin typeface="Consolas"/>
+              </a:rPr>
+              <a:t>   </a:t>
+            </a:r>
+            <a:r>
+              <a:rPr sz="1600">
+                <a:solidFill>
+                  <a:srgbClr val="D4D4D4"/>
+                </a:solidFill>
+                <a:latin typeface="Consolas"/>
+              </a:rPr>
+              <a:t>TRST</a:t>
+            </a:r>
+            <a:r>
+              <a:rPr sz="1600">
+                <a:solidFill>
+                  <a:srgbClr val="D4D4D4"/>
+                </a:solidFill>
+                <a:latin typeface="Consolas"/>
+              </a:rPr>
+              <a:t>=</a:t>
+            </a:r>
+            <a:r>
+              <a:rPr sz="1600">
+                <a:solidFill>
+                  <a:srgbClr val="B5CEA8"/>
+                </a:solidFill>
+                <a:latin typeface="Consolas"/>
+              </a:rPr>
+              <a:t>0.</a:t>
+            </a:r>
+            <a:r>
+              <a:rPr sz="1600">
+                <a:solidFill>
+                  <a:srgbClr val="D4D4D4"/>
+                </a:solidFill>
+                <a:latin typeface="Consolas"/>
+              </a:rPr>
+              <a:t>;</a:t>
+            </a:r>
+          </a:p>
+          <a:p>
+            <a:pPr>
+              <a:spcAft>
+                <a:spcPts val="100"/>
+              </a:spcAft>
+            </a:pPr>
+            <a:r>
+              <a:rPr sz="1600">
+                <a:solidFill>
+                  <a:srgbClr val="D4D4D4"/>
+                </a:solidFill>
+                <a:latin typeface="Consolas"/>
+              </a:rPr>
+              <a:t>    </a:t>
+            </a:r>
+            <a:r>
+              <a:rPr sz="1600">
+                <a:solidFill>
+                  <a:srgbClr val="569CD6"/>
+                </a:solidFill>
+                <a:latin typeface="Consolas"/>
+              </a:rPr>
+              <a:t>end</a:t>
+            </a:r>
+          </a:p>
+          <a:p>
+            <a:pPr>
+              <a:spcAft>
+                <a:spcPts val="100"/>
+              </a:spcAft>
+            </a:pPr>
+            <a:r>
+              <a:rPr sz="1600">
+                <a:solidFill>
+                  <a:srgbClr val="D4D4D4"/>
+                </a:solidFill>
+                <a:latin typeface="Consolas"/>
+              </a:rPr>
+              <a:t>    </a:t>
+            </a:r>
+            <a:r>
+              <a:rPr sz="1600">
+                <a:solidFill>
+                  <a:srgbClr val="D4D4D4"/>
+                </a:solidFill>
+                <a:latin typeface="Consolas"/>
+              </a:rPr>
+              <a:t>AT</a:t>
+            </a:r>
+            <a:r>
+              <a:rPr sz="1600">
+                <a:solidFill>
+                  <a:srgbClr val="D4D4D4"/>
+                </a:solidFill>
+                <a:latin typeface="Consolas"/>
+              </a:rPr>
+              <a:t>=</a:t>
+            </a:r>
+            <a:r>
+              <a:rPr sz="1600">
+                <a:solidFill>
+                  <a:srgbClr val="B5CEA8"/>
+                </a:solidFill>
+                <a:latin typeface="Consolas"/>
+              </a:rPr>
+              <a:t>32.2</a:t>
+            </a:r>
+            <a:r>
+              <a:rPr sz="1600">
+                <a:solidFill>
+                  <a:srgbClr val="D4D4D4"/>
+                </a:solidFill>
+                <a:latin typeface="Consolas"/>
+              </a:rPr>
+              <a:t>*</a:t>
+            </a:r>
+            <a:r>
+              <a:rPr sz="1600">
+                <a:solidFill>
+                  <a:srgbClr val="D4D4D4"/>
+                </a:solidFill>
+                <a:latin typeface="Consolas"/>
+              </a:rPr>
+              <a:t>TRST</a:t>
+            </a:r>
+            <a:r>
+              <a:rPr sz="1600">
+                <a:solidFill>
+                  <a:srgbClr val="D4D4D4"/>
+                </a:solidFill>
+                <a:latin typeface="Consolas"/>
+              </a:rPr>
+              <a:t>/</a:t>
+            </a:r>
+            <a:r>
+              <a:rPr sz="1600">
+                <a:solidFill>
+                  <a:srgbClr val="D4D4D4"/>
+                </a:solidFill>
+                <a:latin typeface="Consolas"/>
+              </a:rPr>
+              <a:t>WGT</a:t>
+            </a:r>
+            <a:r>
+              <a:rPr sz="1600">
+                <a:solidFill>
+                  <a:srgbClr val="D4D4D4"/>
+                </a:solidFill>
+                <a:latin typeface="Consolas"/>
+              </a:rPr>
+              <a:t>;</a:t>
+            </a:r>
+            <a:r>
+              <a:rPr sz="1600">
+                <a:solidFill>
+                  <a:srgbClr val="D4D4D4"/>
+                </a:solidFill>
+                <a:latin typeface="Consolas"/>
+              </a:rPr>
+              <a:t>   </a:t>
+            </a:r>
+            <a:r>
+              <a:rPr sz="1600">
+                <a:solidFill>
+                  <a:srgbClr val="D4D4D4"/>
+                </a:solidFill>
+                <a:latin typeface="Consolas"/>
+              </a:rPr>
+              <a:t>VEL</a:t>
+            </a:r>
+            <a:r>
+              <a:rPr sz="1600">
+                <a:solidFill>
+                  <a:srgbClr val="D4D4D4"/>
+                </a:solidFill>
+                <a:latin typeface="Consolas"/>
+              </a:rPr>
+              <a:t>=</a:t>
+            </a:r>
+            <a:r>
+              <a:rPr sz="1600">
+                <a:solidFill>
+                  <a:srgbClr val="4EC9B0"/>
+                </a:solidFill>
+                <a:latin typeface="Consolas"/>
+              </a:rPr>
+              <a:t>sqrt</a:t>
+            </a:r>
+            <a:r>
+              <a:rPr sz="1600">
+                <a:solidFill>
+                  <a:srgbClr val="D4D4D4"/>
+                </a:solidFill>
+                <a:latin typeface="Consolas"/>
+              </a:rPr>
+              <a:t>(</a:t>
+            </a:r>
+            <a:r>
+              <a:rPr sz="1600">
+                <a:solidFill>
+                  <a:srgbClr val="D4D4D4"/>
+                </a:solidFill>
+                <a:latin typeface="Consolas"/>
+              </a:rPr>
+              <a:t>X1</a:t>
+            </a:r>
+            <a:r>
+              <a:rPr sz="1600">
+                <a:solidFill>
+                  <a:srgbClr val="D4D4D4"/>
+                </a:solidFill>
+                <a:latin typeface="Consolas"/>
+              </a:rPr>
+              <a:t>^</a:t>
+            </a:r>
+            <a:r>
+              <a:rPr sz="1600">
+                <a:solidFill>
+                  <a:srgbClr val="B5CEA8"/>
+                </a:solidFill>
+                <a:latin typeface="Consolas"/>
+              </a:rPr>
+              <a:t>2</a:t>
+            </a:r>
+            <a:r>
+              <a:rPr sz="1600">
+                <a:solidFill>
+                  <a:srgbClr val="D4D4D4"/>
+                </a:solidFill>
+                <a:latin typeface="Consolas"/>
+              </a:rPr>
+              <a:t>+</a:t>
+            </a:r>
+            <a:r>
+              <a:rPr sz="1600">
+                <a:solidFill>
+                  <a:srgbClr val="D4D4D4"/>
+                </a:solidFill>
+                <a:latin typeface="Consolas"/>
+              </a:rPr>
+              <a:t>Y1</a:t>
+            </a:r>
+            <a:r>
+              <a:rPr sz="1600">
+                <a:solidFill>
+                  <a:srgbClr val="D4D4D4"/>
+                </a:solidFill>
+                <a:latin typeface="Consolas"/>
+              </a:rPr>
+              <a:t>^</a:t>
+            </a:r>
+            <a:r>
+              <a:rPr sz="1600">
+                <a:solidFill>
+                  <a:srgbClr val="B5CEA8"/>
+                </a:solidFill>
+                <a:latin typeface="Consolas"/>
+              </a:rPr>
+              <a:t>2</a:t>
+            </a:r>
+            <a:r>
+              <a:rPr sz="1600">
+                <a:solidFill>
+                  <a:srgbClr val="D4D4D4"/>
+                </a:solidFill>
+                <a:latin typeface="Consolas"/>
+              </a:rPr>
+              <a:t>)</a:t>
+            </a:r>
+            <a:r>
+              <a:rPr sz="1600">
+                <a:solidFill>
+                  <a:srgbClr val="D4D4D4"/>
+                </a:solidFill>
+                <a:latin typeface="Consolas"/>
+              </a:rPr>
+              <a:t>;</a:t>
+            </a:r>
+          </a:p>
+          <a:p>
+            <a:pPr>
+              <a:spcAft>
+                <a:spcPts val="100"/>
+              </a:spcAft>
+            </a:pPr>
+            <a:r>
+              <a:rPr sz="1600">
+                <a:solidFill>
+                  <a:srgbClr val="D4D4D4"/>
+                </a:solidFill>
+                <a:latin typeface="Consolas"/>
+              </a:rPr>
+              <a:t>    </a:t>
+            </a:r>
+            <a:r>
+              <a:rPr sz="1600">
+                <a:solidFill>
+                  <a:srgbClr val="D4D4D4"/>
+                </a:solidFill>
+                <a:latin typeface="Consolas"/>
+              </a:rPr>
+              <a:t>TEMBOT</a:t>
+            </a:r>
+            <a:r>
+              <a:rPr sz="1600">
+                <a:solidFill>
+                  <a:srgbClr val="D4D4D4"/>
+                </a:solidFill>
+                <a:latin typeface="Consolas"/>
+              </a:rPr>
+              <a:t>=</a:t>
+            </a:r>
+            <a:r>
+              <a:rPr sz="1600">
+                <a:solidFill>
+                  <a:srgbClr val="D4D4D4"/>
+                </a:solidFill>
+                <a:latin typeface="Consolas"/>
+              </a:rPr>
+              <a:t>(</a:t>
+            </a:r>
+            <a:r>
+              <a:rPr sz="1600">
+                <a:solidFill>
+                  <a:srgbClr val="D4D4D4"/>
+                </a:solidFill>
+                <a:latin typeface="Consolas"/>
+              </a:rPr>
+              <a:t>X</a:t>
+            </a:r>
+            <a:r>
+              <a:rPr sz="1600">
+                <a:solidFill>
+                  <a:srgbClr val="D4D4D4"/>
+                </a:solidFill>
+                <a:latin typeface="Consolas"/>
+              </a:rPr>
+              <a:t>^</a:t>
+            </a:r>
+            <a:r>
+              <a:rPr sz="1600">
+                <a:solidFill>
+                  <a:srgbClr val="B5CEA8"/>
+                </a:solidFill>
+                <a:latin typeface="Consolas"/>
+              </a:rPr>
+              <a:t>2</a:t>
+            </a:r>
+            <a:r>
+              <a:rPr sz="1600">
+                <a:solidFill>
+                  <a:srgbClr val="D4D4D4"/>
+                </a:solidFill>
+                <a:latin typeface="Consolas"/>
+              </a:rPr>
+              <a:t>+</a:t>
+            </a:r>
+            <a:r>
+              <a:rPr sz="1600">
+                <a:solidFill>
+                  <a:srgbClr val="D4D4D4"/>
+                </a:solidFill>
+                <a:latin typeface="Consolas"/>
+              </a:rPr>
+              <a:t>Y</a:t>
+            </a:r>
+            <a:r>
+              <a:rPr sz="1600">
+                <a:solidFill>
+                  <a:srgbClr val="D4D4D4"/>
+                </a:solidFill>
+                <a:latin typeface="Consolas"/>
+              </a:rPr>
+              <a:t>^</a:t>
+            </a:r>
+            <a:r>
+              <a:rPr sz="1600">
+                <a:solidFill>
+                  <a:srgbClr val="B5CEA8"/>
+                </a:solidFill>
+                <a:latin typeface="Consolas"/>
+              </a:rPr>
+              <a:t>2</a:t>
+            </a:r>
+            <a:r>
+              <a:rPr sz="1600">
+                <a:solidFill>
+                  <a:srgbClr val="D4D4D4"/>
+                </a:solidFill>
+                <a:latin typeface="Consolas"/>
+              </a:rPr>
+              <a:t>)</a:t>
+            </a:r>
+            <a:r>
+              <a:rPr sz="1600">
+                <a:solidFill>
+                  <a:srgbClr val="D4D4D4"/>
+                </a:solidFill>
+                <a:latin typeface="Consolas"/>
+              </a:rPr>
+              <a:t>^</a:t>
+            </a:r>
+            <a:r>
+              <a:rPr sz="1600">
+                <a:solidFill>
+                  <a:srgbClr val="B5CEA8"/>
+                </a:solidFill>
+                <a:latin typeface="Consolas"/>
+              </a:rPr>
+              <a:t>1.5</a:t>
+            </a:r>
+            <a:r>
+              <a:rPr sz="1600">
+                <a:solidFill>
+                  <a:srgbClr val="D4D4D4"/>
+                </a:solidFill>
+                <a:latin typeface="Consolas"/>
+              </a:rPr>
+              <a:t>;</a:t>
+            </a:r>
+          </a:p>
+          <a:p>
+            <a:pPr>
+              <a:spcAft>
+                <a:spcPts val="100"/>
+              </a:spcAft>
+            </a:pPr>
+            <a:r>
+              <a:rPr sz="1600">
+                <a:solidFill>
+                  <a:srgbClr val="D4D4D4"/>
+                </a:solidFill>
+                <a:latin typeface="Consolas"/>
+              </a:rPr>
+              <a:t>    </a:t>
+            </a:r>
+            <a:r>
+              <a:rPr sz="1600">
+                <a:solidFill>
+                  <a:srgbClr val="D4D4D4"/>
+                </a:solidFill>
+                <a:latin typeface="Consolas"/>
+              </a:rPr>
+              <a:t>X1D</a:t>
+            </a:r>
+            <a:r>
+              <a:rPr sz="1600">
+                <a:solidFill>
+                  <a:srgbClr val="D4D4D4"/>
+                </a:solidFill>
+                <a:latin typeface="Consolas"/>
+              </a:rPr>
+              <a:t>=</a:t>
+            </a:r>
+            <a:r>
+              <a:rPr sz="1600">
+                <a:solidFill>
+                  <a:srgbClr val="D4D4D4"/>
+                </a:solidFill>
+                <a:latin typeface="Consolas"/>
+              </a:rPr>
+              <a:t>-</a:t>
+            </a:r>
+            <a:r>
+              <a:rPr sz="1600">
+                <a:solidFill>
+                  <a:srgbClr val="D4D4D4"/>
+                </a:solidFill>
+                <a:latin typeface="Consolas"/>
+              </a:rPr>
+              <a:t>GM</a:t>
+            </a:r>
+            <a:r>
+              <a:rPr sz="1600">
+                <a:solidFill>
+                  <a:srgbClr val="D4D4D4"/>
+                </a:solidFill>
+                <a:latin typeface="Consolas"/>
+              </a:rPr>
+              <a:t>*</a:t>
+            </a:r>
+            <a:r>
+              <a:rPr sz="1600">
+                <a:solidFill>
+                  <a:srgbClr val="D4D4D4"/>
+                </a:solidFill>
+                <a:latin typeface="Consolas"/>
+              </a:rPr>
+              <a:t>X</a:t>
+            </a:r>
+            <a:r>
+              <a:rPr sz="1600">
+                <a:solidFill>
+                  <a:srgbClr val="D4D4D4"/>
+                </a:solidFill>
+                <a:latin typeface="Consolas"/>
+              </a:rPr>
+              <a:t>/</a:t>
+            </a:r>
+            <a:r>
+              <a:rPr sz="1600">
+                <a:solidFill>
+                  <a:srgbClr val="D4D4D4"/>
+                </a:solidFill>
+                <a:latin typeface="Consolas"/>
+              </a:rPr>
+              <a:t>TEMBOT</a:t>
+            </a:r>
+            <a:r>
+              <a:rPr sz="1600">
+                <a:solidFill>
+                  <a:srgbClr val="D4D4D4"/>
+                </a:solidFill>
+                <a:latin typeface="Consolas"/>
+              </a:rPr>
+              <a:t>+</a:t>
+            </a:r>
+            <a:r>
+              <a:rPr sz="1600">
+                <a:solidFill>
+                  <a:srgbClr val="D4D4D4"/>
+                </a:solidFill>
+                <a:latin typeface="Consolas"/>
+              </a:rPr>
+              <a:t>AT</a:t>
+            </a:r>
+            <a:r>
+              <a:rPr sz="1600">
+                <a:solidFill>
+                  <a:srgbClr val="D4D4D4"/>
+                </a:solidFill>
+                <a:latin typeface="Consolas"/>
+              </a:rPr>
+              <a:t>*</a:t>
+            </a:r>
+            <a:r>
+              <a:rPr sz="1600">
+                <a:solidFill>
+                  <a:srgbClr val="D4D4D4"/>
+                </a:solidFill>
+                <a:latin typeface="Consolas"/>
+              </a:rPr>
+              <a:t>X1</a:t>
+            </a:r>
+            <a:r>
+              <a:rPr sz="1600">
+                <a:solidFill>
+                  <a:srgbClr val="D4D4D4"/>
+                </a:solidFill>
+                <a:latin typeface="Consolas"/>
+              </a:rPr>
+              <a:t>/</a:t>
+            </a:r>
+            <a:r>
+              <a:rPr sz="1600">
+                <a:solidFill>
+                  <a:srgbClr val="D4D4D4"/>
+                </a:solidFill>
+                <a:latin typeface="Consolas"/>
+              </a:rPr>
+              <a:t>VEL</a:t>
+            </a:r>
+            <a:r>
+              <a:rPr sz="1600">
+                <a:solidFill>
+                  <a:srgbClr val="D4D4D4"/>
+                </a:solidFill>
+                <a:latin typeface="Consolas"/>
+              </a:rPr>
+              <a:t>;</a:t>
+            </a:r>
+          </a:p>
+          <a:p>
+            <a:pPr>
+              <a:spcAft>
+                <a:spcPts val="100"/>
+              </a:spcAft>
+            </a:pPr>
+            <a:r>
+              <a:rPr sz="1600">
+                <a:solidFill>
+                  <a:srgbClr val="D4D4D4"/>
+                </a:solidFill>
+                <a:latin typeface="Consolas"/>
+              </a:rPr>
+              <a:t>    </a:t>
+            </a:r>
+            <a:r>
+              <a:rPr sz="1600">
+                <a:solidFill>
+                  <a:srgbClr val="D4D4D4"/>
+                </a:solidFill>
+                <a:latin typeface="Consolas"/>
+              </a:rPr>
+              <a:t>Y1D</a:t>
+            </a:r>
+            <a:r>
+              <a:rPr sz="1600">
+                <a:solidFill>
+                  <a:srgbClr val="D4D4D4"/>
+                </a:solidFill>
+                <a:latin typeface="Consolas"/>
+              </a:rPr>
+              <a:t>=</a:t>
+            </a:r>
+            <a:r>
+              <a:rPr sz="1600">
+                <a:solidFill>
+                  <a:srgbClr val="D4D4D4"/>
+                </a:solidFill>
+                <a:latin typeface="Consolas"/>
+              </a:rPr>
+              <a:t>-</a:t>
+            </a:r>
+            <a:r>
+              <a:rPr sz="1600">
+                <a:solidFill>
+                  <a:srgbClr val="D4D4D4"/>
+                </a:solidFill>
+                <a:latin typeface="Consolas"/>
+              </a:rPr>
+              <a:t>GM</a:t>
+            </a:r>
+            <a:r>
+              <a:rPr sz="1600">
+                <a:solidFill>
+                  <a:srgbClr val="D4D4D4"/>
+                </a:solidFill>
+                <a:latin typeface="Consolas"/>
+              </a:rPr>
+              <a:t>*</a:t>
+            </a:r>
+            <a:r>
+              <a:rPr sz="1600">
+                <a:solidFill>
+                  <a:srgbClr val="D4D4D4"/>
+                </a:solidFill>
+                <a:latin typeface="Consolas"/>
+              </a:rPr>
+              <a:t>Y</a:t>
+            </a:r>
+            <a:r>
+              <a:rPr sz="1600">
+                <a:solidFill>
+                  <a:srgbClr val="D4D4D4"/>
+                </a:solidFill>
+                <a:latin typeface="Consolas"/>
+              </a:rPr>
+              <a:t>/</a:t>
+            </a:r>
+            <a:r>
+              <a:rPr sz="1600">
+                <a:solidFill>
+                  <a:srgbClr val="D4D4D4"/>
+                </a:solidFill>
+                <a:latin typeface="Consolas"/>
+              </a:rPr>
+              <a:t>TEMBOT</a:t>
+            </a:r>
+            <a:r>
+              <a:rPr sz="1600">
+                <a:solidFill>
+                  <a:srgbClr val="D4D4D4"/>
+                </a:solidFill>
+                <a:latin typeface="Consolas"/>
+              </a:rPr>
+              <a:t>+</a:t>
+            </a:r>
+            <a:r>
+              <a:rPr sz="1600">
+                <a:solidFill>
+                  <a:srgbClr val="D4D4D4"/>
+                </a:solidFill>
+                <a:latin typeface="Consolas"/>
+              </a:rPr>
+              <a:t>AT</a:t>
+            </a:r>
+            <a:r>
+              <a:rPr sz="1600">
+                <a:solidFill>
+                  <a:srgbClr val="D4D4D4"/>
+                </a:solidFill>
+                <a:latin typeface="Consolas"/>
+              </a:rPr>
+              <a:t>*</a:t>
+            </a:r>
+            <a:r>
+              <a:rPr sz="1600">
+                <a:solidFill>
+                  <a:srgbClr val="D4D4D4"/>
+                </a:solidFill>
+                <a:latin typeface="Consolas"/>
+              </a:rPr>
+              <a:t>Y1</a:t>
+            </a:r>
+            <a:r>
+              <a:rPr sz="1600">
+                <a:solidFill>
+                  <a:srgbClr val="D4D4D4"/>
+                </a:solidFill>
+                <a:latin typeface="Consolas"/>
+              </a:rPr>
+              <a:t>/</a:t>
+            </a:r>
+            <a:r>
+              <a:rPr sz="1600">
+                <a:solidFill>
+                  <a:srgbClr val="D4D4D4"/>
+                </a:solidFill>
+                <a:latin typeface="Consolas"/>
+              </a:rPr>
+              <a:t>VEL</a:t>
+            </a:r>
+            <a:r>
+              <a:rPr sz="1600">
+                <a:solidFill>
+                  <a:srgbClr val="D4D4D4"/>
+                </a:solidFill>
+                <a:latin typeface="Consolas"/>
+              </a:rPr>
+              <a:t>;</a:t>
+            </a:r>
+          </a:p>
+          <a:p>
+            <a:pPr>
+              <a:spcAft>
+                <a:spcPts val="100"/>
+              </a:spcAft>
+            </a:pPr>
+            <a:r>
+              <a:rPr sz="1600">
+                <a:solidFill>
+                  <a:srgbClr val="D4D4D4"/>
+                </a:solidFill>
+                <a:latin typeface="Consolas"/>
+              </a:rPr>
+              <a:t>    </a:t>
+            </a:r>
+            <a:r>
+              <a:rPr sz="1600">
+                <a:solidFill>
+                  <a:srgbClr val="569CD6"/>
+                </a:solidFill>
+                <a:latin typeface="Consolas"/>
+              </a:rPr>
+              <a:t>...</a:t>
+            </a:r>
+            <a:r>
+              <a:rPr sz="1600">
+                <a:solidFill>
+                  <a:srgbClr val="6A9955"/>
+                </a:solidFill>
+                <a:latin typeface="Consolas"/>
+              </a:rPr>
+              <a:t>                          % + Euler step, range/altitude bookkeeping</a:t>
+            </a:r>
+          </a:p>
+          <a:p>
+            <a:pPr>
+              <a:spcAft>
+                <a:spcPts val="100"/>
+              </a:spcAft>
+            </a:pPr>
+            <a:r>
+              <a:rPr sz="1600">
+                <a:solidFill>
+                  <a:srgbClr val="569CD6"/>
+                </a:solidFill>
+                <a:latin typeface="Consolas"/>
+              </a:rPr>
+              <a:t>end</a:t>
+            </a:r>
+          </a:p>
+        </p:txBody>
+      </p:sp>
+      <p:sp>
+        <p:nvSpPr>
+          <p:cNvPr id="9" name="TextBox 8"/>
+          <p:cNvSpPr txBox="1"/>
+          <p:nvPr/>
+        </p:nvSpPr>
+        <p:spPr>
+          <a:xfrm>
+            <a:off x="777240" y="5340096"/>
+            <a:ext cx="10972800" cy="274320"/>
+          </a:xfrm>
+          <a:prstGeom prst="rect">
+            <a:avLst/>
+          </a:prstGeom>
+          <a:noFill/>
+        </p:spPr>
+        <p:txBody>
+          <a:bodyPr wrap="none">
+            <a:spAutoFit/>
+          </a:bodyPr>
+          <a:lstStyle/>
+          <a:p>
+            <a:r>
+              <a:rPr sz="1200" i="1">
+                <a:solidFill>
+                  <a:srgbClr val="8CA3B8"/>
+                </a:solidFill>
+                <a:latin typeface="Segoe UI"/>
+              </a:rPr>
+              <a:t>Zarchan, Tactical &amp; Strategic Missile Guidance, 6th ed. (MATLAB) — gravity-turn booster sim</a:t>
+            </a:r>
+          </a:p>
+        </p:txBody>
+      </p:sp>
+      <p:sp>
+        <p:nvSpPr>
+          <p:cNvPr id="10" name="TextBox 9"/>
+          <p:cNvSpPr txBox="1"/>
+          <p:nvPr/>
+        </p:nvSpPr>
+        <p:spPr>
+          <a:xfrm>
+            <a:off x="777240" y="5669280"/>
+            <a:ext cx="10972800" cy="457200"/>
+          </a:xfrm>
+          <a:prstGeom prst="rect">
+            <a:avLst/>
+          </a:prstGeom>
+          <a:noFill/>
+        </p:spPr>
+        <p:txBody>
+          <a:bodyPr wrap="none">
+            <a:spAutoFit/>
+          </a:bodyPr>
+          <a:lstStyle/>
+          <a:p>
+            <a:r>
+              <a:rPr sz="1900" i="1">
+                <a:solidFill>
+                  <a:srgbClr val="7EE08A"/>
+                </a:solidFill>
+                <a:latin typeface="Segoe UI"/>
+              </a:rPr>
+              <a:t>One scope. Every name global. Physics, staging, and the integrator all tangled together.</a:t>
+            </a:r>
+          </a:p>
+        </p:txBody>
+      </p:sp>
+    </p:spTree>
+  </p:cSld>
+  <p:clrMapOvr>
+    <a:masterClrMapping/>
+  </p:clrMapOvr>
+</p:sld>
+</file>
+
+<file path=ppt/slides/slide39.xml><?xml version="1.0" encoding="utf-8"?>
 <p:sld xmlns:a="http://schemas.openxmlformats.org/drawingml/2006/main" xmlns:r="http://schemas.openxmlformats.org/officeDocument/2006/relationships" xmlns:p="http://schemas.openxmlformats.org/presentationml/2006/main">
   <p:cSld>
     <p:bg>
@@ -25262,363 +28545,6 @@
       <p:sp>
         <p:nvSpPr>
           <p:cNvPr id="7" name="TextBox 6"/>
-          <p:cNvSpPr txBox="1"/>
-          <p:nvPr/>
-        </p:nvSpPr>
-        <p:spPr>
-          <a:xfrm>
-            <a:off x="11384280" y="6446520"/>
-            <a:ext cx="548640" cy="320040"/>
-          </a:xfrm>
-          <a:prstGeom prst="rect">
-            <a:avLst/>
-          </a:prstGeom>
-          <a:noFill/>
-        </p:spPr>
-        <p:txBody>
-          <a:bodyPr wrap="none">
-            <a:spAutoFit/>
-          </a:bodyPr>
-          <a:lstStyle/>
-          <a:p>
-            <a:pPr algn="r"/>
-            <a:r>
-              <a:rPr sz="1000">
-                <a:solidFill>
-                  <a:srgbClr val="8CA3B8"/>
-                </a:solidFill>
-                <a:latin typeface="Segoe UI"/>
-              </a:rPr>
-              <a:t>38</a:t>
-            </a:r>
-          </a:p>
-        </p:txBody>
-      </p:sp>
-    </p:spTree>
-  </p:cSld>
-  <p:clrMapOvr>
-    <a:masterClrMapping/>
-  </p:clrMapOvr>
-</p:sld>
-</file>
-
-<file path=ppt/slides/slide39.xml><?xml version="1.0" encoding="utf-8"?>
-<p:sld xmlns:a="http://schemas.openxmlformats.org/drawingml/2006/main" xmlns:r="http://schemas.openxmlformats.org/officeDocument/2006/relationships" xmlns:p="http://schemas.openxmlformats.org/presentationml/2006/main">
-  <p:cSld>
-    <p:bg>
-      <p:bgPr>
-        <a:solidFill>
-          <a:srgbClr val="0B1F33"/>
-        </a:solidFill>
-        <a:effectLst/>
-      </p:bgPr>
-    </p:bg>
-    <p:spTree>
-      <p:nvGrpSpPr>
-        <p:cNvPr id="1" name=""/>
-        <p:cNvGrpSpPr/>
-        <p:nvPr/>
-      </p:nvGrpSpPr>
-      <p:grpSpPr>
-        <a:xfrm>
-          <a:off x="0" y="0"/>
-          <a:ext cx="0" cy="0"/>
-          <a:chOff x="0" y="0"/>
-          <a:chExt cx="0" cy="0"/>
-        </a:xfrm>
-      </p:grpSpPr>
-      <p:sp>
-        <p:nvSpPr>
-          <p:cNvPr id="2" name="TextBox 1"/>
-          <p:cNvSpPr txBox="1"/>
-          <p:nvPr/>
-        </p:nvSpPr>
-        <p:spPr>
-          <a:xfrm>
-            <a:off x="502920" y="384048"/>
-            <a:ext cx="11155680" cy="292608"/>
-          </a:xfrm>
-          <a:prstGeom prst="rect">
-            <a:avLst/>
-          </a:prstGeom>
-          <a:noFill/>
-        </p:spPr>
-        <p:txBody>
-          <a:bodyPr wrap="none">
-            <a:spAutoFit/>
-          </a:bodyPr>
-          <a:lstStyle/>
-          <a:p>
-            <a:r>
-              <a:rPr sz="1300" b="1">
-                <a:solidFill>
-                  <a:srgbClr val="F2C744"/>
-                </a:solidFill>
-                <a:latin typeface="Segoe UI"/>
-              </a:rPr>
-              <a:t>IF YOU REMEMBER FOUR THINGS</a:t>
-            </a:r>
-          </a:p>
-        </p:txBody>
-      </p:sp>
-      <p:sp>
-        <p:nvSpPr>
-          <p:cNvPr id="3" name="TextBox 2"/>
-          <p:cNvSpPr txBox="1"/>
-          <p:nvPr/>
-        </p:nvSpPr>
-        <p:spPr>
-          <a:xfrm>
-            <a:off x="457200" y="694944"/>
-            <a:ext cx="11247120" cy="777240"/>
-          </a:xfrm>
-          <a:prstGeom prst="rect">
-            <a:avLst/>
-          </a:prstGeom>
-          <a:noFill/>
-        </p:spPr>
-        <p:txBody>
-          <a:bodyPr wrap="none">
-            <a:spAutoFit/>
-          </a:bodyPr>
-          <a:lstStyle/>
-          <a:p>
-            <a:r>
-              <a:rPr sz="3100" b="1">
-                <a:solidFill>
-                  <a:srgbClr val="FFFFFF"/>
-                </a:solidFill>
-                <a:latin typeface="Segoe UI"/>
-              </a:rPr>
-              <a:t>Takeaways</a:t>
-            </a:r>
-          </a:p>
-        </p:txBody>
-      </p:sp>
-      <p:sp>
-        <p:nvSpPr>
-          <p:cNvPr id="4" name="TextBox 3"/>
-          <p:cNvSpPr txBox="1"/>
-          <p:nvPr/>
-        </p:nvSpPr>
-        <p:spPr>
-          <a:xfrm>
-            <a:off x="548640" y="1828800"/>
-            <a:ext cx="11064240" cy="4572000"/>
-          </a:xfrm>
-          <a:prstGeom prst="rect">
-            <a:avLst/>
-          </a:prstGeom>
-          <a:noFill/>
-        </p:spPr>
-        <p:txBody>
-          <a:bodyPr wrap="square">
-            <a:spAutoFit/>
-          </a:bodyPr>
-          <a:lstStyle/>
-          <a:p>
-            <a:pPr>
-              <a:spcAft>
-                <a:spcPts val="800"/>
-              </a:spcAft>
-            </a:pPr>
-            <a:r>
-              <a:rPr sz="2300">
-                <a:solidFill>
-                  <a:srgbClr val="35C4E8"/>
-                </a:solidFill>
-                <a:latin typeface="Segoe UI"/>
-              </a:rPr>
-              <a:t>•  </a:t>
-            </a:r>
-            <a:r>
-              <a:rPr sz="2300" b="1">
-                <a:solidFill>
-                  <a:srgbClr val="F2C744"/>
-                </a:solidFill>
-                <a:latin typeface="Segoe UI"/>
-              </a:rPr>
-              <a:t>Separation of concerns is achievable at zero cost</a:t>
-            </a:r>
-            <a:r>
-              <a:rPr sz="2300" b="0">
-                <a:solidFill>
-                  <a:srgbClr val="D8E2EC"/>
-                </a:solidFill>
-                <a:latin typeface="Segoe UI"/>
-              </a:rPr>
-              <a:t> in C++20 — measured, not asserted</a:t>
-            </a:r>
-          </a:p>
-          <a:p>
-            <a:pPr>
-              <a:spcAft>
-                <a:spcPts val="800"/>
-              </a:spcAft>
-            </a:pPr>
-            <a:r>
-              <a:rPr sz="2300">
-                <a:solidFill>
-                  <a:srgbClr val="35C4E8"/>
-                </a:solidFill>
-                <a:latin typeface="Segoe UI"/>
-              </a:rPr>
-              <a:t>•  </a:t>
-            </a:r>
-            <a:r>
-              <a:rPr sz="2300" b="0">
-                <a:solidFill>
-                  <a:srgbClr val="D8E2EC"/>
-                </a:solidFill>
-                <a:latin typeface="Segoe UI"/>
-              </a:rPr>
-              <a:t>The recipe is small: </a:t>
-            </a:r>
-            <a:r>
-              <a:rPr sz="2300" b="1">
-                <a:solidFill>
-                  <a:srgbClr val="35C4E8"/>
-                </a:solidFill>
-                <a:latin typeface="Segoe UI"/>
-              </a:rPr>
-              <a:t>typed tags + overloaded compute() + a constexpr registry + concepts</a:t>
-            </a:r>
-          </a:p>
-          <a:p>
-            <a:pPr lvl="1">
-              <a:spcBef>
-                <a:spcPts val="0"/>
-              </a:spcBef>
-              <a:spcAft>
-                <a:spcPts val="800"/>
-              </a:spcAft>
-            </a:pPr>
-            <a:r>
-              <a:rPr sz="2100">
-                <a:solidFill>
-                  <a:srgbClr val="8CA3B8"/>
-                </a:solidFill>
-                <a:latin typeface="Segoe UI"/>
-              </a:rPr>
-              <a:t>–  </a:t>
-            </a:r>
-            <a:r>
-              <a:rPr sz="2100" b="0">
-                <a:solidFill>
-                  <a:srgbClr val="D8E2EC"/>
-                </a:solidFill>
-                <a:latin typeface="Segoe UI"/>
-              </a:rPr>
-              <a:t>no inheritance, no virtuals, no strings, no codegen</a:t>
-            </a:r>
-          </a:p>
-          <a:p>
-            <a:pPr>
-              <a:spcAft>
-                <a:spcPts val="800"/>
-              </a:spcAft>
-            </a:pPr>
-            <a:r>
-              <a:rPr sz="2300">
-                <a:solidFill>
-                  <a:srgbClr val="35C4E8"/>
-                </a:solidFill>
-                <a:latin typeface="Segoe UI"/>
-              </a:rPr>
-              <a:t>•  </a:t>
-            </a:r>
-            <a:r>
-              <a:rPr sz="2300" b="1">
-                <a:solidFill>
-                  <a:srgbClr val="FFFFFF"/>
-                </a:solidFill>
-                <a:latin typeface="Segoe UI"/>
-              </a:rPr>
-              <a:t>Prefer abstractions you can verify</a:t>
-            </a:r>
-            <a:r>
-              <a:rPr sz="2300" b="0">
-                <a:solidFill>
-                  <a:srgbClr val="D8E2EC"/>
-                </a:solidFill>
-                <a:latin typeface="Segoe UI"/>
-              </a:rPr>
-              <a:t> — conservation laws and disassembly are unit tests for architecture</a:t>
-            </a:r>
-          </a:p>
-          <a:p>
-            <a:pPr>
-              <a:spcAft>
-                <a:spcPts val="800"/>
-              </a:spcAft>
-            </a:pPr>
-            <a:r>
-              <a:rPr sz="2300">
-                <a:solidFill>
-                  <a:srgbClr val="35C4E8"/>
-                </a:solidFill>
-                <a:latin typeface="Segoe UI"/>
-              </a:rPr>
-              <a:t>•  </a:t>
-            </a:r>
-            <a:r>
-              <a:rPr sz="2300" b="1">
-                <a:solidFill>
-                  <a:srgbClr val="FFFFFF"/>
-                </a:solidFill>
-                <a:latin typeface="Segoe UI"/>
-              </a:rPr>
-              <a:t>Quality vs performance was the false tradeoff</a:t>
-            </a:r>
-            <a:r>
-              <a:rPr sz="2300" b="0">
-                <a:solidFill>
-                  <a:srgbClr val="D8E2EC"/>
-                </a:solidFill>
-                <a:latin typeface="Segoe UI"/>
-              </a:rPr>
-              <a:t> — modern C++ finally lets us refuse it</a:t>
-            </a:r>
-          </a:p>
-        </p:txBody>
-      </p:sp>
-      <p:sp>
-        <p:nvSpPr>
-          <p:cNvPr id="5" name="TextBox 4"/>
-          <p:cNvSpPr txBox="1"/>
-          <p:nvPr/>
-        </p:nvSpPr>
-        <p:spPr>
-          <a:xfrm>
-            <a:off x="411480" y="6446520"/>
-            <a:ext cx="10058400" cy="320040"/>
-          </a:xfrm>
-          <a:prstGeom prst="rect">
-            <a:avLst/>
-          </a:prstGeom>
-          <a:noFill/>
-        </p:spPr>
-        <p:txBody>
-          <a:bodyPr wrap="none">
-            <a:spAutoFit/>
-          </a:bodyPr>
-          <a:lstStyle/>
-          <a:p>
-            <a:r>
-              <a:rPr sz="1000">
-                <a:solidFill>
-                  <a:srgbClr val="8CA3B8"/>
-                </a:solidFill>
-                <a:latin typeface="Segoe UI"/>
-              </a:rPr>
-              <a:t>Separation of Concerns at Zero Cost — ACCU on Sea 2026</a:t>
-            </a:r>
-          </a:p>
-        </p:txBody>
-      </p:sp>
-      <p:sp>
-        <p:nvSpPr>
-          <p:cNvPr id="6" name="TextBox 5"/>
           <p:cNvSpPr txBox="1"/>
           <p:nvPr/>
         </p:nvSpPr>
@@ -26411,6 +29337,363 @@
         </p:nvSpPr>
         <p:spPr>
           <a:xfrm>
+            <a:off x="502920" y="384048"/>
+            <a:ext cx="11155680" cy="292608"/>
+          </a:xfrm>
+          <a:prstGeom prst="rect">
+            <a:avLst/>
+          </a:prstGeom>
+          <a:noFill/>
+        </p:spPr>
+        <p:txBody>
+          <a:bodyPr wrap="none">
+            <a:spAutoFit/>
+          </a:bodyPr>
+          <a:lstStyle/>
+          <a:p>
+            <a:r>
+              <a:rPr sz="1300" b="1">
+                <a:solidFill>
+                  <a:srgbClr val="F2C744"/>
+                </a:solidFill>
+                <a:latin typeface="Segoe UI"/>
+              </a:rPr>
+              <a:t>IF YOU REMEMBER FOUR THINGS</a:t>
+            </a:r>
+          </a:p>
+        </p:txBody>
+      </p:sp>
+      <p:sp>
+        <p:nvSpPr>
+          <p:cNvPr id="3" name="TextBox 2"/>
+          <p:cNvSpPr txBox="1"/>
+          <p:nvPr/>
+        </p:nvSpPr>
+        <p:spPr>
+          <a:xfrm>
+            <a:off x="457200" y="694944"/>
+            <a:ext cx="11247120" cy="777240"/>
+          </a:xfrm>
+          <a:prstGeom prst="rect">
+            <a:avLst/>
+          </a:prstGeom>
+          <a:noFill/>
+        </p:spPr>
+        <p:txBody>
+          <a:bodyPr wrap="none">
+            <a:spAutoFit/>
+          </a:bodyPr>
+          <a:lstStyle/>
+          <a:p>
+            <a:r>
+              <a:rPr sz="3100" b="1">
+                <a:solidFill>
+                  <a:srgbClr val="FFFFFF"/>
+                </a:solidFill>
+                <a:latin typeface="Segoe UI"/>
+              </a:rPr>
+              <a:t>Takeaways</a:t>
+            </a:r>
+          </a:p>
+        </p:txBody>
+      </p:sp>
+      <p:sp>
+        <p:nvSpPr>
+          <p:cNvPr id="4" name="TextBox 3"/>
+          <p:cNvSpPr txBox="1"/>
+          <p:nvPr/>
+        </p:nvSpPr>
+        <p:spPr>
+          <a:xfrm>
+            <a:off x="548640" y="1828800"/>
+            <a:ext cx="11064240" cy="4572000"/>
+          </a:xfrm>
+          <a:prstGeom prst="rect">
+            <a:avLst/>
+          </a:prstGeom>
+          <a:noFill/>
+        </p:spPr>
+        <p:txBody>
+          <a:bodyPr wrap="square">
+            <a:spAutoFit/>
+          </a:bodyPr>
+          <a:lstStyle/>
+          <a:p>
+            <a:pPr>
+              <a:spcAft>
+                <a:spcPts val="800"/>
+              </a:spcAft>
+            </a:pPr>
+            <a:r>
+              <a:rPr sz="2300">
+                <a:solidFill>
+                  <a:srgbClr val="35C4E8"/>
+                </a:solidFill>
+                <a:latin typeface="Segoe UI"/>
+              </a:rPr>
+              <a:t>•  </a:t>
+            </a:r>
+            <a:r>
+              <a:rPr sz="2300" b="1">
+                <a:solidFill>
+                  <a:srgbClr val="F2C744"/>
+                </a:solidFill>
+                <a:latin typeface="Segoe UI"/>
+              </a:rPr>
+              <a:t>Separation of concerns is achievable at zero cost</a:t>
+            </a:r>
+            <a:r>
+              <a:rPr sz="2300" b="0">
+                <a:solidFill>
+                  <a:srgbClr val="D8E2EC"/>
+                </a:solidFill>
+                <a:latin typeface="Segoe UI"/>
+              </a:rPr>
+              <a:t> in C++20 — measured, not asserted</a:t>
+            </a:r>
+          </a:p>
+          <a:p>
+            <a:pPr>
+              <a:spcAft>
+                <a:spcPts val="800"/>
+              </a:spcAft>
+            </a:pPr>
+            <a:r>
+              <a:rPr sz="2300">
+                <a:solidFill>
+                  <a:srgbClr val="35C4E8"/>
+                </a:solidFill>
+                <a:latin typeface="Segoe UI"/>
+              </a:rPr>
+              <a:t>•  </a:t>
+            </a:r>
+            <a:r>
+              <a:rPr sz="2300" b="0">
+                <a:solidFill>
+                  <a:srgbClr val="D8E2EC"/>
+                </a:solidFill>
+                <a:latin typeface="Segoe UI"/>
+              </a:rPr>
+              <a:t>The recipe is small: </a:t>
+            </a:r>
+            <a:r>
+              <a:rPr sz="2300" b="1">
+                <a:solidFill>
+                  <a:srgbClr val="35C4E8"/>
+                </a:solidFill>
+                <a:latin typeface="Segoe UI"/>
+              </a:rPr>
+              <a:t>typed tags + overloaded compute() + a constexpr registry + concepts</a:t>
+            </a:r>
+          </a:p>
+          <a:p>
+            <a:pPr lvl="1">
+              <a:spcBef>
+                <a:spcPts val="0"/>
+              </a:spcBef>
+              <a:spcAft>
+                <a:spcPts val="800"/>
+              </a:spcAft>
+            </a:pPr>
+            <a:r>
+              <a:rPr sz="2100">
+                <a:solidFill>
+                  <a:srgbClr val="8CA3B8"/>
+                </a:solidFill>
+                <a:latin typeface="Segoe UI"/>
+              </a:rPr>
+              <a:t>–  </a:t>
+            </a:r>
+            <a:r>
+              <a:rPr sz="2100" b="0">
+                <a:solidFill>
+                  <a:srgbClr val="D8E2EC"/>
+                </a:solidFill>
+                <a:latin typeface="Segoe UI"/>
+              </a:rPr>
+              <a:t>no inheritance, no virtuals, no strings, no codegen</a:t>
+            </a:r>
+          </a:p>
+          <a:p>
+            <a:pPr>
+              <a:spcAft>
+                <a:spcPts val="800"/>
+              </a:spcAft>
+            </a:pPr>
+            <a:r>
+              <a:rPr sz="2300">
+                <a:solidFill>
+                  <a:srgbClr val="35C4E8"/>
+                </a:solidFill>
+                <a:latin typeface="Segoe UI"/>
+              </a:rPr>
+              <a:t>•  </a:t>
+            </a:r>
+            <a:r>
+              <a:rPr sz="2300" b="1">
+                <a:solidFill>
+                  <a:srgbClr val="FFFFFF"/>
+                </a:solidFill>
+                <a:latin typeface="Segoe UI"/>
+              </a:rPr>
+              <a:t>Prefer abstractions you can verify</a:t>
+            </a:r>
+            <a:r>
+              <a:rPr sz="2300" b="0">
+                <a:solidFill>
+                  <a:srgbClr val="D8E2EC"/>
+                </a:solidFill>
+                <a:latin typeface="Segoe UI"/>
+              </a:rPr>
+              <a:t> — conservation laws and disassembly are unit tests for architecture</a:t>
+            </a:r>
+          </a:p>
+          <a:p>
+            <a:pPr>
+              <a:spcAft>
+                <a:spcPts val="800"/>
+              </a:spcAft>
+            </a:pPr>
+            <a:r>
+              <a:rPr sz="2300">
+                <a:solidFill>
+                  <a:srgbClr val="35C4E8"/>
+                </a:solidFill>
+                <a:latin typeface="Segoe UI"/>
+              </a:rPr>
+              <a:t>•  </a:t>
+            </a:r>
+            <a:r>
+              <a:rPr sz="2300" b="1">
+                <a:solidFill>
+                  <a:srgbClr val="FFFFFF"/>
+                </a:solidFill>
+                <a:latin typeface="Segoe UI"/>
+              </a:rPr>
+              <a:t>Quality vs performance was the false tradeoff</a:t>
+            </a:r>
+            <a:r>
+              <a:rPr sz="2300" b="0">
+                <a:solidFill>
+                  <a:srgbClr val="D8E2EC"/>
+                </a:solidFill>
+                <a:latin typeface="Segoe UI"/>
+              </a:rPr>
+              <a:t> — modern C++ finally lets us refuse it</a:t>
+            </a:r>
+          </a:p>
+        </p:txBody>
+      </p:sp>
+      <p:sp>
+        <p:nvSpPr>
+          <p:cNvPr id="5" name="TextBox 4"/>
+          <p:cNvSpPr txBox="1"/>
+          <p:nvPr/>
+        </p:nvSpPr>
+        <p:spPr>
+          <a:xfrm>
+            <a:off x="411480" y="6446520"/>
+            <a:ext cx="10058400" cy="320040"/>
+          </a:xfrm>
+          <a:prstGeom prst="rect">
+            <a:avLst/>
+          </a:prstGeom>
+          <a:noFill/>
+        </p:spPr>
+        <p:txBody>
+          <a:bodyPr wrap="none">
+            <a:spAutoFit/>
+          </a:bodyPr>
+          <a:lstStyle/>
+          <a:p>
+            <a:r>
+              <a:rPr sz="1000">
+                <a:solidFill>
+                  <a:srgbClr val="8CA3B8"/>
+                </a:solidFill>
+                <a:latin typeface="Segoe UI"/>
+              </a:rPr>
+              <a:t>Separation of Concerns at Zero Cost — ACCU on Sea 2026</a:t>
+            </a:r>
+          </a:p>
+        </p:txBody>
+      </p:sp>
+      <p:sp>
+        <p:nvSpPr>
+          <p:cNvPr id="6" name="TextBox 5"/>
+          <p:cNvSpPr txBox="1"/>
+          <p:nvPr/>
+        </p:nvSpPr>
+        <p:spPr>
+          <a:xfrm>
+            <a:off x="11384280" y="6446520"/>
+            <a:ext cx="548640" cy="320040"/>
+          </a:xfrm>
+          <a:prstGeom prst="rect">
+            <a:avLst/>
+          </a:prstGeom>
+          <a:noFill/>
+        </p:spPr>
+        <p:txBody>
+          <a:bodyPr wrap="none">
+            <a:spAutoFit/>
+          </a:bodyPr>
+          <a:lstStyle/>
+          <a:p>
+            <a:pPr algn="r"/>
+            <a:r>
+              <a:rPr sz="1000">
+                <a:solidFill>
+                  <a:srgbClr val="8CA3B8"/>
+                </a:solidFill>
+                <a:latin typeface="Segoe UI"/>
+              </a:rPr>
+              <a:t>40</a:t>
+            </a:r>
+          </a:p>
+        </p:txBody>
+      </p:sp>
+    </p:spTree>
+  </p:cSld>
+  <p:clrMapOvr>
+    <a:masterClrMapping/>
+  </p:clrMapOvr>
+</p:sld>
+</file>
+
+<file path=ppt/slides/slide41.xml><?xml version="1.0" encoding="utf-8"?>
+<p:sld xmlns:a="http://schemas.openxmlformats.org/drawingml/2006/main" xmlns:r="http://schemas.openxmlformats.org/officeDocument/2006/relationships" xmlns:p="http://schemas.openxmlformats.org/presentationml/2006/main">
+  <p:cSld>
+    <p:bg>
+      <p:bgPr>
+        <a:solidFill>
+          <a:srgbClr val="0B1F33"/>
+        </a:solidFill>
+        <a:effectLst/>
+      </p:bgPr>
+    </p:bg>
+    <p:spTree>
+      <p:nvGrpSpPr>
+        <p:cNvPr id="1" name=""/>
+        <p:cNvGrpSpPr/>
+        <p:nvPr/>
+      </p:nvGrpSpPr>
+      <p:grpSpPr>
+        <a:xfrm>
+          <a:off x="0" y="0"/>
+          <a:ext cx="0" cy="0"/>
+          <a:chOff x="0" y="0"/>
+          <a:chExt cx="0" cy="0"/>
+        </a:xfrm>
+      </p:grpSpPr>
+      <p:sp>
+        <p:nvSpPr>
+          <p:cNvPr id="2" name="TextBox 1"/>
+          <p:cNvSpPr txBox="1"/>
+          <p:nvPr/>
+        </p:nvSpPr>
+        <p:spPr>
+          <a:xfrm>
             <a:off x="822960" y="1463040"/>
             <a:ext cx="10515600" cy="1371600"/>
           </a:xfrm>
@@ -26716,7 +29999,7 @@
                 </a:solidFill>
                 <a:latin typeface="Segoe UI"/>
               </a:rPr>
-              <a:t>40</a:t>
+              <a:t>41</a:t>
             </a:r>
           </a:p>
         </p:txBody>

</xml_diff>

<commit_message>
Add 3rd Zarchan slide: the plotting/file-I/O tail
Completes the 'old way' arc in the history-lesson section: (1) setup globals +
staging math, (2) the integration loop, (3) the tail — trajectory logging,
plot/xlabel/ylabel, save ... /ascii, disp — all in the same global scope.
Takeaway: no boundary between simulation, analysis, and I/O. Deck now 42
slides; page numbers renumbered; PDF regenerated.

Co-Authored-By: Claude Opus 4.8 (1M context) <noreply@anthropic.com>
</commit_message>
<xml_diff>
--- a/slides/ACCU-Separation-of-Concerns-at-Zero-Cost.pptx
+++ b/slides/ACCU-Separation-of-Concerns-at-Zero-Cost.pptx
@@ -46,6 +46,7 @@
     <p:sldId id="289" r:id="rId36"/>
     <p:sldId id="290" r:id="rId37"/>
     <p:sldId id="298" r:id="rId47"/>
+    <p:sldId id="299" r:id="rId48"/>
     <p:sldId id="291" r:id="rId38"/>
     <p:sldId id="292" r:id="rId39"/>
     <p:sldId id="293" r:id="rId40"/>
@@ -28572,7 +28573,7 @@
                 </a:solidFill>
                 <a:latin typeface="Segoe UI"/>
               </a:rPr>
-              <a:t>39</a:t>
+              <a:t>40</a:t>
             </a:r>
           </a:p>
         </p:txBody>
@@ -29648,7 +29649,7 @@
                 </a:solidFill>
                 <a:latin typeface="Segoe UI"/>
               </a:rPr>
-              <a:t>40</a:t>
+              <a:t>41</a:t>
             </a:r>
           </a:p>
         </p:txBody>
@@ -29999,7 +30000,1777 @@
                 </a:solidFill>
                 <a:latin typeface="Segoe UI"/>
               </a:rPr>
-              <a:t>41</a:t>
+              <a:t>42</a:t>
+            </a:r>
+          </a:p>
+        </p:txBody>
+      </p:sp>
+    </p:spTree>
+  </p:cSld>
+  <p:clrMapOvr>
+    <a:masterClrMapping/>
+  </p:clrMapOvr>
+</p:sld>
+</file>
+
+<file path=ppt/slides/slide42.xml><?xml version="1.0" encoding="utf-8"?>
+<p:sld xmlns:a="http://schemas.openxmlformats.org/drawingml/2006/main" xmlns:p="http://schemas.openxmlformats.org/presentationml/2006/main" xmlns:r="http://schemas.openxmlformats.org/officeDocument/2006/relationships">
+  <p:cSld>
+    <p:bg>
+      <p:bgPr>
+        <a:solidFill>
+          <a:srgbClr val="0B1F33"/>
+        </a:solidFill>
+        <a:effectLst/>
+      </p:bgPr>
+    </p:bg>
+    <p:spTree>
+      <p:nvGrpSpPr>
+        <p:cNvPr id="1" name=""/>
+        <p:cNvGrpSpPr/>
+        <p:nvPr/>
+      </p:nvGrpSpPr>
+      <p:grpSpPr/>
+      <p:sp>
+        <p:nvSpPr>
+          <p:cNvPr id="2" name="TextBox 1"/>
+          <p:cNvSpPr txBox="1"/>
+          <p:nvPr/>
+        </p:nvSpPr>
+        <p:spPr>
+          <a:xfrm>
+            <a:off x="502920" y="384048"/>
+            <a:ext cx="11155680" cy="292608"/>
+          </a:xfrm>
+          <a:prstGeom prst="rect">
+            <a:avLst/>
+          </a:prstGeom>
+          <a:noFill/>
+        </p:spPr>
+        <p:txBody>
+          <a:bodyPr wrap="none">
+            <a:spAutoFit/>
+          </a:bodyPr>
+          <a:lstStyle/>
+          <a:p>
+            <a:r>
+              <a:rPr sz="1300" b="1">
+                <a:solidFill>
+                  <a:srgbClr val="F2C744"/>
+                </a:solidFill>
+                <a:latin typeface="Segoe UI"/>
+              </a:rPr>
+              <a:t>A SHORT HISTORY LESSON</a:t>
+            </a:r>
+          </a:p>
+        </p:txBody>
+      </p:sp>
+      <p:sp>
+        <p:nvSpPr>
+          <p:cNvPr id="3" name="TextBox 2"/>
+          <p:cNvSpPr txBox="1"/>
+          <p:nvPr/>
+        </p:nvSpPr>
+        <p:spPr>
+          <a:xfrm>
+            <a:off x="457200" y="694944"/>
+            <a:ext cx="11247120" cy="777240"/>
+          </a:xfrm>
+          <a:prstGeom prst="rect">
+            <a:avLst/>
+          </a:prstGeom>
+          <a:noFill/>
+        </p:spPr>
+        <p:txBody>
+          <a:bodyPr wrap="none">
+            <a:spAutoFit/>
+          </a:bodyPr>
+          <a:lstStyle/>
+          <a:p>
+            <a:r>
+              <a:rPr sz="3100" b="1">
+                <a:solidFill>
+                  <a:srgbClr val="FFFFFF"/>
+                </a:solidFill>
+                <a:latin typeface="Segoe UI"/>
+              </a:rPr>
+              <a:t>Same script — even the plotting and file I/O</a:t>
+            </a:r>
+          </a:p>
+        </p:txBody>
+      </p:sp>
+      <p:sp>
+        <p:nvSpPr>
+          <p:cNvPr id="4" name="Rounded Rectangle 3"/>
+          <p:cNvSpPr/>
+          <p:nvPr/>
+        </p:nvSpPr>
+        <p:spPr>
+          <a:xfrm>
+            <a:off x="548640" y="1463040"/>
+            <a:ext cx="11338560" cy="3520440"/>
+          </a:xfrm>
+          <a:prstGeom prst="roundRect">
+            <a:avLst>
+              <a:gd name="adj" fmla="val 10000"/>
+            </a:avLst>
+          </a:prstGeom>
+          <a:solidFill>
+            <a:srgbClr val="081626"/>
+          </a:solidFill>
+          <a:ln w="12700">
+            <a:solidFill>
+              <a:srgbClr val="1E3A55"/>
+            </a:solidFill>
+          </a:ln>
+          <a:effectLst/>
+        </p:spPr>
+        <p:style>
+          <a:lnRef idx="1">
+            <a:schemeClr val="accent1"/>
+          </a:lnRef>
+          <a:fillRef idx="3">
+            <a:schemeClr val="accent1"/>
+          </a:fillRef>
+          <a:effectRef idx="2">
+            <a:schemeClr val="accent1"/>
+          </a:effectRef>
+          <a:fontRef idx="minor">
+            <a:schemeClr val="lt1"/>
+          </a:fontRef>
+        </p:style>
+        <p:txBody>
+          <a:bodyPr wrap="square" rtlCol="0" anchor="ctr"/>
+          <a:lstStyle/>
+          <a:p>
+            <a:pPr algn="ctr"/>
+          </a:p>
+        </p:txBody>
+      </p:sp>
+      <p:sp>
+        <p:nvSpPr>
+          <p:cNvPr id="6" name="TextBox 5"/>
+          <p:cNvSpPr txBox="1"/>
+          <p:nvPr/>
+        </p:nvSpPr>
+        <p:spPr>
+          <a:xfrm>
+            <a:off x="411480" y="6446520"/>
+            <a:ext cx="10058400" cy="320040"/>
+          </a:xfrm>
+          <a:prstGeom prst="rect">
+            <a:avLst/>
+          </a:prstGeom>
+          <a:noFill/>
+        </p:spPr>
+        <p:txBody>
+          <a:bodyPr wrap="none">
+            <a:spAutoFit/>
+          </a:bodyPr>
+          <a:lstStyle/>
+          <a:p>
+            <a:r>
+              <a:rPr sz="1000">
+                <a:solidFill>
+                  <a:srgbClr val="8CA3B8"/>
+                </a:solidFill>
+                <a:latin typeface="Segoe UI"/>
+              </a:rPr>
+              <a:t>Separation of Concerns at Zero Cost — ACCU on Sea 2026</a:t>
+            </a:r>
+          </a:p>
+        </p:txBody>
+      </p:sp>
+      <p:sp>
+        <p:nvSpPr>
+          <p:cNvPr id="7" name="TextBox 6"/>
+          <p:cNvSpPr txBox="1"/>
+          <p:nvPr/>
+        </p:nvSpPr>
+        <p:spPr>
+          <a:xfrm>
+            <a:off x="11384280" y="6446520"/>
+            <a:ext cx="548640" cy="320040"/>
+          </a:xfrm>
+          <a:prstGeom prst="rect">
+            <a:avLst/>
+          </a:prstGeom>
+          <a:noFill/>
+        </p:spPr>
+        <p:txBody>
+          <a:bodyPr wrap="none">
+            <a:spAutoFit/>
+          </a:bodyPr>
+          <a:lstStyle/>
+          <a:p>
+            <a:pPr algn="r"/>
+            <a:r>
+              <a:rPr sz="1000">
+                <a:solidFill>
+                  <a:srgbClr val="8CA3B8"/>
+                </a:solidFill>
+                <a:latin typeface="Segoe UI"/>
+              </a:rPr>
+              <a:t>39</a:t>
+            </a:r>
+          </a:p>
+        </p:txBody>
+      </p:sp>
+      <p:sp>
+        <p:nvSpPr>
+          <p:cNvPr id="8" name="zarchan tail"/>
+          <p:cNvSpPr txBox="1"/>
+          <p:nvPr/>
+        </p:nvSpPr>
+        <p:spPr>
+          <a:xfrm>
+            <a:off x="777240" y="1600200"/>
+            <a:ext cx="10881360" cy="3319272"/>
+          </a:xfrm>
+          <a:prstGeom prst="rect">
+            <a:avLst/>
+          </a:prstGeom>
+          <a:noFill/>
+        </p:spPr>
+        <p:txBody>
+          <a:bodyPr wrap="none">
+            <a:spAutoFit/>
+          </a:bodyPr>
+          <a:lstStyle/>
+          <a:p>
+            <a:pPr>
+              <a:spcAft>
+                <a:spcPts val="100"/>
+              </a:spcAft>
+            </a:pPr>
+            <a:r>
+              <a:rPr sz="1600">
+                <a:solidFill>
+                  <a:srgbClr val="D4D4D4"/>
+                </a:solidFill>
+                <a:latin typeface="Consolas"/>
+              </a:rPr>
+              <a:t>    </a:t>
+            </a:r>
+            <a:r>
+              <a:rPr sz="1600">
+                <a:solidFill>
+                  <a:srgbClr val="569CD6"/>
+                </a:solidFill>
+                <a:latin typeface="Consolas"/>
+              </a:rPr>
+              <a:t>if</a:t>
+            </a:r>
+            <a:r>
+              <a:rPr sz="1600">
+                <a:solidFill>
+                  <a:srgbClr val="D4D4D4"/>
+                </a:solidFill>
+                <a:latin typeface="Consolas"/>
+              </a:rPr>
+              <a:t> </a:t>
+            </a:r>
+            <a:r>
+              <a:rPr sz="1600">
+                <a:solidFill>
+                  <a:srgbClr val="D4D4D4"/>
+                </a:solidFill>
+                <a:latin typeface="Consolas"/>
+              </a:rPr>
+              <a:t>S</a:t>
+            </a:r>
+            <a:r>
+              <a:rPr sz="1600">
+                <a:solidFill>
+                  <a:srgbClr val="D4D4D4"/>
+                </a:solidFill>
+                <a:latin typeface="Consolas"/>
+              </a:rPr>
+              <a:t>&gt;=</a:t>
+            </a:r>
+            <a:r>
+              <a:rPr sz="1600">
+                <a:solidFill>
+                  <a:srgbClr val="B5CEA8"/>
+                </a:solidFill>
+                <a:latin typeface="Consolas"/>
+              </a:rPr>
+              <a:t>9.99999</a:t>
+            </a:r>
+          </a:p>
+          <a:p>
+            <a:pPr>
+              <a:spcAft>
+                <a:spcPts val="100"/>
+              </a:spcAft>
+            </a:pPr>
+            <a:r>
+              <a:rPr sz="1600">
+                <a:solidFill>
+                  <a:srgbClr val="D4D4D4"/>
+                </a:solidFill>
+                <a:latin typeface="Consolas"/>
+              </a:rPr>
+              <a:t>        </a:t>
+            </a:r>
+            <a:r>
+              <a:rPr sz="1600">
+                <a:solidFill>
+                  <a:srgbClr val="D4D4D4"/>
+                </a:solidFill>
+                <a:latin typeface="Consolas"/>
+              </a:rPr>
+              <a:t>R</a:t>
+            </a:r>
+            <a:r>
+              <a:rPr sz="1600">
+                <a:solidFill>
+                  <a:srgbClr val="D4D4D4"/>
+                </a:solidFill>
+                <a:latin typeface="Consolas"/>
+              </a:rPr>
+              <a:t>=</a:t>
+            </a:r>
+            <a:r>
+              <a:rPr sz="1600">
+                <a:solidFill>
+                  <a:srgbClr val="4EC9B0"/>
+                </a:solidFill>
+                <a:latin typeface="Consolas"/>
+              </a:rPr>
+              <a:t>sqrt</a:t>
+            </a:r>
+            <a:r>
+              <a:rPr sz="1600">
+                <a:solidFill>
+                  <a:srgbClr val="D4D4D4"/>
+                </a:solidFill>
+                <a:latin typeface="Consolas"/>
+              </a:rPr>
+              <a:t>(</a:t>
+            </a:r>
+            <a:r>
+              <a:rPr sz="1600">
+                <a:solidFill>
+                  <a:srgbClr val="D4D4D4"/>
+                </a:solidFill>
+                <a:latin typeface="Consolas"/>
+              </a:rPr>
+              <a:t>X</a:t>
+            </a:r>
+            <a:r>
+              <a:rPr sz="1600">
+                <a:solidFill>
+                  <a:srgbClr val="D4D4D4"/>
+                </a:solidFill>
+                <a:latin typeface="Consolas"/>
+              </a:rPr>
+              <a:t>^</a:t>
+            </a:r>
+            <a:r>
+              <a:rPr sz="1600">
+                <a:solidFill>
+                  <a:srgbClr val="B5CEA8"/>
+                </a:solidFill>
+                <a:latin typeface="Consolas"/>
+              </a:rPr>
+              <a:t>2</a:t>
+            </a:r>
+            <a:r>
+              <a:rPr sz="1600">
+                <a:solidFill>
+                  <a:srgbClr val="D4D4D4"/>
+                </a:solidFill>
+                <a:latin typeface="Consolas"/>
+              </a:rPr>
+              <a:t>+</a:t>
+            </a:r>
+            <a:r>
+              <a:rPr sz="1600">
+                <a:solidFill>
+                  <a:srgbClr val="D4D4D4"/>
+                </a:solidFill>
+                <a:latin typeface="Consolas"/>
+              </a:rPr>
+              <a:t>Y</a:t>
+            </a:r>
+            <a:r>
+              <a:rPr sz="1600">
+                <a:solidFill>
+                  <a:srgbClr val="D4D4D4"/>
+                </a:solidFill>
+                <a:latin typeface="Consolas"/>
+              </a:rPr>
+              <a:t>^</a:t>
+            </a:r>
+            <a:r>
+              <a:rPr sz="1600">
+                <a:solidFill>
+                  <a:srgbClr val="B5CEA8"/>
+                </a:solidFill>
+                <a:latin typeface="Consolas"/>
+              </a:rPr>
+              <a:t>2</a:t>
+            </a:r>
+            <a:r>
+              <a:rPr sz="1600">
+                <a:solidFill>
+                  <a:srgbClr val="D4D4D4"/>
+                </a:solidFill>
+                <a:latin typeface="Consolas"/>
+              </a:rPr>
+              <a:t>)</a:t>
+            </a:r>
+            <a:r>
+              <a:rPr sz="1600">
+                <a:solidFill>
+                  <a:srgbClr val="D4D4D4"/>
+                </a:solidFill>
+                <a:latin typeface="Consolas"/>
+              </a:rPr>
+              <a:t>;</a:t>
+            </a:r>
+            <a:r>
+              <a:rPr sz="1600">
+                <a:solidFill>
+                  <a:srgbClr val="D4D4D4"/>
+                </a:solidFill>
+                <a:latin typeface="Consolas"/>
+              </a:rPr>
+              <a:t>   </a:t>
+            </a:r>
+            <a:r>
+              <a:rPr sz="1600">
+                <a:solidFill>
+                  <a:srgbClr val="D4D4D4"/>
+                </a:solidFill>
+                <a:latin typeface="Consolas"/>
+              </a:rPr>
+              <a:t>RF</a:t>
+            </a:r>
+            <a:r>
+              <a:rPr sz="1600">
+                <a:solidFill>
+                  <a:srgbClr val="D4D4D4"/>
+                </a:solidFill>
+                <a:latin typeface="Consolas"/>
+              </a:rPr>
+              <a:t>=</a:t>
+            </a:r>
+            <a:r>
+              <a:rPr sz="1600">
+                <a:solidFill>
+                  <a:srgbClr val="4EC9B0"/>
+                </a:solidFill>
+                <a:latin typeface="Consolas"/>
+              </a:rPr>
+              <a:t>sqrt</a:t>
+            </a:r>
+            <a:r>
+              <a:rPr sz="1600">
+                <a:solidFill>
+                  <a:srgbClr val="D4D4D4"/>
+                </a:solidFill>
+                <a:latin typeface="Consolas"/>
+              </a:rPr>
+              <a:t>(</a:t>
+            </a:r>
+            <a:r>
+              <a:rPr sz="1600">
+                <a:solidFill>
+                  <a:srgbClr val="D4D4D4"/>
+                </a:solidFill>
+                <a:latin typeface="Consolas"/>
+              </a:rPr>
+              <a:t>XFIRST</a:t>
+            </a:r>
+            <a:r>
+              <a:rPr sz="1600">
+                <a:solidFill>
+                  <a:srgbClr val="D4D4D4"/>
+                </a:solidFill>
+                <a:latin typeface="Consolas"/>
+              </a:rPr>
+              <a:t>^</a:t>
+            </a:r>
+            <a:r>
+              <a:rPr sz="1600">
+                <a:solidFill>
+                  <a:srgbClr val="B5CEA8"/>
+                </a:solidFill>
+                <a:latin typeface="Consolas"/>
+              </a:rPr>
+              <a:t>2</a:t>
+            </a:r>
+            <a:r>
+              <a:rPr sz="1600">
+                <a:solidFill>
+                  <a:srgbClr val="D4D4D4"/>
+                </a:solidFill>
+                <a:latin typeface="Consolas"/>
+              </a:rPr>
+              <a:t>+</a:t>
+            </a:r>
+            <a:r>
+              <a:rPr sz="1600">
+                <a:solidFill>
+                  <a:srgbClr val="D4D4D4"/>
+                </a:solidFill>
+                <a:latin typeface="Consolas"/>
+              </a:rPr>
+              <a:t>YFIRST</a:t>
+            </a:r>
+            <a:r>
+              <a:rPr sz="1600">
+                <a:solidFill>
+                  <a:srgbClr val="D4D4D4"/>
+                </a:solidFill>
+                <a:latin typeface="Consolas"/>
+              </a:rPr>
+              <a:t>^</a:t>
+            </a:r>
+            <a:r>
+              <a:rPr sz="1600">
+                <a:solidFill>
+                  <a:srgbClr val="B5CEA8"/>
+                </a:solidFill>
+                <a:latin typeface="Consolas"/>
+              </a:rPr>
+              <a:t>2</a:t>
+            </a:r>
+            <a:r>
+              <a:rPr sz="1600">
+                <a:solidFill>
+                  <a:srgbClr val="D4D4D4"/>
+                </a:solidFill>
+                <a:latin typeface="Consolas"/>
+              </a:rPr>
+              <a:t>)</a:t>
+            </a:r>
+            <a:r>
+              <a:rPr sz="1600">
+                <a:solidFill>
+                  <a:srgbClr val="D4D4D4"/>
+                </a:solidFill>
+                <a:latin typeface="Consolas"/>
+              </a:rPr>
+              <a:t>;</a:t>
+            </a:r>
+          </a:p>
+          <a:p>
+            <a:pPr>
+              <a:spcAft>
+                <a:spcPts val="100"/>
+              </a:spcAft>
+            </a:pPr>
+            <a:r>
+              <a:rPr sz="1600">
+                <a:solidFill>
+                  <a:srgbClr val="D4D4D4"/>
+                </a:solidFill>
+                <a:latin typeface="Consolas"/>
+              </a:rPr>
+              <a:t>        </a:t>
+            </a:r>
+            <a:r>
+              <a:rPr sz="1600">
+                <a:solidFill>
+                  <a:srgbClr val="D4D4D4"/>
+                </a:solidFill>
+                <a:latin typeface="Consolas"/>
+              </a:rPr>
+              <a:t>BETA</a:t>
+            </a:r>
+            <a:r>
+              <a:rPr sz="1600">
+                <a:solidFill>
+                  <a:srgbClr val="D4D4D4"/>
+                </a:solidFill>
+                <a:latin typeface="Consolas"/>
+              </a:rPr>
+              <a:t>=</a:t>
+            </a:r>
+            <a:r>
+              <a:rPr sz="1600">
+                <a:solidFill>
+                  <a:srgbClr val="4EC9B0"/>
+                </a:solidFill>
+                <a:latin typeface="Consolas"/>
+              </a:rPr>
+              <a:t>acos</a:t>
+            </a:r>
+            <a:r>
+              <a:rPr sz="1600">
+                <a:solidFill>
+                  <a:srgbClr val="D4D4D4"/>
+                </a:solidFill>
+                <a:latin typeface="Consolas"/>
+              </a:rPr>
+              <a:t>(</a:t>
+            </a:r>
+            <a:r>
+              <a:rPr sz="1600">
+                <a:solidFill>
+                  <a:srgbClr val="D4D4D4"/>
+                </a:solidFill>
+                <a:latin typeface="Consolas"/>
+              </a:rPr>
+              <a:t>(</a:t>
+            </a:r>
+            <a:r>
+              <a:rPr sz="1600">
+                <a:solidFill>
+                  <a:srgbClr val="D4D4D4"/>
+                </a:solidFill>
+                <a:latin typeface="Consolas"/>
+              </a:rPr>
+              <a:t>X</a:t>
+            </a:r>
+            <a:r>
+              <a:rPr sz="1600">
+                <a:solidFill>
+                  <a:srgbClr val="D4D4D4"/>
+                </a:solidFill>
+                <a:latin typeface="Consolas"/>
+              </a:rPr>
+              <a:t>*</a:t>
+            </a:r>
+            <a:r>
+              <a:rPr sz="1600">
+                <a:solidFill>
+                  <a:srgbClr val="D4D4D4"/>
+                </a:solidFill>
+                <a:latin typeface="Consolas"/>
+              </a:rPr>
+              <a:t>XFIRST</a:t>
+            </a:r>
+            <a:r>
+              <a:rPr sz="1600">
+                <a:solidFill>
+                  <a:srgbClr val="D4D4D4"/>
+                </a:solidFill>
+                <a:latin typeface="Consolas"/>
+              </a:rPr>
+              <a:t>+</a:t>
+            </a:r>
+            <a:r>
+              <a:rPr sz="1600">
+                <a:solidFill>
+                  <a:srgbClr val="D4D4D4"/>
+                </a:solidFill>
+                <a:latin typeface="Consolas"/>
+              </a:rPr>
+              <a:t>Y</a:t>
+            </a:r>
+            <a:r>
+              <a:rPr sz="1600">
+                <a:solidFill>
+                  <a:srgbClr val="D4D4D4"/>
+                </a:solidFill>
+                <a:latin typeface="Consolas"/>
+              </a:rPr>
+              <a:t>*</a:t>
+            </a:r>
+            <a:r>
+              <a:rPr sz="1600">
+                <a:solidFill>
+                  <a:srgbClr val="D4D4D4"/>
+                </a:solidFill>
+                <a:latin typeface="Consolas"/>
+              </a:rPr>
+              <a:t>YFIRST</a:t>
+            </a:r>
+            <a:r>
+              <a:rPr sz="1600">
+                <a:solidFill>
+                  <a:srgbClr val="D4D4D4"/>
+                </a:solidFill>
+                <a:latin typeface="Consolas"/>
+              </a:rPr>
+              <a:t>)</a:t>
+            </a:r>
+            <a:r>
+              <a:rPr sz="1600">
+                <a:solidFill>
+                  <a:srgbClr val="D4D4D4"/>
+                </a:solidFill>
+                <a:latin typeface="Consolas"/>
+              </a:rPr>
+              <a:t>/</a:t>
+            </a:r>
+            <a:r>
+              <a:rPr sz="1600">
+                <a:solidFill>
+                  <a:srgbClr val="D4D4D4"/>
+                </a:solidFill>
+                <a:latin typeface="Consolas"/>
+              </a:rPr>
+              <a:t>(</a:t>
+            </a:r>
+            <a:r>
+              <a:rPr sz="1600">
+                <a:solidFill>
+                  <a:srgbClr val="D4D4D4"/>
+                </a:solidFill>
+                <a:latin typeface="Consolas"/>
+              </a:rPr>
+              <a:t>R</a:t>
+            </a:r>
+            <a:r>
+              <a:rPr sz="1600">
+                <a:solidFill>
+                  <a:srgbClr val="D4D4D4"/>
+                </a:solidFill>
+                <a:latin typeface="Consolas"/>
+              </a:rPr>
+              <a:t>*</a:t>
+            </a:r>
+            <a:r>
+              <a:rPr sz="1600">
+                <a:solidFill>
+                  <a:srgbClr val="D4D4D4"/>
+                </a:solidFill>
+                <a:latin typeface="Consolas"/>
+              </a:rPr>
+              <a:t>RF</a:t>
+            </a:r>
+            <a:r>
+              <a:rPr sz="1600">
+                <a:solidFill>
+                  <a:srgbClr val="D4D4D4"/>
+                </a:solidFill>
+                <a:latin typeface="Consolas"/>
+              </a:rPr>
+              <a:t>)</a:t>
+            </a:r>
+            <a:r>
+              <a:rPr sz="1600">
+                <a:solidFill>
+                  <a:srgbClr val="D4D4D4"/>
+                </a:solidFill>
+                <a:latin typeface="Consolas"/>
+              </a:rPr>
+              <a:t>)</a:t>
+            </a:r>
+            <a:r>
+              <a:rPr sz="1600">
+                <a:solidFill>
+                  <a:srgbClr val="D4D4D4"/>
+                </a:solidFill>
+                <a:latin typeface="Consolas"/>
+              </a:rPr>
+              <a:t>;</a:t>
+            </a:r>
+          </a:p>
+          <a:p>
+            <a:pPr>
+              <a:spcAft>
+                <a:spcPts val="100"/>
+              </a:spcAft>
+            </a:pPr>
+            <a:r>
+              <a:rPr sz="1600">
+                <a:solidFill>
+                  <a:srgbClr val="D4D4D4"/>
+                </a:solidFill>
+                <a:latin typeface="Consolas"/>
+              </a:rPr>
+              <a:t>        </a:t>
+            </a:r>
+            <a:r>
+              <a:rPr sz="1600">
+                <a:solidFill>
+                  <a:srgbClr val="D4D4D4"/>
+                </a:solidFill>
+                <a:latin typeface="Consolas"/>
+              </a:rPr>
+              <a:t>DISTNM</a:t>
+            </a:r>
+            <a:r>
+              <a:rPr sz="1600">
+                <a:solidFill>
+                  <a:srgbClr val="D4D4D4"/>
+                </a:solidFill>
+                <a:latin typeface="Consolas"/>
+              </a:rPr>
+              <a:t>=</a:t>
+            </a:r>
+            <a:r>
+              <a:rPr sz="1600">
+                <a:solidFill>
+                  <a:srgbClr val="D4D4D4"/>
+                </a:solidFill>
+                <a:latin typeface="Consolas"/>
+              </a:rPr>
+              <a:t>A</a:t>
+            </a:r>
+            <a:r>
+              <a:rPr sz="1600">
+                <a:solidFill>
+                  <a:srgbClr val="D4D4D4"/>
+                </a:solidFill>
+                <a:latin typeface="Consolas"/>
+              </a:rPr>
+              <a:t>*</a:t>
+            </a:r>
+            <a:r>
+              <a:rPr sz="1600">
+                <a:solidFill>
+                  <a:srgbClr val="D4D4D4"/>
+                </a:solidFill>
+                <a:latin typeface="Consolas"/>
+              </a:rPr>
+              <a:t>BETA</a:t>
+            </a:r>
+            <a:r>
+              <a:rPr sz="1600">
+                <a:solidFill>
+                  <a:srgbClr val="D4D4D4"/>
+                </a:solidFill>
+                <a:latin typeface="Consolas"/>
+              </a:rPr>
+              <a:t>/</a:t>
+            </a:r>
+            <a:r>
+              <a:rPr sz="1600">
+                <a:solidFill>
+                  <a:srgbClr val="B5CEA8"/>
+                </a:solidFill>
+                <a:latin typeface="Consolas"/>
+              </a:rPr>
+              <a:t>6076.</a:t>
+            </a:r>
+            <a:r>
+              <a:rPr sz="1600">
+                <a:solidFill>
+                  <a:srgbClr val="D4D4D4"/>
+                </a:solidFill>
+                <a:latin typeface="Consolas"/>
+              </a:rPr>
+              <a:t>;</a:t>
+            </a:r>
+            <a:r>
+              <a:rPr sz="1600">
+                <a:solidFill>
+                  <a:srgbClr val="D4D4D4"/>
+                </a:solidFill>
+                <a:latin typeface="Consolas"/>
+              </a:rPr>
+              <a:t>   </a:t>
+            </a:r>
+            <a:r>
+              <a:rPr sz="1600">
+                <a:solidFill>
+                  <a:srgbClr val="D4D4D4"/>
+                </a:solidFill>
+                <a:latin typeface="Consolas"/>
+              </a:rPr>
+              <a:t>ALTNM</a:t>
+            </a:r>
+            <a:r>
+              <a:rPr sz="1600">
+                <a:solidFill>
+                  <a:srgbClr val="D4D4D4"/>
+                </a:solidFill>
+                <a:latin typeface="Consolas"/>
+              </a:rPr>
+              <a:t>=</a:t>
+            </a:r>
+            <a:r>
+              <a:rPr sz="1600">
+                <a:solidFill>
+                  <a:srgbClr val="D4D4D4"/>
+                </a:solidFill>
+                <a:latin typeface="Consolas"/>
+              </a:rPr>
+              <a:t>(</a:t>
+            </a:r>
+            <a:r>
+              <a:rPr sz="1600">
+                <a:solidFill>
+                  <a:srgbClr val="4EC9B0"/>
+                </a:solidFill>
+                <a:latin typeface="Consolas"/>
+              </a:rPr>
+              <a:t>sqrt</a:t>
+            </a:r>
+            <a:r>
+              <a:rPr sz="1600">
+                <a:solidFill>
+                  <a:srgbClr val="D4D4D4"/>
+                </a:solidFill>
+                <a:latin typeface="Consolas"/>
+              </a:rPr>
+              <a:t>(</a:t>
+            </a:r>
+            <a:r>
+              <a:rPr sz="1600">
+                <a:solidFill>
+                  <a:srgbClr val="D4D4D4"/>
+                </a:solidFill>
+                <a:latin typeface="Consolas"/>
+              </a:rPr>
+              <a:t>X</a:t>
+            </a:r>
+            <a:r>
+              <a:rPr sz="1600">
+                <a:solidFill>
+                  <a:srgbClr val="D4D4D4"/>
+                </a:solidFill>
+                <a:latin typeface="Consolas"/>
+              </a:rPr>
+              <a:t>^</a:t>
+            </a:r>
+            <a:r>
+              <a:rPr sz="1600">
+                <a:solidFill>
+                  <a:srgbClr val="B5CEA8"/>
+                </a:solidFill>
+                <a:latin typeface="Consolas"/>
+              </a:rPr>
+              <a:t>2</a:t>
+            </a:r>
+            <a:r>
+              <a:rPr sz="1600">
+                <a:solidFill>
+                  <a:srgbClr val="D4D4D4"/>
+                </a:solidFill>
+                <a:latin typeface="Consolas"/>
+              </a:rPr>
+              <a:t>+</a:t>
+            </a:r>
+            <a:r>
+              <a:rPr sz="1600">
+                <a:solidFill>
+                  <a:srgbClr val="D4D4D4"/>
+                </a:solidFill>
+                <a:latin typeface="Consolas"/>
+              </a:rPr>
+              <a:t>Y</a:t>
+            </a:r>
+            <a:r>
+              <a:rPr sz="1600">
+                <a:solidFill>
+                  <a:srgbClr val="D4D4D4"/>
+                </a:solidFill>
+                <a:latin typeface="Consolas"/>
+              </a:rPr>
+              <a:t>^</a:t>
+            </a:r>
+            <a:r>
+              <a:rPr sz="1600">
+                <a:solidFill>
+                  <a:srgbClr val="B5CEA8"/>
+                </a:solidFill>
+                <a:latin typeface="Consolas"/>
+              </a:rPr>
+              <a:t>2</a:t>
+            </a:r>
+            <a:r>
+              <a:rPr sz="1600">
+                <a:solidFill>
+                  <a:srgbClr val="D4D4D4"/>
+                </a:solidFill>
+                <a:latin typeface="Consolas"/>
+              </a:rPr>
+              <a:t>)</a:t>
+            </a:r>
+            <a:r>
+              <a:rPr sz="1600">
+                <a:solidFill>
+                  <a:srgbClr val="D4D4D4"/>
+                </a:solidFill>
+                <a:latin typeface="Consolas"/>
+              </a:rPr>
+              <a:t>-</a:t>
+            </a:r>
+            <a:r>
+              <a:rPr sz="1600">
+                <a:solidFill>
+                  <a:srgbClr val="D4D4D4"/>
+                </a:solidFill>
+                <a:latin typeface="Consolas"/>
+              </a:rPr>
+              <a:t>A</a:t>
+            </a:r>
+            <a:r>
+              <a:rPr sz="1600">
+                <a:solidFill>
+                  <a:srgbClr val="D4D4D4"/>
+                </a:solidFill>
+                <a:latin typeface="Consolas"/>
+              </a:rPr>
+              <a:t>)</a:t>
+            </a:r>
+            <a:r>
+              <a:rPr sz="1600">
+                <a:solidFill>
+                  <a:srgbClr val="D4D4D4"/>
+                </a:solidFill>
+                <a:latin typeface="Consolas"/>
+              </a:rPr>
+              <a:t>/</a:t>
+            </a:r>
+            <a:r>
+              <a:rPr sz="1600">
+                <a:solidFill>
+                  <a:srgbClr val="B5CEA8"/>
+                </a:solidFill>
+                <a:latin typeface="Consolas"/>
+              </a:rPr>
+              <a:t>6076.</a:t>
+            </a:r>
+            <a:r>
+              <a:rPr sz="1600">
+                <a:solidFill>
+                  <a:srgbClr val="D4D4D4"/>
+                </a:solidFill>
+                <a:latin typeface="Consolas"/>
+              </a:rPr>
+              <a:t>;</a:t>
+            </a:r>
+          </a:p>
+          <a:p>
+            <a:pPr>
+              <a:spcAft>
+                <a:spcPts val="100"/>
+              </a:spcAft>
+            </a:pPr>
+            <a:r>
+              <a:rPr sz="1600">
+                <a:solidFill>
+                  <a:srgbClr val="D4D4D4"/>
+                </a:solidFill>
+                <a:latin typeface="Consolas"/>
+              </a:rPr>
+              <a:t>        </a:t>
+            </a:r>
+            <a:r>
+              <a:rPr sz="1600">
+                <a:solidFill>
+                  <a:srgbClr val="4EC9B0"/>
+                </a:solidFill>
+                <a:latin typeface="Consolas"/>
+              </a:rPr>
+              <a:t>count</a:t>
+            </a:r>
+            <a:r>
+              <a:rPr sz="1600">
+                <a:solidFill>
+                  <a:srgbClr val="D4D4D4"/>
+                </a:solidFill>
+                <a:latin typeface="Consolas"/>
+              </a:rPr>
+              <a:t>=</a:t>
+            </a:r>
+            <a:r>
+              <a:rPr sz="1600">
+                <a:solidFill>
+                  <a:srgbClr val="4EC9B0"/>
+                </a:solidFill>
+                <a:latin typeface="Consolas"/>
+              </a:rPr>
+              <a:t>count</a:t>
+            </a:r>
+            <a:r>
+              <a:rPr sz="1600">
+                <a:solidFill>
+                  <a:srgbClr val="D4D4D4"/>
+                </a:solidFill>
+                <a:latin typeface="Consolas"/>
+              </a:rPr>
+              <a:t>+</a:t>
+            </a:r>
+            <a:r>
+              <a:rPr sz="1600">
+                <a:solidFill>
+                  <a:srgbClr val="B5CEA8"/>
+                </a:solidFill>
+                <a:latin typeface="Consolas"/>
+              </a:rPr>
+              <a:t>1</a:t>
+            </a:r>
+            <a:r>
+              <a:rPr sz="1600">
+                <a:solidFill>
+                  <a:srgbClr val="D4D4D4"/>
+                </a:solidFill>
+                <a:latin typeface="Consolas"/>
+              </a:rPr>
+              <a:t>;</a:t>
+            </a:r>
+          </a:p>
+          <a:p>
+            <a:pPr>
+              <a:spcAft>
+                <a:spcPts val="100"/>
+              </a:spcAft>
+            </a:pPr>
+            <a:r>
+              <a:rPr sz="1600">
+                <a:solidFill>
+                  <a:srgbClr val="D4D4D4"/>
+                </a:solidFill>
+                <a:latin typeface="Consolas"/>
+              </a:rPr>
+              <a:t>        </a:t>
+            </a:r>
+            <a:r>
+              <a:rPr sz="1600">
+                <a:solidFill>
+                  <a:srgbClr val="D4D4D4"/>
+                </a:solidFill>
+                <a:latin typeface="Consolas"/>
+              </a:rPr>
+              <a:t>ArrayT</a:t>
+            </a:r>
+            <a:r>
+              <a:rPr sz="1600">
+                <a:solidFill>
+                  <a:srgbClr val="D4D4D4"/>
+                </a:solidFill>
+                <a:latin typeface="Consolas"/>
+              </a:rPr>
+              <a:t>(</a:t>
+            </a:r>
+            <a:r>
+              <a:rPr sz="1600">
+                <a:solidFill>
+                  <a:srgbClr val="4EC9B0"/>
+                </a:solidFill>
+                <a:latin typeface="Consolas"/>
+              </a:rPr>
+              <a:t>count</a:t>
+            </a:r>
+            <a:r>
+              <a:rPr sz="1600">
+                <a:solidFill>
+                  <a:srgbClr val="D4D4D4"/>
+                </a:solidFill>
+                <a:latin typeface="Consolas"/>
+              </a:rPr>
+              <a:t>)</a:t>
+            </a:r>
+            <a:r>
+              <a:rPr sz="1600">
+                <a:solidFill>
+                  <a:srgbClr val="D4D4D4"/>
+                </a:solidFill>
+                <a:latin typeface="Consolas"/>
+              </a:rPr>
+              <a:t>=</a:t>
+            </a:r>
+            <a:r>
+              <a:rPr sz="1600">
+                <a:solidFill>
+                  <a:srgbClr val="D4D4D4"/>
+                </a:solidFill>
+                <a:latin typeface="Consolas"/>
+              </a:rPr>
+              <a:t>T</a:t>
+            </a:r>
+            <a:r>
+              <a:rPr sz="1600">
+                <a:solidFill>
+                  <a:srgbClr val="D4D4D4"/>
+                </a:solidFill>
+                <a:latin typeface="Consolas"/>
+              </a:rPr>
+              <a:t>;</a:t>
+            </a:r>
+            <a:r>
+              <a:rPr sz="1600">
+                <a:solidFill>
+                  <a:srgbClr val="D4D4D4"/>
+                </a:solidFill>
+                <a:latin typeface="Consolas"/>
+              </a:rPr>
+              <a:t>  </a:t>
+            </a:r>
+            <a:r>
+              <a:rPr sz="1600">
+                <a:solidFill>
+                  <a:srgbClr val="D4D4D4"/>
+                </a:solidFill>
+                <a:latin typeface="Consolas"/>
+              </a:rPr>
+              <a:t>ArrayDISTNM</a:t>
+            </a:r>
+            <a:r>
+              <a:rPr sz="1600">
+                <a:solidFill>
+                  <a:srgbClr val="D4D4D4"/>
+                </a:solidFill>
+                <a:latin typeface="Consolas"/>
+              </a:rPr>
+              <a:t>(</a:t>
+            </a:r>
+            <a:r>
+              <a:rPr sz="1600">
+                <a:solidFill>
+                  <a:srgbClr val="4EC9B0"/>
+                </a:solidFill>
+                <a:latin typeface="Consolas"/>
+              </a:rPr>
+              <a:t>count</a:t>
+            </a:r>
+            <a:r>
+              <a:rPr sz="1600">
+                <a:solidFill>
+                  <a:srgbClr val="D4D4D4"/>
+                </a:solidFill>
+                <a:latin typeface="Consolas"/>
+              </a:rPr>
+              <a:t>)</a:t>
+            </a:r>
+            <a:r>
+              <a:rPr sz="1600">
+                <a:solidFill>
+                  <a:srgbClr val="D4D4D4"/>
+                </a:solidFill>
+                <a:latin typeface="Consolas"/>
+              </a:rPr>
+              <a:t>=</a:t>
+            </a:r>
+            <a:r>
+              <a:rPr sz="1600">
+                <a:solidFill>
+                  <a:srgbClr val="D4D4D4"/>
+                </a:solidFill>
+                <a:latin typeface="Consolas"/>
+              </a:rPr>
+              <a:t>DISTNM</a:t>
+            </a:r>
+            <a:r>
+              <a:rPr sz="1600">
+                <a:solidFill>
+                  <a:srgbClr val="D4D4D4"/>
+                </a:solidFill>
+                <a:latin typeface="Consolas"/>
+              </a:rPr>
+              <a:t>;</a:t>
+            </a:r>
+            <a:r>
+              <a:rPr sz="1600">
+                <a:solidFill>
+                  <a:srgbClr val="D4D4D4"/>
+                </a:solidFill>
+                <a:latin typeface="Consolas"/>
+              </a:rPr>
+              <a:t>  </a:t>
+            </a:r>
+            <a:r>
+              <a:rPr sz="1600">
+                <a:solidFill>
+                  <a:srgbClr val="D4D4D4"/>
+                </a:solidFill>
+                <a:latin typeface="Consolas"/>
+              </a:rPr>
+              <a:t>ArrayALTNM</a:t>
+            </a:r>
+            <a:r>
+              <a:rPr sz="1600">
+                <a:solidFill>
+                  <a:srgbClr val="D4D4D4"/>
+                </a:solidFill>
+                <a:latin typeface="Consolas"/>
+              </a:rPr>
+              <a:t>(</a:t>
+            </a:r>
+            <a:r>
+              <a:rPr sz="1600">
+                <a:solidFill>
+                  <a:srgbClr val="4EC9B0"/>
+                </a:solidFill>
+                <a:latin typeface="Consolas"/>
+              </a:rPr>
+              <a:t>count</a:t>
+            </a:r>
+            <a:r>
+              <a:rPr sz="1600">
+                <a:solidFill>
+                  <a:srgbClr val="D4D4D4"/>
+                </a:solidFill>
+                <a:latin typeface="Consolas"/>
+              </a:rPr>
+              <a:t>)</a:t>
+            </a:r>
+            <a:r>
+              <a:rPr sz="1600">
+                <a:solidFill>
+                  <a:srgbClr val="D4D4D4"/>
+                </a:solidFill>
+                <a:latin typeface="Consolas"/>
+              </a:rPr>
+              <a:t>=</a:t>
+            </a:r>
+            <a:r>
+              <a:rPr sz="1600">
+                <a:solidFill>
+                  <a:srgbClr val="D4D4D4"/>
+                </a:solidFill>
+                <a:latin typeface="Consolas"/>
+              </a:rPr>
+              <a:t>ALTNM</a:t>
+            </a:r>
+            <a:r>
+              <a:rPr sz="1600">
+                <a:solidFill>
+                  <a:srgbClr val="D4D4D4"/>
+                </a:solidFill>
+                <a:latin typeface="Consolas"/>
+              </a:rPr>
+              <a:t>;</a:t>
+            </a:r>
+          </a:p>
+          <a:p>
+            <a:pPr>
+              <a:spcAft>
+                <a:spcPts val="100"/>
+              </a:spcAft>
+            </a:pPr>
+            <a:r>
+              <a:rPr sz="1600">
+                <a:solidFill>
+                  <a:srgbClr val="D4D4D4"/>
+                </a:solidFill>
+                <a:latin typeface="Consolas"/>
+              </a:rPr>
+              <a:t>    </a:t>
+            </a:r>
+            <a:r>
+              <a:rPr sz="1600">
+                <a:solidFill>
+                  <a:srgbClr val="569CD6"/>
+                </a:solidFill>
+                <a:latin typeface="Consolas"/>
+              </a:rPr>
+              <a:t>end</a:t>
+            </a:r>
+          </a:p>
+          <a:p>
+            <a:pPr>
+              <a:spcAft>
+                <a:spcPts val="100"/>
+              </a:spcAft>
+            </a:pPr>
+            <a:r>
+              <a:rPr sz="1600">
+                <a:solidFill>
+                  <a:srgbClr val="569CD6"/>
+                </a:solidFill>
+                <a:latin typeface="Consolas"/>
+              </a:rPr>
+              <a:t>end</a:t>
+            </a:r>
+          </a:p>
+          <a:p>
+            <a:pPr>
+              <a:spcAft>
+                <a:spcPts val="100"/>
+              </a:spcAft>
+            </a:pPr>
+            <a:r>
+              <a:rPr sz="1600">
+                <a:solidFill>
+                  <a:srgbClr val="4EC9B0"/>
+                </a:solidFill>
+                <a:latin typeface="Consolas"/>
+              </a:rPr>
+              <a:t>figure</a:t>
+            </a:r>
+          </a:p>
+          <a:p>
+            <a:pPr>
+              <a:spcAft>
+                <a:spcPts val="100"/>
+              </a:spcAft>
+            </a:pPr>
+            <a:r>
+              <a:rPr sz="1600">
+                <a:solidFill>
+                  <a:srgbClr val="4EC9B0"/>
+                </a:solidFill>
+                <a:latin typeface="Consolas"/>
+              </a:rPr>
+              <a:t>plot</a:t>
+            </a:r>
+            <a:r>
+              <a:rPr sz="1600">
+                <a:solidFill>
+                  <a:srgbClr val="D4D4D4"/>
+                </a:solidFill>
+                <a:latin typeface="Consolas"/>
+              </a:rPr>
+              <a:t>(</a:t>
+            </a:r>
+            <a:r>
+              <a:rPr sz="1600">
+                <a:solidFill>
+                  <a:srgbClr val="D4D4D4"/>
+                </a:solidFill>
+                <a:latin typeface="Consolas"/>
+              </a:rPr>
+              <a:t>ArrayDISTNM</a:t>
+            </a:r>
+            <a:r>
+              <a:rPr sz="1600">
+                <a:solidFill>
+                  <a:srgbClr val="D4D4D4"/>
+                </a:solidFill>
+                <a:latin typeface="Consolas"/>
+              </a:rPr>
+              <a:t>,</a:t>
+            </a:r>
+            <a:r>
+              <a:rPr sz="1600">
+                <a:solidFill>
+                  <a:srgbClr val="D4D4D4"/>
+                </a:solidFill>
+                <a:latin typeface="Consolas"/>
+              </a:rPr>
+              <a:t>ArrayALTNM</a:t>
+            </a:r>
+            <a:r>
+              <a:rPr sz="1600">
+                <a:solidFill>
+                  <a:srgbClr val="D4D4D4"/>
+                </a:solidFill>
+                <a:latin typeface="Consolas"/>
+              </a:rPr>
+              <a:t>)</a:t>
+            </a:r>
+            <a:r>
+              <a:rPr sz="1600">
+                <a:solidFill>
+                  <a:srgbClr val="D4D4D4"/>
+                </a:solidFill>
+                <a:latin typeface="Consolas"/>
+              </a:rPr>
+              <a:t>,</a:t>
+            </a:r>
+            <a:r>
+              <a:rPr sz="1600">
+                <a:solidFill>
+                  <a:srgbClr val="4EC9B0"/>
+                </a:solidFill>
+                <a:latin typeface="Consolas"/>
+              </a:rPr>
+              <a:t>grid</a:t>
+            </a:r>
+          </a:p>
+          <a:p>
+            <a:pPr>
+              <a:spcAft>
+                <a:spcPts val="100"/>
+              </a:spcAft>
+            </a:pPr>
+            <a:r>
+              <a:rPr sz="1600">
+                <a:solidFill>
+                  <a:srgbClr val="4EC9B0"/>
+                </a:solidFill>
+                <a:latin typeface="Consolas"/>
+              </a:rPr>
+              <a:t>xlabel</a:t>
+            </a:r>
+            <a:r>
+              <a:rPr sz="1600">
+                <a:solidFill>
+                  <a:srgbClr val="D4D4D4"/>
+                </a:solidFill>
+                <a:latin typeface="Consolas"/>
+              </a:rPr>
+              <a:t>(</a:t>
+            </a:r>
+            <a:r>
+              <a:rPr sz="1600">
+                <a:solidFill>
+                  <a:srgbClr val="CE9178"/>
+                </a:solidFill>
+                <a:latin typeface="Consolas"/>
+              </a:rPr>
+              <a:t>'</a:t>
+            </a:r>
+            <a:r>
+              <a:rPr sz="1600">
+                <a:solidFill>
+                  <a:srgbClr val="CE9178"/>
+                </a:solidFill>
+                <a:latin typeface="Consolas"/>
+              </a:rPr>
+              <a:t>Downrange (Nmi)'</a:t>
+            </a:r>
+            <a:r>
+              <a:rPr sz="1600">
+                <a:solidFill>
+                  <a:srgbClr val="D4D4D4"/>
+                </a:solidFill>
+                <a:latin typeface="Consolas"/>
+              </a:rPr>
+              <a:t>)</a:t>
+            </a:r>
+            <a:r>
+              <a:rPr sz="1600">
+                <a:solidFill>
+                  <a:srgbClr val="D4D4D4"/>
+                </a:solidFill>
+                <a:latin typeface="Consolas"/>
+              </a:rPr>
+              <a:t>;</a:t>
+            </a:r>
+            <a:r>
+              <a:rPr sz="1600">
+                <a:solidFill>
+                  <a:srgbClr val="D4D4D4"/>
+                </a:solidFill>
+                <a:latin typeface="Consolas"/>
+              </a:rPr>
+              <a:t>   </a:t>
+            </a:r>
+            <a:r>
+              <a:rPr sz="1600">
+                <a:solidFill>
+                  <a:srgbClr val="4EC9B0"/>
+                </a:solidFill>
+                <a:latin typeface="Consolas"/>
+              </a:rPr>
+              <a:t>ylabel</a:t>
+            </a:r>
+            <a:r>
+              <a:rPr sz="1600">
+                <a:solidFill>
+                  <a:srgbClr val="D4D4D4"/>
+                </a:solidFill>
+                <a:latin typeface="Consolas"/>
+              </a:rPr>
+              <a:t>(</a:t>
+            </a:r>
+            <a:r>
+              <a:rPr sz="1600">
+                <a:solidFill>
+                  <a:srgbClr val="CE9178"/>
+                </a:solidFill>
+                <a:latin typeface="Consolas"/>
+              </a:rPr>
+              <a:t>'</a:t>
+            </a:r>
+            <a:r>
+              <a:rPr sz="1600">
+                <a:solidFill>
+                  <a:srgbClr val="CE9178"/>
+                </a:solidFill>
+                <a:latin typeface="Consolas"/>
+              </a:rPr>
+              <a:t>Altitude (Nmi)'</a:t>
+            </a:r>
+            <a:r>
+              <a:rPr sz="1600">
+                <a:solidFill>
+                  <a:srgbClr val="D4D4D4"/>
+                </a:solidFill>
+                <a:latin typeface="Consolas"/>
+              </a:rPr>
+              <a:t>)</a:t>
+            </a:r>
+            <a:r>
+              <a:rPr sz="1600">
+                <a:solidFill>
+                  <a:srgbClr val="D4D4D4"/>
+                </a:solidFill>
+                <a:latin typeface="Consolas"/>
+              </a:rPr>
+              <a:t>;</a:t>
+            </a:r>
+          </a:p>
+          <a:p>
+            <a:pPr>
+              <a:spcAft>
+                <a:spcPts val="100"/>
+              </a:spcAft>
+            </a:pPr>
+            <a:r>
+              <a:rPr sz="1600">
+                <a:solidFill>
+                  <a:srgbClr val="D4D4D4"/>
+                </a:solidFill>
+                <a:latin typeface="Consolas"/>
+              </a:rPr>
+              <a:t>save</a:t>
+            </a:r>
+            <a:r>
+              <a:rPr sz="1600">
+                <a:solidFill>
+                  <a:srgbClr val="D4D4D4"/>
+                </a:solidFill>
+                <a:latin typeface="Consolas"/>
+              </a:rPr>
+              <a:t> </a:t>
+            </a:r>
+            <a:r>
+              <a:rPr sz="1600">
+                <a:solidFill>
+                  <a:srgbClr val="CE9178"/>
+                </a:solidFill>
+                <a:latin typeface="Consolas"/>
+              </a:rPr>
+              <a:t>datfil</a:t>
+            </a:r>
+            <a:r>
+              <a:rPr sz="1600">
+                <a:solidFill>
+                  <a:srgbClr val="D4D4D4"/>
+                </a:solidFill>
+                <a:latin typeface="Consolas"/>
+              </a:rPr>
+              <a:t> </a:t>
+            </a:r>
+            <a:r>
+              <a:rPr sz="1600">
+                <a:solidFill>
+                  <a:srgbClr val="CE9178"/>
+                </a:solidFill>
+                <a:latin typeface="Consolas"/>
+              </a:rPr>
+              <a:t>output</a:t>
+            </a:r>
+            <a:r>
+              <a:rPr sz="1600">
+                <a:solidFill>
+                  <a:srgbClr val="D4D4D4"/>
+                </a:solidFill>
+                <a:latin typeface="Consolas"/>
+              </a:rPr>
+              <a:t> </a:t>
+            </a:r>
+            <a:r>
+              <a:rPr sz="1600">
+                <a:solidFill>
+                  <a:srgbClr val="D4D4D4"/>
+                </a:solidFill>
+                <a:latin typeface="Consolas"/>
+              </a:rPr>
+              <a:t>/</a:t>
+            </a:r>
+            <a:r>
+              <a:rPr sz="1600">
+                <a:solidFill>
+                  <a:srgbClr val="4EC9B0"/>
+                </a:solidFill>
+                <a:latin typeface="Consolas"/>
+              </a:rPr>
+              <a:t>ascii</a:t>
+            </a:r>
+          </a:p>
+          <a:p>
+            <a:pPr>
+              <a:spcAft>
+                <a:spcPts val="100"/>
+              </a:spcAft>
+            </a:pPr>
+            <a:r>
+              <a:rPr sz="1600">
+                <a:solidFill>
+                  <a:srgbClr val="4EC9B0"/>
+                </a:solidFill>
+                <a:latin typeface="Consolas"/>
+              </a:rPr>
+              <a:t>disp</a:t>
+            </a:r>
+            <a:r>
+              <a:rPr sz="1600">
+                <a:solidFill>
+                  <a:srgbClr val="D4D4D4"/>
+                </a:solidFill>
+                <a:latin typeface="Consolas"/>
+              </a:rPr>
+              <a:t> </a:t>
+            </a:r>
+            <a:r>
+              <a:rPr sz="1600">
+                <a:solidFill>
+                  <a:srgbClr val="CE9178"/>
+                </a:solidFill>
+                <a:latin typeface="Consolas"/>
+              </a:rPr>
+              <a:t>'</a:t>
+            </a:r>
+            <a:r>
+              <a:rPr sz="1600">
+                <a:solidFill>
+                  <a:srgbClr val="CE9178"/>
+                </a:solidFill>
+                <a:latin typeface="Consolas"/>
+              </a:rPr>
+              <a:t>simulation finished'</a:t>
+            </a:r>
+          </a:p>
+        </p:txBody>
+      </p:sp>
+      <p:sp>
+        <p:nvSpPr>
+          <p:cNvPr id="9" name="TextBox 8"/>
+          <p:cNvSpPr txBox="1"/>
+          <p:nvPr/>
+        </p:nvSpPr>
+        <p:spPr>
+          <a:xfrm>
+            <a:off x="777240" y="5093208"/>
+            <a:ext cx="10972800" cy="274320"/>
+          </a:xfrm>
+          <a:prstGeom prst="rect">
+            <a:avLst/>
+          </a:prstGeom>
+          <a:noFill/>
+        </p:spPr>
+        <p:txBody>
+          <a:bodyPr wrap="none">
+            <a:spAutoFit/>
+          </a:bodyPr>
+          <a:lstStyle/>
+          <a:p>
+            <a:r>
+              <a:rPr sz="1200" i="1">
+                <a:solidFill>
+                  <a:srgbClr val="8CA3B8"/>
+                </a:solidFill>
+                <a:latin typeface="Segoe UI"/>
+              </a:rPr>
+              <a:t>Zarchan, Tactical &amp; Strategic Missile Guidance, 6th ed. (MATLAB) — gravity-turn booster sim</a:t>
+            </a:r>
+          </a:p>
+        </p:txBody>
+      </p:sp>
+      <p:sp>
+        <p:nvSpPr>
+          <p:cNvPr id="10" name="TextBox 9"/>
+          <p:cNvSpPr txBox="1"/>
+          <p:nvPr/>
+        </p:nvSpPr>
+        <p:spPr>
+          <a:xfrm>
+            <a:off x="777240" y="5422392"/>
+            <a:ext cx="10972800" cy="457200"/>
+          </a:xfrm>
+          <a:prstGeom prst="rect">
+            <a:avLst/>
+          </a:prstGeom>
+          <a:noFill/>
+        </p:spPr>
+        <p:txBody>
+          <a:bodyPr wrap="none">
+            <a:spAutoFit/>
+          </a:bodyPr>
+          <a:lstStyle/>
+          <a:p>
+            <a:r>
+              <a:rPr sz="1900" i="1">
+                <a:solidFill>
+                  <a:srgbClr val="7EE08A"/>
+                </a:solidFill>
+                <a:latin typeface="Segoe UI"/>
+              </a:rPr>
+              <a:t>No boundary between simulation, analysis, and I/O — every concern in one scope.</a:t>
             </a:r>
           </a:p>
         </p:txBody>

</xml_diff>

<commit_message>
Remove the live-demo line from the closing slide
The live-demo slide was replaced by the sleepy-son photo, so the
'Live demo: github.io/sopot' pointer on the Thank-you slide no longer applies.
Closing slide now lists just Code & slides (accu-on-sea repo) and Email.
PDF regenerated.

Co-Authored-By: Claude Opus 4.8 (1M context) <noreply@anthropic.com>
</commit_message>
<xml_diff>
--- a/slides/ACCU-Separation-of-Concerns-at-Zero-Cost.pptx
+++ b/slides/ACCU-Separation-of-Concerns-at-Zero-Cost.pptx
@@ -32508,55 +32508,6 @@
                 <a:latin typeface="Segoe UI"/>
               </a:rPr>
               <a:t>/</a:t>
-            </a:r>
-            <a:r>
-              <a:rPr sz="2400" b="1" dirty="0" err="1">
-                <a:solidFill>
-                  <a:srgbClr val="35C4E8"/>
-                </a:solidFill>
-                <a:latin typeface="Segoe UI"/>
-              </a:rPr>
-              <a:t>accu-on-sea-2026-modular-physics</a:t>
-            </a:r>
-            <a:endParaRPr sz="2400" b="1" dirty="0">
-              <a:solidFill>
-                <a:srgbClr val="35C4E8"/>
-              </a:solidFill>
-              <a:latin typeface="Segoe UI"/>
-            </a:endParaRPr>
-          </a:p>
-          <a:p>
-            <a:pPr>
-              <a:spcAft>
-                <a:spcPts val="800"/>
-              </a:spcAft>
-            </a:pPr>
-            <a:r>
-              <a:rPr sz="2400" dirty="0">
-                <a:solidFill>
-                  <a:srgbClr val="35C4E8"/>
-                </a:solidFill>
-                <a:latin typeface="Segoe UI"/>
-              </a:rPr>
-              <a:t>•  </a:t>
-            </a:r>
-            <a:r>
-              <a:rPr sz="2400" b="0" dirty="0">
-                <a:solidFill>
-                  <a:srgbClr val="8CA3B8"/>
-                </a:solidFill>
-                <a:latin typeface="Segoe UI"/>
-              </a:rPr>
-              <a:t>Live demo:  </a:t>
-            </a:r>
-            <a:r>
-              <a:rPr sz="2400" b="1" dirty="0">
-                <a:solidFill>
-                  <a:srgbClr val="35C4E8"/>
-                </a:solidFill>
-                <a:latin typeface="Segoe UI"/>
-              </a:rPr>
-              <a:t>jedrzejmichalczyk.github.io/</a:t>
             </a:r>
             <a:r>
               <a:rPr sz="2400" b="1" dirty="0" err="1">

</xml_diff>